<commit_message>
Align Final Internal Review 11-slide presentation, update web slide deck and demo footer
</commit_message>
<xml_diff>
--- a/Final_Review_Mini_Project_Semiconductor_Defects.pptx
+++ b/Final_Review_Mini_Project_Semiconductor_Defects.pptx
@@ -16,12 +16,8 @@
     <p:sldId id="308" r:id="rId7"/>
     <p:sldId id="310" r:id="rId8"/>
     <p:sldId id="311" r:id="rId9"/>
-    <p:sldId id="312" r:id="rId10"/>
-    <p:sldId id="313" r:id="rId11"/>
     <p:sldId id="316" r:id="rId12"/>
-    <p:sldId id="317" r:id="rId13"/>
     <p:sldId id="318" r:id="rId14"/>
-    <p:sldId id="319" r:id="rId15"/>
     <p:sldId id="322" r:id="rId16"/>
     <p:sldId id="323" r:id="rId17"/>
   </p:sldIdLst>
@@ -14875,13 +14871,13 @@
           <a:p>
             <a:pPr algn="l"/>
             <a:r>
-              <a:rPr sz="1400" b="0">
-                <a:solidFill>
-                  <a:srgbClr val="1E293B"/>
+              <a:rPr sz="1400" b="1">
+                <a:solidFill>
+                  <a:srgbClr val="0F172A"/>
                 </a:solidFill>
                 <a:latin typeface="Times New Roman"/>
               </a:rPr>
-              <a:t>Date: October 2026</a:t>
+              <a:t>B.Tech Mini Project Final Internal Review • October 2026</a:t>
             </a:r>
           </a:p>
         </p:txBody>
@@ -14995,10 +14991,15 @@
               </a:spcAft>
               <a:buNone/>
             </a:pPr>
-            <a:fld id="{00000000-1234-1234-1234-123412341234}" type="slidenum">
-              <a:rPr lang="en-US"/>
+            <a:r>
+              <a:rPr sz="1800" b="1">
+                <a:solidFill>
+                  <a:srgbClr val="0F172A"/>
+                </a:solidFill>
+                <a:latin typeface="Times New Roman"/>
+              </a:rPr>
               <a:t>1</a:t>
-            </a:fld>
+            </a:r>
             <a:endParaRPr/>
           </a:p>
         </p:txBody>
@@ -15209,10 +15210,15 @@
               </a:spcAft>
               <a:buNone/>
             </a:pPr>
-            <a:fld id="{00000000-1234-1234-1234-123412341234}" type="slidenum">
-              <a:rPr lang="en-US"/>
-              <a:t>10</a:t>
-            </a:fld>
+            <a:r>
+              <a:rPr sz="1800" b="1">
+                <a:solidFill>
+                  <a:srgbClr val="0F172A"/>
+                </a:solidFill>
+                <a:latin typeface="Times New Roman"/>
+              </a:rPr>
+              <a:t>8</a:t>
+            </a:r>
             <a:endParaRPr/>
           </a:p>
         </p:txBody>
@@ -15846,13 +15852,34 @@
               <a:buNone/>
             </a:pPr>
             <a:r>
-              <a:rPr sz="3400" b="1">
-                <a:solidFill>
-                  <a:srgbClr val="0F172A"/>
-                </a:solidFill>
+              <a:rPr lang="en-US" sz="4000" dirty="0">
+                <a:solidFill>
+                  <a:srgbClr val="181C24"/>
+                </a:solidFill>
+                <a:highlight>
+                  <a:srgbClr val="FFFFFF"/>
+                </a:highlight>
                 <a:latin typeface="Times New Roman"/>
+                <a:ea typeface="Times New Roman"/>
+                <a:cs typeface="Times New Roman"/>
+                <a:sym typeface="Times New Roman"/>
               </a:rPr>
-              <a:t>HARDWARE &amp; SOFTWARE REQUIREMENTS</a:t>
+              <a:t> </a:t>
+            </a:r>
+            <a:r>
+              <a:rPr lang="en-US" sz="3600" b="1" dirty="0">
+                <a:solidFill>
+                  <a:srgbClr val="181C24"/>
+                </a:solidFill>
+                <a:highlight>
+                  <a:srgbClr val="FFFFFF"/>
+                </a:highlight>
+                <a:latin typeface="Times New Roman"/>
+                <a:ea typeface="Times New Roman"/>
+                <a:cs typeface="Times New Roman"/>
+                <a:sym typeface="Times New Roman"/>
+              </a:rPr>
+              <a:t>HARDWARE REQUIREMENTS</a:t>
             </a:r>
             <a:endParaRPr sz="3600" b="1" dirty="0">
               <a:latin typeface="Times New Roman"/>
@@ -15875,8 +15902,8 @@
         </p:nvSpPr>
         <p:spPr>
           <a:xfrm>
-            <a:off x="731520" y="1920240"/>
-            <a:ext cx="10698480" cy="4114800"/>
+            <a:off x="459967" y="2055887"/>
+            <a:ext cx="11128800" cy="4351800"/>
           </a:xfrm>
           <a:prstGeom prst="rect">
             <a:avLst/>
@@ -15897,232 +15924,78 @@
                 <a:spcPct val="100000"/>
               </a:lnSpc>
               <a:spcBef>
-                <a:spcPts val="800"/>
-              </a:spcBef>
-              <a:spcAft>
-                <a:spcPts val="200"/>
-              </a:spcAft>
+                <a:spcPts val="1200"/>
+              </a:spcBef>
               <a:buSzPts val="2600"/>
               <a:buFont typeface="Noto Sans Symbols"/>
               <a:buChar char="⮪"/>
             </a:pPr>
             <a:r>
-              <a:rPr sz="2200" b="1">
-                <a:solidFill>
-                  <a:srgbClr val="0284C7"/>
-                </a:solidFill>
-                <a:latin typeface="Times New Roman"/>
+              <a:rPr lang="en-US" dirty="0">
+                <a:latin typeface="Times New Roman" panose="02020603050405020304" pitchFamily="18" charset="0"/>
+                <a:cs typeface="Times New Roman" panose="02020603050405020304" pitchFamily="18" charset="0"/>
               </a:rPr>
-              <a:t>Software Requirements</a:t>
+              <a:t>Intel i5 Processor (or equivalent)</a:t>
             </a:r>
           </a:p>
           <a:p>
-            <a:pPr>
-              <a:spcBef>
-                <a:spcPts val="200"/>
-              </a:spcBef>
-              <a:spcAft>
-                <a:spcPts val="400"/>
-              </a:spcAft>
+            <a:pPr marL="342900" lvl="0" indent="-342900" algn="l">
+              <a:lnSpc>
+                <a:spcPct val="100000"/>
+              </a:lnSpc>
+              <a:spcBef>
+                <a:spcPts val="1200"/>
+              </a:spcBef>
+              <a:buSzPts val="2600"/>
+              <a:buFont typeface="Noto Sans Symbols"/>
+              <a:buChar char="⮪"/>
             </a:pPr>
             <a:r>
-              <a:rPr sz="1800" b="0">
-                <a:solidFill>
-                  <a:srgbClr val="1E293B"/>
-                </a:solidFill>
-                <a:latin typeface="Times New Roman"/>
+              <a:rPr lang="en-US" dirty="0">
+                <a:latin typeface="Times New Roman" panose="02020603050405020304" pitchFamily="18" charset="0"/>
+                <a:cs typeface="Times New Roman" panose="02020603050405020304" pitchFamily="18" charset="0"/>
               </a:rPr>
-              <a:t>•  Operating System: Windows 11 / Linux (Ubuntu 22.04 LTS)</a:t>
+              <a:t>8 GB RAM</a:t>
             </a:r>
           </a:p>
           <a:p>
-            <a:pPr>
-              <a:spcBef>
-                <a:spcPts val="200"/>
-              </a:spcBef>
-              <a:spcAft>
-                <a:spcPts val="400"/>
-              </a:spcAft>
+            <a:pPr marL="342900" lvl="0" indent="-342900" algn="l">
+              <a:lnSpc>
+                <a:spcPct val="100000"/>
+              </a:lnSpc>
+              <a:spcBef>
+                <a:spcPts val="1200"/>
+              </a:spcBef>
+              <a:buSzPts val="2600"/>
+              <a:buFont typeface="Noto Sans Symbols"/>
+              <a:buChar char="⮪"/>
             </a:pPr>
             <a:r>
-              <a:rPr sz="1800" b="0">
-                <a:solidFill>
-                  <a:srgbClr val="1E293B"/>
-                </a:solidFill>
-                <a:latin typeface="Times New Roman"/>
+              <a:rPr lang="en-US" dirty="0">
+                <a:latin typeface="Times New Roman" panose="02020603050405020304" pitchFamily="18" charset="0"/>
+                <a:cs typeface="Times New Roman" panose="02020603050405020304" pitchFamily="18" charset="0"/>
               </a:rPr>
-              <a:t>•  Programming Language: Python 3.12 / 3.10</a:t>
+              <a:t>256 GB SSD Storage</a:t>
             </a:r>
           </a:p>
           <a:p>
-            <a:pPr>
-              <a:spcBef>
-                <a:spcPts val="200"/>
-              </a:spcBef>
-              <a:spcAft>
-                <a:spcPts val="400"/>
-              </a:spcAft>
+            <a:pPr marL="342900" lvl="0" indent="-342900" algn="l">
+              <a:lnSpc>
+                <a:spcPct val="100000"/>
+              </a:lnSpc>
+              <a:spcBef>
+                <a:spcPts val="1200"/>
+              </a:spcBef>
+              <a:buSzPts val="2600"/>
+              <a:buFont typeface="Noto Sans Symbols"/>
+              <a:buChar char="⮪"/>
             </a:pPr>
             <a:r>
-              <a:rPr sz="1800" b="0">
-                <a:solidFill>
-                  <a:srgbClr val="1E293B"/>
-                </a:solidFill>
-                <a:latin typeface="Times New Roman"/>
+              <a:rPr lang="en-US" dirty="0">
+                <a:latin typeface="Times New Roman" panose="02020603050405020304" pitchFamily="18" charset="0"/>
+                <a:cs typeface="Times New Roman" panose="02020603050405020304" pitchFamily="18" charset="0"/>
               </a:rPr>
-              <a:t>•  Deep Learning Framework: PyTorch 2.x, Torchvision</a:t>
-            </a:r>
-          </a:p>
-          <a:p>
-            <a:pPr>
-              <a:spcBef>
-                <a:spcPts val="200"/>
-              </a:spcBef>
-              <a:spcAft>
-                <a:spcPts val="400"/>
-              </a:spcAft>
-            </a:pPr>
-            <a:r>
-              <a:rPr sz="1800" b="0">
-                <a:solidFill>
-                  <a:srgbClr val="1E293B"/>
-                </a:solidFill>
-                <a:latin typeface="Times New Roman"/>
-              </a:rPr>
-              <a:t>•  Edge Runtime Engine: ONNX Runtime 1.18+</a:t>
-            </a:r>
-          </a:p>
-          <a:p>
-            <a:pPr>
-              <a:spcBef>
-                <a:spcPts val="200"/>
-              </a:spcBef>
-              <a:spcAft>
-                <a:spcPts val="400"/>
-              </a:spcAft>
-            </a:pPr>
-            <a:r>
-              <a:rPr sz="1800" b="0">
-                <a:solidFill>
-                  <a:srgbClr val="1E293B"/>
-                </a:solidFill>
-                <a:latin typeface="Times New Roman"/>
-              </a:rPr>
-              <a:t>•  Computer Vision &amp; Analytics: OpenCV (cv2), NumPy, Scikit-learn, Matplotlib, Seaborn</a:t>
-            </a:r>
-          </a:p>
-          <a:p>
-            <a:pPr>
-              <a:spcBef>
-                <a:spcPts val="200"/>
-              </a:spcBef>
-              <a:spcAft>
-                <a:spcPts val="400"/>
-              </a:spcAft>
-            </a:pPr>
-            <a:r>
-              <a:rPr sz="1800" b="0">
-                <a:solidFill>
-                  <a:srgbClr val="1E293B"/>
-                </a:solidFill>
-                <a:latin typeface="Times New Roman"/>
-              </a:rPr>
-              <a:t>•  Web Application &amp; API: HTML5 Canvas, Vanilla CSS3, JavaScript ES6, Python HTTP Server</a:t>
-            </a:r>
-          </a:p>
-          <a:p>
-            <a:pPr>
-              <a:spcBef>
-                <a:spcPts val="800"/>
-              </a:spcBef>
-              <a:spcAft>
-                <a:spcPts val="200"/>
-              </a:spcAft>
-            </a:pPr>
-            <a:r>
-              <a:rPr sz="2200" b="1">
-                <a:solidFill>
-                  <a:srgbClr val="0284C7"/>
-                </a:solidFill>
-                <a:latin typeface="Times New Roman"/>
-              </a:rPr>
-              <a:t>Hardware Requirements</a:t>
-            </a:r>
-          </a:p>
-          <a:p>
-            <a:pPr>
-              <a:spcBef>
-                <a:spcPts val="200"/>
-              </a:spcBef>
-              <a:spcAft>
-                <a:spcPts val="400"/>
-              </a:spcAft>
-            </a:pPr>
-            <a:r>
-              <a:rPr sz="1800" b="0">
-                <a:solidFill>
-                  <a:srgbClr val="1E293B"/>
-                </a:solidFill>
-                <a:latin typeface="Times New Roman"/>
-              </a:rPr>
-              <a:t>•  Training Platform: Intel Core i5/i7 Processor, 16 GB RAM (optional NVIDIA RTX GPU for training)</a:t>
-            </a:r>
-          </a:p>
-          <a:p>
-            <a:pPr>
-              <a:spcBef>
-                <a:spcPts val="200"/>
-              </a:spcBef>
-              <a:spcAft>
-                <a:spcPts val="400"/>
-              </a:spcAft>
-            </a:pPr>
-            <a:r>
-              <a:rPr sz="1800" b="0">
-                <a:solidFill>
-                  <a:srgbClr val="1E293B"/>
-                </a:solidFill>
-                <a:latin typeface="Times New Roman"/>
-              </a:rPr>
-              <a:t>•  Deployment Station: Standard x86 PC or ARM Single Board Computer (Raspberry Pi 4/5, Intel NUC)</a:t>
-            </a:r>
-          </a:p>
-          <a:p>
-            <a:pPr>
-              <a:spcBef>
-                <a:spcPts val="200"/>
-              </a:spcBef>
-              <a:spcAft>
-                <a:spcPts val="400"/>
-              </a:spcAft>
-            </a:pPr>
-            <a:r>
-              <a:rPr sz="1800" b="0">
-                <a:solidFill>
-                  <a:srgbClr val="1E293B"/>
-                </a:solidFill>
-                <a:latin typeface="Times New Roman"/>
-              </a:rPr>
-              <a:t>•  Storage: 256 GB SSD (dataset repository and evaluation logs)</a:t>
-            </a:r>
-          </a:p>
-          <a:p>
-            <a:pPr>
-              <a:spcBef>
-                <a:spcPts val="200"/>
-              </a:spcBef>
-              <a:spcAft>
-                <a:spcPts val="400"/>
-              </a:spcAft>
-            </a:pPr>
-            <a:r>
-              <a:rPr sz="1800" b="0">
-                <a:solidFill>
-                  <a:srgbClr val="1E293B"/>
-                </a:solidFill>
-                <a:latin typeface="Times New Roman"/>
-              </a:rPr>
-              <a:t>•  Network: Standard Gigabit Ethernet / Wi-Fi for shop-floor scanner transmission</a:t>
+              <a:t>Stable Internet Connection</a:t>
             </a:r>
           </a:p>
         </p:txBody>
@@ -16217,10 +16090,15 @@
               </a:spcAft>
               <a:buNone/>
             </a:pPr>
-            <a:fld id="{00000000-1234-1234-1234-123412341234}" type="slidenum">
-              <a:rPr lang="en-US"/>
-              <a:t>12</a:t>
-            </a:fld>
+            <a:r>
+              <a:rPr sz="1800" b="1">
+                <a:solidFill>
+                  <a:srgbClr val="0F172A"/>
+                </a:solidFill>
+                <a:latin typeface="Times New Roman"/>
+              </a:rPr>
+              <a:t>9</a:t>
+            </a:r>
             <a:endParaRPr/>
           </a:p>
         </p:txBody>
@@ -16815,13 +16693,34 @@
               <a:buNone/>
             </a:pPr>
             <a:r>
-              <a:rPr sz="3400" b="1">
-                <a:solidFill>
-                  <a:srgbClr val="0F172A"/>
-                </a:solidFill>
+              <a:rPr lang="en-US" sz="3600" i="0" dirty="0">
+                <a:solidFill>
+                  <a:srgbClr val="181C24"/>
+                </a:solidFill>
+                <a:highlight>
+                  <a:srgbClr val="FFFFFF"/>
+                </a:highlight>
                 <a:latin typeface="Times New Roman"/>
+                <a:ea typeface="Times New Roman"/>
+                <a:cs typeface="Times New Roman"/>
+                <a:sym typeface="Times New Roman"/>
               </a:rPr>
-              <a:t>PROJECT TIMELINE &amp; TEAM CONTRIBUTIONS</a:t>
+              <a:t>    </a:t>
+            </a:r>
+            <a:r>
+              <a:rPr lang="en-US" sz="3600" b="1" i="0" dirty="0">
+                <a:solidFill>
+                  <a:srgbClr val="181C24"/>
+                </a:solidFill>
+                <a:highlight>
+                  <a:srgbClr val="FFFFFF"/>
+                </a:highlight>
+                <a:latin typeface="Times New Roman"/>
+                <a:ea typeface="Times New Roman"/>
+                <a:cs typeface="Times New Roman"/>
+                <a:sym typeface="Times New Roman"/>
+              </a:rPr>
+              <a:t>PROJECT TIMELINE</a:t>
             </a:r>
             <a:endParaRPr sz="3600" b="1" dirty="0">
               <a:latin typeface="Times New Roman"/>
@@ -16975,219 +16874,6 @@
           </a:p>
         </p:txBody>
       </p:sp>
-      <p:sp>
-        <p:nvSpPr>
-          <p:cNvPr id="170" name="TextBox 169"/>
-          <p:cNvSpPr txBox="1"/>
-          <p:nvPr/>
-        </p:nvSpPr>
-        <p:spPr>
-          <a:xfrm>
-            <a:off x="731520" y="1920240"/>
-            <a:ext cx="10698480" cy="4114800"/>
-          </a:xfrm>
-          <a:prstGeom prst="rect">
-            <a:avLst/>
-          </a:prstGeom>
-          <a:noFill/>
-        </p:spPr>
-        <p:txBody>
-          <a:bodyPr wrap="square">
-            <a:spAutoFit/>
-          </a:bodyPr>
-          <a:lstStyle/>
-          <a:p>
-            <a:pPr>
-              <a:spcBef>
-                <a:spcPts val="800"/>
-              </a:spcBef>
-              <a:spcAft>
-                <a:spcPts val="200"/>
-              </a:spcAft>
-            </a:pPr>
-            <a:r>
-              <a:rPr sz="2200" b="1">
-                <a:solidFill>
-                  <a:srgbClr val="0284C7"/>
-                </a:solidFill>
-                <a:latin typeface="Times New Roman"/>
-              </a:rPr>
-              <a:t>Project Milestone Timeline</a:t>
-            </a:r>
-          </a:p>
-          <a:p>
-            <a:pPr>
-              <a:spcBef>
-                <a:spcPts val="200"/>
-              </a:spcBef>
-              <a:spcAft>
-                <a:spcPts val="400"/>
-              </a:spcAft>
-            </a:pPr>
-            <a:r>
-              <a:rPr sz="1800" b="0">
-                <a:solidFill>
-                  <a:srgbClr val="1E293B"/>
-                </a:solidFill>
-                <a:latin typeface="Times New Roman"/>
-              </a:rPr>
-              <a:t>•  Weeks 1–3: Literature survey, problem formulation, and WM-811K benchmark acquisition.</a:t>
-            </a:r>
-          </a:p>
-          <a:p>
-            <a:pPr>
-              <a:spcBef>
-                <a:spcPts val="200"/>
-              </a:spcBef>
-              <a:spcAft>
-                <a:spcPts val="400"/>
-              </a:spcAft>
-            </a:pPr>
-            <a:r>
-              <a:rPr sz="1800" b="0">
-                <a:solidFill>
-                  <a:srgbClr val="1E293B"/>
-                </a:solidFill>
-                <a:latin typeface="Times New Roman"/>
-              </a:rPr>
-              <a:t>•  Weeks 4–6: Dataset preprocessing, spatial normalization (224x224), and augmentation pipeline.</a:t>
-            </a:r>
-          </a:p>
-          <a:p>
-            <a:pPr>
-              <a:spcBef>
-                <a:spcPts val="200"/>
-              </a:spcBef>
-              <a:spcAft>
-                <a:spcPts val="400"/>
-              </a:spcAft>
-            </a:pPr>
-            <a:r>
-              <a:rPr sz="1800" b="0">
-                <a:solidFill>
-                  <a:srgbClr val="1E293B"/>
-                </a:solidFill>
-                <a:latin typeface="Times New Roman"/>
-              </a:rPr>
-              <a:t>•  Weeks 7–9: MobileNetV3-Small model implementation, transfer learning, and hyperparameter tuning.</a:t>
-            </a:r>
-          </a:p>
-          <a:p>
-            <a:pPr>
-              <a:spcBef>
-                <a:spcPts val="200"/>
-              </a:spcBef>
-              <a:spcAft>
-                <a:spcPts val="400"/>
-              </a:spcAft>
-            </a:pPr>
-            <a:r>
-              <a:rPr sz="1800" b="0">
-                <a:solidFill>
-                  <a:srgbClr val="1E293B"/>
-                </a:solidFill>
-                <a:latin typeface="Times New Roman"/>
-              </a:rPr>
-              <a:t>•  Weeks 10–12: ONNX edge runtime conversion, latency benchmarking, and confusion matrix evaluation.</a:t>
-            </a:r>
-          </a:p>
-          <a:p>
-            <a:pPr>
-              <a:spcBef>
-                <a:spcPts val="200"/>
-              </a:spcBef>
-              <a:spcAft>
-                <a:spcPts val="400"/>
-              </a:spcAft>
-            </a:pPr>
-            <a:r>
-              <a:rPr sz="1800" b="0">
-                <a:solidFill>
-                  <a:srgbClr val="1E293B"/>
-                </a:solidFill>
-                <a:latin typeface="Times New Roman"/>
-              </a:rPr>
-              <a:t>•  Weeks 13–14: Full-stack web AOI demo development, die pass/fail matrix, and defense documentation.</a:t>
-            </a:r>
-          </a:p>
-          <a:p>
-            <a:pPr>
-              <a:spcBef>
-                <a:spcPts val="800"/>
-              </a:spcBef>
-              <a:spcAft>
-                <a:spcPts val="200"/>
-              </a:spcAft>
-            </a:pPr>
-            <a:r>
-              <a:rPr sz="2200" b="1">
-                <a:solidFill>
-                  <a:srgbClr val="0284C7"/>
-                </a:solidFill>
-                <a:latin typeface="Times New Roman"/>
-              </a:rPr>
-              <a:t>Individual Team Member Responsibilities</a:t>
-            </a:r>
-          </a:p>
-          <a:p>
-            <a:pPr>
-              <a:spcBef>
-                <a:spcPts val="200"/>
-              </a:spcBef>
-              <a:spcAft>
-                <a:spcPts val="400"/>
-              </a:spcAft>
-            </a:pPr>
-            <a:r>
-              <a:rPr sz="1800" b="0">
-                <a:solidFill>
-                  <a:srgbClr val="1E293B"/>
-                </a:solidFill>
-                <a:latin typeface="Times New Roman"/>
-              </a:rPr>
-              <a:t>•  ADITHYAN B (MGP23EVLSI001): Model architecture engineering, MobileNetV3-Small training, PyTorch-to-ONNX model optimization, and latency profiling.</a:t>
-            </a:r>
-          </a:p>
-          <a:p>
-            <a:pPr>
-              <a:spcBef>
-                <a:spcPts val="200"/>
-              </a:spcBef>
-              <a:spcAft>
-                <a:spcPts val="400"/>
-              </a:spcAft>
-            </a:pPr>
-            <a:r>
-              <a:rPr sz="1800" b="0">
-                <a:solidFill>
-                  <a:srgbClr val="1E293B"/>
-                </a:solidFill>
-                <a:latin typeface="Times New Roman"/>
-              </a:rPr>
-              <a:t>•  ANNA BOBAN (MGP23EVLSI002): Dataset curation, spatial normalization, data augmentation, evaluation metrics calculation, and confusion matrix validation.</a:t>
-            </a:r>
-          </a:p>
-          <a:p>
-            <a:pPr>
-              <a:spcBef>
-                <a:spcPts val="200"/>
-              </a:spcBef>
-              <a:spcAft>
-                <a:spcPts val="400"/>
-              </a:spcAft>
-            </a:pPr>
-            <a:r>
-              <a:rPr sz="1800" b="0">
-                <a:solidFill>
-                  <a:srgbClr val="1E293B"/>
-                </a:solidFill>
-                <a:latin typeface="Times New Roman"/>
-              </a:rPr>
-              <a:t>•  NOOPA MARIA ROJAN (MGP23EVLSI009): Real-time web deployment, interactive HTML5 wafer canvas, die pass/fail color logic, fab lot simulator, and REST API integration.</a:t>
-            </a:r>
-          </a:p>
-        </p:txBody>
-      </p:sp>
     </p:spTree>
   </p:cSld>
   <p:clrMapOvr>
@@ -17310,10 +16996,15 @@
               </a:spcAft>
               <a:buNone/>
             </a:pPr>
-            <a:fld id="{00000000-1234-1234-1234-123412341234}" type="slidenum">
-              <a:rPr lang="en-US"/>
-              <a:t>14</a:t>
-            </a:fld>
+            <a:r>
+              <a:rPr sz="1800" b="1">
+                <a:solidFill>
+                  <a:srgbClr val="0F172A"/>
+                </a:solidFill>
+                <a:latin typeface="Times New Roman"/>
+              </a:rPr>
+              <a:t>10</a:t>
+            </a:r>
             <a:endParaRPr/>
           </a:p>
         </p:txBody>
@@ -17642,10 +17333,15 @@
               </a:spcAft>
               <a:buNone/>
             </a:pPr>
-            <a:fld id="{00000000-1234-1234-1234-123412341234}" type="slidenum">
-              <a:rPr lang="en-US"/>
-              <a:t>15</a:t>
-            </a:fld>
+            <a:r>
+              <a:rPr sz="1800" b="1">
+                <a:solidFill>
+                  <a:srgbClr val="0F172A"/>
+                </a:solidFill>
+                <a:latin typeface="Times New Roman"/>
+              </a:rPr>
+              <a:t>11</a:t>
+            </a:r>
             <a:endParaRPr/>
           </a:p>
         </p:txBody>
@@ -17928,7 +17624,7 @@
                 </a:solidFill>
                 <a:latin typeface="Times New Roman"/>
               </a:rPr>
-              <a:t>B.Tech Mini Project Final Review • Saintgits College of Engineering (Autonomous)</a:t>
+              <a:t>B.Tech Mini Project Final Internal Review • Saintgits College of Engineering (Autonomous)</a:t>
             </a:r>
           </a:p>
           <a:p>
@@ -18020,10 +17716,15 @@
               </a:spcAft>
               <a:buNone/>
             </a:pPr>
-            <a:fld id="{00000000-1234-1234-1234-123412341234}" type="slidenum">
-              <a:rPr lang="en-US"/>
+            <a:r>
+              <a:rPr sz="1800" b="1">
+                <a:solidFill>
+                  <a:srgbClr val="0F172A"/>
+                </a:solidFill>
+                <a:latin typeface="Times New Roman"/>
+              </a:rPr>
               <a:t>2</a:t>
-            </a:fld>
+            </a:r>
             <a:endParaRPr/>
           </a:p>
         </p:txBody>
@@ -18473,10 +18174,15 @@
               </a:spcAft>
               <a:buNone/>
             </a:pPr>
-            <a:fld id="{00000000-1234-1234-1234-123412341234}" type="slidenum">
-              <a:rPr lang="en-US"/>
+            <a:r>
+              <a:rPr sz="1800" b="1">
+                <a:solidFill>
+                  <a:srgbClr val="0F172A"/>
+                </a:solidFill>
+                <a:latin typeface="Times New Roman"/>
+              </a:rPr>
               <a:t>3</a:t>
-            </a:fld>
+            </a:r>
             <a:endParaRPr/>
           </a:p>
         </p:txBody>
@@ -18926,10 +18632,15 @@
               </a:spcAft>
               <a:buNone/>
             </a:pPr>
-            <a:fld id="{00000000-1234-1234-1234-123412341234}" type="slidenum">
-              <a:rPr lang="en-US"/>
+            <a:r>
+              <a:rPr sz="1800" b="1">
+                <a:solidFill>
+                  <a:srgbClr val="0F172A"/>
+                </a:solidFill>
+                <a:latin typeface="Times New Roman"/>
+              </a:rPr>
               <a:t>4</a:t>
-            </a:fld>
+            </a:r>
             <a:endParaRPr/>
           </a:p>
         </p:txBody>
@@ -19417,10 +19128,15 @@
               </a:spcAft>
               <a:buNone/>
             </a:pPr>
-            <a:fld id="{00000000-1234-1234-1234-123412341234}" type="slidenum">
-              <a:rPr lang="en-US"/>
+            <a:r>
+              <a:rPr sz="1800" b="1">
+                <a:solidFill>
+                  <a:srgbClr val="0F172A"/>
+                </a:solidFill>
+                <a:latin typeface="Times New Roman"/>
+              </a:rPr>
               <a:t>5</a:t>
-            </a:fld>
+            </a:r>
             <a:endParaRPr/>
           </a:p>
         </p:txBody>
@@ -19826,7 +19542,7 @@
                 </a:solidFill>
                 <a:latin typeface="Times New Roman"/>
               </a:rPr>
-              <a:t>EXISTING SYSTEM</a:t>
+              <a:t>END-TO-END SYSTEM ARCHITECTURE</a:t>
             </a:r>
             <a:endParaRPr sz="3600" b="1" dirty="0">
               <a:latin typeface="Times New Roman" panose="02020603050405020304" pitchFamily="18" charset="0"/>
@@ -19853,8 +19569,8 @@
         </p:nvSpPr>
         <p:spPr>
           <a:xfrm>
-            <a:off x="731520" y="1920240"/>
-            <a:ext cx="10698480" cy="4114800"/>
+            <a:off x="-18288000" y="1754042"/>
+            <a:ext cx="10955338" cy="4419668"/>
           </a:xfrm>
           <a:prstGeom prst="rect">
             <a:avLst/>
@@ -19875,176 +19591,12 @@
                 <a:spcPct val="100000"/>
               </a:lnSpc>
               <a:spcBef>
-                <a:spcPts val="800"/>
-              </a:spcBef>
-              <a:spcAft>
-                <a:spcPts val="200"/>
-              </a:spcAft>
+                <a:spcPts val="1200"/>
+              </a:spcBef>
               <a:buSzPts val="2600"/>
               <a:buFont typeface="Noto Sans Symbols"/>
               <a:buChar char="⮪"/>
             </a:pPr>
-            <a:r>
-              <a:rPr sz="2200" b="1">
-                <a:solidFill>
-                  <a:srgbClr val="0284C7"/>
-                </a:solidFill>
-                <a:latin typeface="Times New Roman"/>
-              </a:rPr>
-              <a:t>Current Industrial Inspection Methods</a:t>
-            </a:r>
-          </a:p>
-          <a:p>
-            <a:pPr>
-              <a:spcBef>
-                <a:spcPts val="200"/>
-              </a:spcBef>
-              <a:spcAft>
-                <a:spcPts val="400"/>
-              </a:spcAft>
-            </a:pPr>
-            <a:r>
-              <a:rPr sz="1800" b="0">
-                <a:solidFill>
-                  <a:srgbClr val="1E293B"/>
-                </a:solidFill>
-                <a:latin typeface="Times New Roman"/>
-              </a:rPr>
-              <a:t>•  Manual microscopy visual verification conducted by quality assurance personnel.</a:t>
-            </a:r>
-          </a:p>
-          <a:p>
-            <a:pPr>
-              <a:spcBef>
-                <a:spcPts val="200"/>
-              </a:spcBef>
-              <a:spcAft>
-                <a:spcPts val="400"/>
-              </a:spcAft>
-            </a:pPr>
-            <a:r>
-              <a:rPr sz="1800" b="0">
-                <a:solidFill>
-                  <a:srgbClr val="1E293B"/>
-                </a:solidFill>
-                <a:latin typeface="Times New Roman"/>
-              </a:rPr>
-              <a:t>•  Legacy rule-based computer vision utilizing handcrafted spatial filters, Hough transforms, and template matching.</a:t>
-            </a:r>
-          </a:p>
-          <a:p>
-            <a:pPr>
-              <a:spcBef>
-                <a:spcPts val="800"/>
-              </a:spcBef>
-              <a:spcAft>
-                <a:spcPts val="200"/>
-              </a:spcAft>
-            </a:pPr>
-            <a:r>
-              <a:rPr sz="2200" b="1">
-                <a:solidFill>
-                  <a:srgbClr val="0284C7"/>
-                </a:solidFill>
-                <a:latin typeface="Times New Roman"/>
-              </a:rPr>
-              <a:t>Operational Workflow</a:t>
-            </a:r>
-          </a:p>
-          <a:p>
-            <a:pPr>
-              <a:spcBef>
-                <a:spcPts val="200"/>
-              </a:spcBef>
-              <a:spcAft>
-                <a:spcPts val="400"/>
-              </a:spcAft>
-            </a:pPr>
-            <a:r>
-              <a:rPr sz="1800" b="0">
-                <a:solidFill>
-                  <a:srgbClr val="1E293B"/>
-                </a:solidFill>
-                <a:latin typeface="Times New Roman"/>
-              </a:rPr>
-              <a:t>•  Wafer scan acquired -&gt; Batch saved to server -&gt; Heuristic filters evaluate die failure threshold -&gt; Manual verification triggered for ambiguous patterns.</a:t>
-            </a:r>
-          </a:p>
-          <a:p>
-            <a:pPr>
-              <a:spcBef>
-                <a:spcPts val="800"/>
-              </a:spcBef>
-              <a:spcAft>
-                <a:spcPts val="200"/>
-              </a:spcAft>
-            </a:pPr>
-            <a:r>
-              <a:rPr sz="2200" b="1">
-                <a:solidFill>
-                  <a:srgbClr val="0284C7"/>
-                </a:solidFill>
-                <a:latin typeface="Times New Roman"/>
-              </a:rPr>
-              <a:t>Key Technical Limitations</a:t>
-            </a:r>
-          </a:p>
-          <a:p>
-            <a:pPr>
-              <a:spcBef>
-                <a:spcPts val="200"/>
-              </a:spcBef>
-              <a:spcAft>
-                <a:spcPts val="400"/>
-              </a:spcAft>
-            </a:pPr>
-            <a:r>
-              <a:rPr sz="1800" b="0">
-                <a:solidFill>
-                  <a:srgbClr val="1E293B"/>
-                </a:solidFill>
-                <a:latin typeface="Times New Roman"/>
-              </a:rPr>
-              <a:t>•  High latency (&gt;500 ms per wafer) incompatible with continuous inline fab speed.</a:t>
-            </a:r>
-          </a:p>
-          <a:p>
-            <a:pPr>
-              <a:spcBef>
-                <a:spcPts val="200"/>
-              </a:spcBef>
-              <a:spcAft>
-                <a:spcPts val="400"/>
-              </a:spcAft>
-            </a:pPr>
-            <a:r>
-              <a:rPr sz="1800" b="0">
-                <a:solidFill>
-                  <a:srgbClr val="1E293B"/>
-                </a:solidFill>
-                <a:latin typeface="Times New Roman"/>
-              </a:rPr>
-              <a:t>•  High false-alarm rate on nominal wafers caused by random single-die sensor noise.</a:t>
-            </a:r>
-          </a:p>
-          <a:p>
-            <a:pPr>
-              <a:spcBef>
-                <a:spcPts val="200"/>
-              </a:spcBef>
-              <a:spcAft>
-                <a:spcPts val="400"/>
-              </a:spcAft>
-            </a:pPr>
-            <a:r>
-              <a:rPr sz="1800" b="0">
-                <a:solidFill>
-                  <a:srgbClr val="1E293B"/>
-                </a:solidFill>
-                <a:latin typeface="Times New Roman"/>
-              </a:rPr>
-              <a:t>•  Inability to adapt to amorphous, complex, or rotated spatial cluster patterns.</a:t>
-            </a:r>
           </a:p>
         </p:txBody>
       </p:sp>
@@ -20088,10 +19640,15 @@
               </a:spcAft>
               <a:buNone/>
             </a:pPr>
-            <a:fld id="{00000000-1234-1234-1234-123412341234}" type="slidenum">
-              <a:rPr lang="en-US"/>
+            <a:r>
+              <a:rPr sz="1800" b="1">
+                <a:solidFill>
+                  <a:srgbClr val="0F172A"/>
+                </a:solidFill>
+                <a:latin typeface="Times New Roman"/>
+              </a:rPr>
               <a:t>6</a:t>
-            </a:fld>
+            </a:r>
             <a:endParaRPr/>
           </a:p>
         </p:txBody>
@@ -20257,6 +19814,681 @@
           </a:p>
         </p:txBody>
       </p:sp>
+      <p:sp>
+        <p:nvSpPr>
+          <p:cNvPr id="236" name="Rounded Rectangle 235"/>
+          <p:cNvSpPr/>
+          <p:nvPr/>
+        </p:nvSpPr>
+        <p:spPr>
+          <a:xfrm>
+            <a:off x="548640" y="1828800"/>
+            <a:ext cx="2514600" cy="3291840"/>
+          </a:xfrm>
+          <a:prstGeom prst="roundRect">
+            <a:avLst/>
+          </a:prstGeom>
+          <a:solidFill>
+            <a:srgbClr val="F1F5F9"/>
+          </a:solidFill>
+          <a:ln w="19050">
+            <a:solidFill>
+              <a:srgbClr val="CBD5E1"/>
+            </a:solidFill>
+          </a:ln>
+        </p:spPr>
+        <p:style>
+          <a:lnRef idx="1">
+            <a:schemeClr val="accent1"/>
+          </a:lnRef>
+          <a:fillRef idx="3">
+            <a:schemeClr val="accent1"/>
+          </a:fillRef>
+          <a:effectRef idx="2">
+            <a:schemeClr val="accent1"/>
+          </a:effectRef>
+          <a:fontRef idx="minor">
+            <a:schemeClr val="lt1"/>
+          </a:fontRef>
+        </p:style>
+        <p:txBody>
+          <a:bodyPr rtlCol="0" anchor="ctr" wrap="square" lIns="137160" rIns="137160" tIns="164592"/>
+          <a:lstStyle/>
+          <a:p>
+            <a:pPr algn="ctr">
+              <a:spcAft>
+                <a:spcPts val="800"/>
+              </a:spcAft>
+            </a:pPr>
+            <a:r>
+              <a:rPr sz="1400" b="1">
+                <a:solidFill>
+                  <a:srgbClr val="0284C7"/>
+                </a:solidFill>
+                <a:latin typeface="Times New Roman"/>
+              </a:rPr>
+              <a:t>STAGE A: DATA PIPELINE</a:t>
+            </a:r>
+          </a:p>
+          <a:p>
+            <a:pPr>
+              <a:spcBef>
+                <a:spcPts val="300"/>
+              </a:spcBef>
+              <a:spcAft>
+                <a:spcPts val="300"/>
+              </a:spcAft>
+            </a:pPr>
+            <a:r>
+              <a:rPr sz="1200" b="0">
+                <a:solidFill>
+                  <a:srgbClr val="1E293B"/>
+                </a:solidFill>
+                <a:latin typeface="Times New Roman"/>
+              </a:rPr>
+              <a:t>• Raw LSWMD.pkl parsing</a:t>
+            </a:r>
+          </a:p>
+          <a:p>
+            <a:pPr>
+              <a:spcBef>
+                <a:spcPts val="300"/>
+              </a:spcBef>
+              <a:spcAft>
+                <a:spcPts val="300"/>
+              </a:spcAft>
+            </a:pPr>
+            <a:r>
+              <a:rPr sz="1200" b="0">
+                <a:solidFill>
+                  <a:srgbClr val="1E293B"/>
+                </a:solidFill>
+                <a:latin typeface="Times New Roman"/>
+              </a:rPr>
+              <a:t>• Pandas index patch</a:t>
+            </a:r>
+          </a:p>
+          <a:p>
+            <a:pPr>
+              <a:spcBef>
+                <a:spcPts val="300"/>
+              </a:spcBef>
+              <a:spcAft>
+                <a:spcPts val="300"/>
+              </a:spcAft>
+            </a:pPr>
+            <a:r>
+              <a:rPr sz="1200" b="0">
+                <a:solidFill>
+                  <a:srgbClr val="1E293B"/>
+                </a:solidFill>
+                <a:latin typeface="Times New Roman"/>
+              </a:rPr>
+              <a:t>• Bilinear resize to 224x224</a:t>
+            </a:r>
+          </a:p>
+          <a:p>
+            <a:pPr>
+              <a:spcBef>
+                <a:spcPts val="300"/>
+              </a:spcBef>
+              <a:spcAft>
+                <a:spcPts val="300"/>
+              </a:spcAft>
+            </a:pPr>
+            <a:r>
+              <a:rPr sz="1200" b="0">
+                <a:solidFill>
+                  <a:srgbClr val="1E293B"/>
+                </a:solidFill>
+                <a:latin typeface="Times New Roman"/>
+              </a:rPr>
+              <a:t>• Min-Max normalization (0-255)</a:t>
+            </a:r>
+          </a:p>
+          <a:p>
+            <a:pPr>
+              <a:spcBef>
+                <a:spcPts val="300"/>
+              </a:spcBef>
+              <a:spcAft>
+                <a:spcPts val="300"/>
+              </a:spcAft>
+            </a:pPr>
+            <a:r>
+              <a:rPr sz="1200" b="0">
+                <a:solidFill>
+                  <a:srgbClr val="1E293B"/>
+                </a:solidFill>
+                <a:latin typeface="Times New Roman"/>
+              </a:rPr>
+              <a:t>• 70% / 15% / 15% Stratified split</a:t>
+            </a:r>
+          </a:p>
+        </p:txBody>
+      </p:sp>
+      <p:sp>
+        <p:nvSpPr>
+          <p:cNvPr id="237" name="Rounded Rectangle 236"/>
+          <p:cNvSpPr/>
+          <p:nvPr/>
+        </p:nvSpPr>
+        <p:spPr>
+          <a:xfrm>
+            <a:off x="3246120" y="1828800"/>
+            <a:ext cx="2514600" cy="3291840"/>
+          </a:xfrm>
+          <a:prstGeom prst="roundRect">
+            <a:avLst/>
+          </a:prstGeom>
+          <a:solidFill>
+            <a:srgbClr val="F1F5F9"/>
+          </a:solidFill>
+          <a:ln w="19050">
+            <a:solidFill>
+              <a:srgbClr val="CBD5E1"/>
+            </a:solidFill>
+          </a:ln>
+        </p:spPr>
+        <p:style>
+          <a:lnRef idx="1">
+            <a:schemeClr val="accent1"/>
+          </a:lnRef>
+          <a:fillRef idx="3">
+            <a:schemeClr val="accent1"/>
+          </a:fillRef>
+          <a:effectRef idx="2">
+            <a:schemeClr val="accent1"/>
+          </a:effectRef>
+          <a:fontRef idx="minor">
+            <a:schemeClr val="lt1"/>
+          </a:fontRef>
+        </p:style>
+        <p:txBody>
+          <a:bodyPr rtlCol="0" anchor="ctr" wrap="square" lIns="137160" rIns="137160" tIns="164592"/>
+          <a:lstStyle/>
+          <a:p>
+            <a:pPr algn="ctr">
+              <a:spcAft>
+                <a:spcPts val="800"/>
+              </a:spcAft>
+            </a:pPr>
+            <a:r>
+              <a:rPr sz="1400" b="1">
+                <a:solidFill>
+                  <a:srgbClr val="0284C7"/>
+                </a:solidFill>
+                <a:latin typeface="Times New Roman"/>
+              </a:rPr>
+              <a:t>STAGE B: MODEL TRAINING</a:t>
+            </a:r>
+          </a:p>
+          <a:p>
+            <a:pPr>
+              <a:spcBef>
+                <a:spcPts val="300"/>
+              </a:spcBef>
+              <a:spcAft>
+                <a:spcPts val="300"/>
+              </a:spcAft>
+            </a:pPr>
+            <a:r>
+              <a:rPr sz="1200" b="0">
+                <a:solidFill>
+                  <a:srgbClr val="1E293B"/>
+                </a:solidFill>
+                <a:latin typeface="Times New Roman"/>
+              </a:rPr>
+              <a:t>• Backbone: MobileNetV3-Small</a:t>
+            </a:r>
+          </a:p>
+          <a:p>
+            <a:pPr>
+              <a:spcBef>
+                <a:spcPts val="300"/>
+              </a:spcBef>
+              <a:spcAft>
+                <a:spcPts val="300"/>
+              </a:spcAft>
+            </a:pPr>
+            <a:r>
+              <a:rPr sz="1200" b="0">
+                <a:solidFill>
+                  <a:srgbClr val="1E293B"/>
+                </a:solidFill>
+                <a:latin typeface="Times New Roman"/>
+              </a:rPr>
+              <a:t>• Inverted residual blocks + SE</a:t>
+            </a:r>
+          </a:p>
+          <a:p>
+            <a:pPr>
+              <a:spcBef>
+                <a:spcPts val="300"/>
+              </a:spcBef>
+              <a:spcAft>
+                <a:spcPts val="300"/>
+              </a:spcAft>
+            </a:pPr>
+            <a:r>
+              <a:rPr sz="1200" b="0">
+                <a:solidFill>
+                  <a:srgbClr val="1E293B"/>
+                </a:solidFill>
+                <a:latin typeface="Times New Roman"/>
+              </a:rPr>
+              <a:t>• Custom 8-class linear head</a:t>
+            </a:r>
+          </a:p>
+          <a:p>
+            <a:pPr>
+              <a:spcBef>
+                <a:spcPts val="300"/>
+              </a:spcBef>
+              <a:spcAft>
+                <a:spcPts val="300"/>
+              </a:spcAft>
+            </a:pPr>
+            <a:r>
+              <a:rPr sz="1200" b="0">
+                <a:solidFill>
+                  <a:srgbClr val="1E293B"/>
+                </a:solidFill>
+                <a:latin typeface="Times New Roman"/>
+              </a:rPr>
+              <a:t>• Adam optimizer (lr=3e-4)</a:t>
+            </a:r>
+          </a:p>
+          <a:p>
+            <a:pPr>
+              <a:spcBef>
+                <a:spcPts val="300"/>
+              </a:spcBef>
+              <a:spcAft>
+                <a:spcPts val="300"/>
+              </a:spcAft>
+            </a:pPr>
+            <a:r>
+              <a:rPr sz="1200" b="0">
+                <a:solidFill>
+                  <a:srgbClr val="1E293B"/>
+                </a:solidFill>
+                <a:latin typeface="Times New Roman"/>
+              </a:rPr>
+              <a:t>• Cross-Entropy loss over 8 epochs</a:t>
+            </a:r>
+          </a:p>
+        </p:txBody>
+      </p:sp>
+      <p:sp>
+        <p:nvSpPr>
+          <p:cNvPr id="238" name="Rounded Rectangle 237"/>
+          <p:cNvSpPr/>
+          <p:nvPr/>
+        </p:nvSpPr>
+        <p:spPr>
+          <a:xfrm>
+            <a:off x="5943600" y="1828800"/>
+            <a:ext cx="2514600" cy="3291840"/>
+          </a:xfrm>
+          <a:prstGeom prst="roundRect">
+            <a:avLst/>
+          </a:prstGeom>
+          <a:solidFill>
+            <a:srgbClr val="F1F5F9"/>
+          </a:solidFill>
+          <a:ln w="19050">
+            <a:solidFill>
+              <a:srgbClr val="CBD5E1"/>
+            </a:solidFill>
+          </a:ln>
+        </p:spPr>
+        <p:style>
+          <a:lnRef idx="1">
+            <a:schemeClr val="accent1"/>
+          </a:lnRef>
+          <a:fillRef idx="3">
+            <a:schemeClr val="accent1"/>
+          </a:fillRef>
+          <a:effectRef idx="2">
+            <a:schemeClr val="accent1"/>
+          </a:effectRef>
+          <a:fontRef idx="minor">
+            <a:schemeClr val="lt1"/>
+          </a:fontRef>
+        </p:style>
+        <p:txBody>
+          <a:bodyPr rtlCol="0" anchor="ctr" wrap="square" lIns="137160" rIns="137160" tIns="164592"/>
+          <a:lstStyle/>
+          <a:p>
+            <a:pPr algn="ctr">
+              <a:spcAft>
+                <a:spcPts val="800"/>
+              </a:spcAft>
+            </a:pPr>
+            <a:r>
+              <a:rPr sz="1400" b="1">
+                <a:solidFill>
+                  <a:srgbClr val="0284C7"/>
+                </a:solidFill>
+                <a:latin typeface="Times New Roman"/>
+              </a:rPr>
+              <a:t>STAGE C: ONNX OPTIMIZATION</a:t>
+            </a:r>
+          </a:p>
+          <a:p>
+            <a:pPr>
+              <a:spcBef>
+                <a:spcPts val="300"/>
+              </a:spcBef>
+              <a:spcAft>
+                <a:spcPts val="300"/>
+              </a:spcAft>
+            </a:pPr>
+            <a:r>
+              <a:rPr sz="1200" b="0">
+                <a:solidFill>
+                  <a:srgbClr val="1E293B"/>
+                </a:solidFill>
+                <a:latin typeface="Times New Roman"/>
+              </a:rPr>
+              <a:t>• PyTorch model graph trace</a:t>
+            </a:r>
+          </a:p>
+          <a:p>
+            <a:pPr>
+              <a:spcBef>
+                <a:spcPts val="300"/>
+              </a:spcBef>
+              <a:spcAft>
+                <a:spcPts val="300"/>
+              </a:spcAft>
+            </a:pPr>
+            <a:r>
+              <a:rPr sz="1200" b="0">
+                <a:solidFill>
+                  <a:srgbClr val="1E293B"/>
+                </a:solidFill>
+                <a:latin typeface="Times New Roman"/>
+              </a:rPr>
+              <a:t>• ONNX Opset 12 export</a:t>
+            </a:r>
+          </a:p>
+          <a:p>
+            <a:pPr>
+              <a:spcBef>
+                <a:spcPts val="300"/>
+              </a:spcBef>
+              <a:spcAft>
+                <a:spcPts val="300"/>
+              </a:spcAft>
+            </a:pPr>
+            <a:r>
+              <a:rPr sz="1200" b="0">
+                <a:solidFill>
+                  <a:srgbClr val="1E293B"/>
+                </a:solidFill>
+                <a:latin typeface="Times New Roman"/>
+              </a:rPr>
+              <a:t>• Constant folding &amp; prune</a:t>
+            </a:r>
+          </a:p>
+          <a:p>
+            <a:pPr>
+              <a:spcBef>
+                <a:spcPts val="300"/>
+              </a:spcBef>
+              <a:spcAft>
+                <a:spcPts val="300"/>
+              </a:spcAft>
+            </a:pPr>
+            <a:r>
+              <a:rPr sz="1200" b="0">
+                <a:solidFill>
+                  <a:srgbClr val="1E293B"/>
+                </a:solidFill>
+                <a:latin typeface="Times New Roman"/>
+              </a:rPr>
+              <a:t>• Dynamic batch dimension</a:t>
+            </a:r>
+          </a:p>
+          <a:p>
+            <a:pPr>
+              <a:spcBef>
+                <a:spcPts val="300"/>
+              </a:spcBef>
+              <a:spcAft>
+                <a:spcPts val="300"/>
+              </a:spcAft>
+            </a:pPr>
+            <a:r>
+              <a:rPr sz="1200" b="0">
+                <a:solidFill>
+                  <a:srgbClr val="1E293B"/>
+                </a:solidFill>
+                <a:latin typeface="Times New Roman"/>
+              </a:rPr>
+              <a:t>• Model size: 5.84 MB</a:t>
+            </a:r>
+          </a:p>
+        </p:txBody>
+      </p:sp>
+      <p:sp>
+        <p:nvSpPr>
+          <p:cNvPr id="239" name="Rounded Rectangle 238"/>
+          <p:cNvSpPr/>
+          <p:nvPr/>
+        </p:nvSpPr>
+        <p:spPr>
+          <a:xfrm>
+            <a:off x="8641080" y="1828800"/>
+            <a:ext cx="2514600" cy="3291840"/>
+          </a:xfrm>
+          <a:prstGeom prst="roundRect">
+            <a:avLst/>
+          </a:prstGeom>
+          <a:solidFill>
+            <a:srgbClr val="F1F5F9"/>
+          </a:solidFill>
+          <a:ln w="19050">
+            <a:solidFill>
+              <a:srgbClr val="CBD5E1"/>
+            </a:solidFill>
+          </a:ln>
+        </p:spPr>
+        <p:style>
+          <a:lnRef idx="1">
+            <a:schemeClr val="accent1"/>
+          </a:lnRef>
+          <a:fillRef idx="3">
+            <a:schemeClr val="accent1"/>
+          </a:fillRef>
+          <a:effectRef idx="2">
+            <a:schemeClr val="accent1"/>
+          </a:effectRef>
+          <a:fontRef idx="minor">
+            <a:schemeClr val="lt1"/>
+          </a:fontRef>
+        </p:style>
+        <p:txBody>
+          <a:bodyPr rtlCol="0" anchor="ctr" wrap="square" lIns="137160" rIns="137160" tIns="164592"/>
+          <a:lstStyle/>
+          <a:p>
+            <a:pPr algn="ctr">
+              <a:spcAft>
+                <a:spcPts val="800"/>
+              </a:spcAft>
+            </a:pPr>
+            <a:r>
+              <a:rPr sz="1400" b="1">
+                <a:solidFill>
+                  <a:srgbClr val="0284C7"/>
+                </a:solidFill>
+                <a:latin typeface="Times New Roman"/>
+              </a:rPr>
+              <a:t>STAGE D: EDGE INFERENCE</a:t>
+            </a:r>
+          </a:p>
+          <a:p>
+            <a:pPr>
+              <a:spcBef>
+                <a:spcPts val="300"/>
+              </a:spcBef>
+              <a:spcAft>
+                <a:spcPts val="300"/>
+              </a:spcAft>
+            </a:pPr>
+            <a:r>
+              <a:rPr sz="1200" b="0">
+                <a:solidFill>
+                  <a:srgbClr val="1E293B"/>
+                </a:solidFill>
+                <a:latin typeface="Times New Roman"/>
+              </a:rPr>
+              <a:t>• ONNX Runtime CPU engine</a:t>
+            </a:r>
+          </a:p>
+          <a:p>
+            <a:pPr>
+              <a:spcBef>
+                <a:spcPts val="300"/>
+              </a:spcBef>
+              <a:spcAft>
+                <a:spcPts val="300"/>
+              </a:spcAft>
+            </a:pPr>
+            <a:r>
+              <a:rPr sz="1200" b="0">
+                <a:solidFill>
+                  <a:srgbClr val="1E293B"/>
+                </a:solidFill>
+                <a:latin typeface="Times New Roman"/>
+              </a:rPr>
+              <a:t>• ImageNet tensor normalization</a:t>
+            </a:r>
+          </a:p>
+          <a:p>
+            <a:pPr>
+              <a:spcBef>
+                <a:spcPts val="300"/>
+              </a:spcBef>
+              <a:spcAft>
+                <a:spcPts val="300"/>
+              </a:spcAft>
+            </a:pPr>
+            <a:r>
+              <a:rPr sz="1200" b="0">
+                <a:solidFill>
+                  <a:srgbClr val="1E293B"/>
+                </a:solidFill>
+                <a:latin typeface="Times New Roman"/>
+              </a:rPr>
+              <a:t>• Top-3 confidence scoring</a:t>
+            </a:r>
+          </a:p>
+          <a:p>
+            <a:pPr>
+              <a:spcBef>
+                <a:spcPts val="300"/>
+              </a:spcBef>
+              <a:spcAft>
+                <a:spcPts val="300"/>
+              </a:spcAft>
+            </a:pPr>
+            <a:r>
+              <a:rPr sz="1200" b="0">
+                <a:solidFill>
+                  <a:srgbClr val="1E293B"/>
+                </a:solidFill>
+                <a:latin typeface="Times New Roman"/>
+              </a:rPr>
+              <a:t>• Sub-2ms inference latency</a:t>
+            </a:r>
+          </a:p>
+          <a:p>
+            <a:pPr>
+              <a:spcBef>
+                <a:spcPts val="300"/>
+              </a:spcBef>
+              <a:spcAft>
+                <a:spcPts val="300"/>
+              </a:spcAft>
+            </a:pPr>
+            <a:r>
+              <a:rPr sz="1200" b="0">
+                <a:solidFill>
+                  <a:srgbClr val="1E293B"/>
+                </a:solidFill>
+                <a:latin typeface="Times New Roman"/>
+              </a:rPr>
+              <a:t>• Web demo &amp; CLI runner</a:t>
+            </a:r>
+          </a:p>
+        </p:txBody>
+      </p:sp>
+      <p:sp>
+        <p:nvSpPr>
+          <p:cNvPr id="240" name="Rounded Rectangle 239"/>
+          <p:cNvSpPr/>
+          <p:nvPr/>
+        </p:nvSpPr>
+        <p:spPr>
+          <a:xfrm>
+            <a:off x="548640" y="5257800"/>
+            <a:ext cx="10607040" cy="594360"/>
+          </a:xfrm>
+          <a:prstGeom prst="roundRect">
+            <a:avLst/>
+          </a:prstGeom>
+          <a:solidFill>
+            <a:srgbClr val="0F172A"/>
+          </a:solidFill>
+          <a:ln w="12700">
+            <a:solidFill>
+              <a:srgbClr val="0284C7"/>
+            </a:solidFill>
+          </a:ln>
+        </p:spPr>
+        <p:style>
+          <a:lnRef idx="1">
+            <a:schemeClr val="accent1"/>
+          </a:lnRef>
+          <a:fillRef idx="3">
+            <a:schemeClr val="accent1"/>
+          </a:fillRef>
+          <a:effectRef idx="2">
+            <a:schemeClr val="accent1"/>
+          </a:effectRef>
+          <a:fontRef idx="minor">
+            <a:schemeClr val="lt1"/>
+          </a:fontRef>
+        </p:style>
+        <p:txBody>
+          <a:bodyPr rtlCol="0" anchor="ctr" wrap="square"/>
+          <a:lstStyle/>
+          <a:p>
+            <a:pPr algn="ctr"/>
+            <a:r>
+              <a:rPr sz="1200" b="1">
+                <a:solidFill>
+                  <a:srgbClr val="38BDF8"/>
+                </a:solidFill>
+                <a:latin typeface="Times New Roman"/>
+              </a:rPr>
+              <a:t>Target Defect Classes:  </a:t>
+            </a:r>
+            <a:r>
+              <a:rPr sz="1200" b="0">
+                <a:solidFill>
+                  <a:srgbClr val="F1F5F9"/>
+                </a:solidFill>
+                <a:latin typeface="Times New Roman"/>
+              </a:rPr>
+              <a:t>Center  |  Donut  |  Edge-Loc  |  Edge-Ring  |  Loc  |  Scratch  |  Other  |  Clean (Nominal)</a:t>
+            </a:r>
+          </a:p>
+        </p:txBody>
+      </p:sp>
     </p:spTree>
     <p:extLst>
       <p:ext uri="{BB962C8B-B14F-4D97-AF65-F5344CB8AC3E}">
@@ -20338,7 +20570,7 @@
                 </a:solidFill>
                 <a:latin typeface="Times New Roman"/>
               </a:rPr>
-              <a:t>PROPOSED SYSTEM</a:t>
+              <a:t>WM-811K DATASET &amp; DEFECT PATTERNS</a:t>
             </a:r>
             <a:endParaRPr sz="3600" b="1" dirty="0">
               <a:latin typeface="Times New Roman" panose="02020603050405020304" pitchFamily="18" charset="0"/>
@@ -20365,8 +20597,8 @@
         </p:nvSpPr>
         <p:spPr>
           <a:xfrm>
-            <a:off x="731520" y="1920240"/>
-            <a:ext cx="10698480" cy="4114800"/>
+            <a:off x="-18288000" y="1627991"/>
+            <a:ext cx="10955338" cy="4419668"/>
           </a:xfrm>
           <a:prstGeom prst="rect">
             <a:avLst/>
@@ -20387,195 +20619,12 @@
                 <a:spcPct val="100000"/>
               </a:lnSpc>
               <a:spcBef>
-                <a:spcPts val="800"/>
-              </a:spcBef>
-              <a:spcAft>
-                <a:spcPts val="200"/>
-              </a:spcAft>
+                <a:spcPts val="1200"/>
+              </a:spcBef>
               <a:buSzPts val="2600"/>
               <a:buFont typeface="Noto Sans Symbols"/>
               <a:buChar char="⮪"/>
             </a:pPr>
-            <a:r>
-              <a:rPr sz="2200" b="1">
-                <a:solidFill>
-                  <a:srgbClr val="0284C7"/>
-                </a:solidFill>
-                <a:latin typeface="Times New Roman"/>
-              </a:rPr>
-              <a:t>Our Deep Learning Solution</a:t>
-            </a:r>
-          </a:p>
-          <a:p>
-            <a:pPr>
-              <a:spcBef>
-                <a:spcPts val="200"/>
-              </a:spcBef>
-              <a:spcAft>
-                <a:spcPts val="400"/>
-              </a:spcAft>
-            </a:pPr>
-            <a:r>
-              <a:rPr sz="1800" b="0">
-                <a:solidFill>
-                  <a:srgbClr val="1E293B"/>
-                </a:solidFill>
-                <a:latin typeface="Times New Roman"/>
-              </a:rPr>
-              <a:t>•  An automated, lightweight deep convolutional network (MobileNetV3-Small) optimized through ONNX Runtime for real-time edge execution on commodity CPUs and ARM architectures.</a:t>
-            </a:r>
-          </a:p>
-          <a:p>
-            <a:pPr>
-              <a:spcBef>
-                <a:spcPts val="800"/>
-              </a:spcBef>
-              <a:spcAft>
-                <a:spcPts val="200"/>
-              </a:spcAft>
-            </a:pPr>
-            <a:r>
-              <a:rPr sz="2200" b="1">
-                <a:solidFill>
-                  <a:srgbClr val="0284C7"/>
-                </a:solidFill>
-                <a:latin typeface="Times New Roman"/>
-              </a:rPr>
-              <a:t>Why It Is Superior</a:t>
-            </a:r>
-          </a:p>
-          <a:p>
-            <a:pPr>
-              <a:spcBef>
-                <a:spcPts val="200"/>
-              </a:spcBef>
-              <a:spcAft>
-                <a:spcPts val="400"/>
-              </a:spcAft>
-            </a:pPr>
-            <a:r>
-              <a:rPr sz="1800" b="0">
-                <a:solidFill>
-                  <a:srgbClr val="1E293B"/>
-                </a:solidFill>
-                <a:latin typeface="Times New Roman"/>
-              </a:rPr>
-              <a:t>•  Ultra-Low Latency: Real-time 1.53 ms inference per wafer map (over 300x faster than manual review).</a:t>
-            </a:r>
-          </a:p>
-          <a:p>
-            <a:pPr>
-              <a:spcBef>
-                <a:spcPts val="200"/>
-              </a:spcBef>
-              <a:spcAft>
-                <a:spcPts val="400"/>
-              </a:spcAft>
-            </a:pPr>
-            <a:r>
-              <a:rPr sz="1800" b="0">
-                <a:solidFill>
-                  <a:srgbClr val="1E293B"/>
-                </a:solidFill>
-                <a:latin typeface="Times New Roman"/>
-              </a:rPr>
-              <a:t>•  High Accuracy: 98.02% overall test accuracy across 121,719 test wafer samples.</a:t>
-            </a:r>
-          </a:p>
-          <a:p>
-            <a:pPr>
-              <a:spcBef>
-                <a:spcPts val="200"/>
-              </a:spcBef>
-              <a:spcAft>
-                <a:spcPts val="400"/>
-              </a:spcAft>
-            </a:pPr>
-            <a:r>
-              <a:rPr sz="1800" b="0">
-                <a:solidFill>
-                  <a:srgbClr val="1E293B"/>
-                </a:solidFill>
-                <a:latin typeface="Times New Roman"/>
-              </a:rPr>
-              <a:t>•  Minimal Footprint: 5.84 MB compact ONNX model binary requiring zero GPU hardware.</a:t>
-            </a:r>
-          </a:p>
-          <a:p>
-            <a:pPr>
-              <a:spcBef>
-                <a:spcPts val="800"/>
-              </a:spcBef>
-              <a:spcAft>
-                <a:spcPts val="200"/>
-              </a:spcAft>
-            </a:pPr>
-            <a:r>
-              <a:rPr sz="2200" b="1">
-                <a:solidFill>
-                  <a:srgbClr val="0284C7"/>
-                </a:solidFill>
-                <a:latin typeface="Times New Roman"/>
-              </a:rPr>
-              <a:t>Core Functional Features</a:t>
-            </a:r>
-          </a:p>
-          <a:p>
-            <a:pPr>
-              <a:spcBef>
-                <a:spcPts val="200"/>
-              </a:spcBef>
-              <a:spcAft>
-                <a:spcPts val="400"/>
-              </a:spcAft>
-            </a:pPr>
-            <a:r>
-              <a:rPr sz="1800" b="0">
-                <a:solidFill>
-                  <a:srgbClr val="1E293B"/>
-                </a:solidFill>
-                <a:latin typeface="Times New Roman"/>
-              </a:rPr>
-              <a:t>•  Instant 8-class topological classification with full softmax probability distribution.</a:t>
-            </a:r>
-          </a:p>
-          <a:p>
-            <a:pPr>
-              <a:spcBef>
-                <a:spcPts val="200"/>
-              </a:spcBef>
-              <a:spcAft>
-                <a:spcPts val="400"/>
-              </a:spcAft>
-            </a:pPr>
-            <a:r>
-              <a:rPr sz="1800" b="0">
-                <a:solidFill>
-                  <a:srgbClr val="1E293B"/>
-                </a:solidFill>
-                <a:latin typeface="Times New Roman"/>
-              </a:rPr>
-              <a:t>•  Interactive silicon wafer canvas with die-level pass/fail color mapping (Green = Pass, Red = Fail).</a:t>
-            </a:r>
-          </a:p>
-          <a:p>
-            <a:pPr>
-              <a:spcBef>
-                <a:spcPts val="200"/>
-              </a:spcBef>
-              <a:spcAft>
-                <a:spcPts val="400"/>
-              </a:spcAft>
-            </a:pPr>
-            <a:r>
-              <a:rPr sz="1800" b="0">
-                <a:solidFill>
-                  <a:srgbClr val="1E293B"/>
-                </a:solidFill>
-                <a:latin typeface="Times New Roman"/>
-              </a:rPr>
-              <a:t>•  Automated fab lot screening simulator with live yield tracking and defect counter.</a:t>
-            </a:r>
           </a:p>
         </p:txBody>
       </p:sp>
@@ -20619,10 +20668,15 @@
               </a:spcAft>
               <a:buNone/>
             </a:pPr>
-            <a:fld id="{00000000-1234-1234-1234-123412341234}" type="slidenum">
-              <a:rPr lang="en-US"/>
+            <a:r>
+              <a:rPr sz="1800" b="1">
+                <a:solidFill>
+                  <a:srgbClr val="0F172A"/>
+                </a:solidFill>
+                <a:latin typeface="Times New Roman"/>
+              </a:rPr>
               <a:t>7</a:t>
-            </a:fld>
+            </a:r>
             <a:endParaRPr/>
           </a:p>
         </p:txBody>
@@ -20788,6 +20842,467 @@
           </a:p>
         </p:txBody>
       </p:sp>
+      <p:sp>
+        <p:nvSpPr>
+          <p:cNvPr id="236" name="Rounded Rectangle 235"/>
+          <p:cNvSpPr/>
+          <p:nvPr/>
+        </p:nvSpPr>
+        <p:spPr>
+          <a:xfrm>
+            <a:off x="548640" y="1828800"/>
+            <a:ext cx="5303520" cy="3931920"/>
+          </a:xfrm>
+          <a:prstGeom prst="roundRect">
+            <a:avLst/>
+          </a:prstGeom>
+          <a:solidFill>
+            <a:srgbClr val="F1F5F9"/>
+          </a:solidFill>
+          <a:ln w="19050">
+            <a:solidFill>
+              <a:srgbClr val="CBD5E1"/>
+            </a:solidFill>
+          </a:ln>
+        </p:spPr>
+        <p:style>
+          <a:lnRef idx="1">
+            <a:schemeClr val="accent1"/>
+          </a:lnRef>
+          <a:fillRef idx="3">
+            <a:schemeClr val="accent1"/>
+          </a:fillRef>
+          <a:effectRef idx="2">
+            <a:schemeClr val="accent1"/>
+          </a:effectRef>
+          <a:fontRef idx="minor">
+            <a:schemeClr val="lt1"/>
+          </a:fontRef>
+        </p:style>
+        <p:txBody>
+          <a:bodyPr rtlCol="0" anchor="ctr" wrap="square" lIns="182880" tIns="182880"/>
+          <a:lstStyle/>
+          <a:p>
+            <a:pPr algn="ctr"/>
+            <a:r>
+              <a:rPr sz="1800" b="1">
+                <a:solidFill>
+                  <a:srgbClr val="0284C7"/>
+                </a:solidFill>
+                <a:latin typeface="Times New Roman"/>
+              </a:rPr>
+              <a:t>Dataset Profile &amp; Industrial Challenges</a:t>
+            </a:r>
+          </a:p>
+          <a:p>
+            <a:pPr>
+              <a:spcBef>
+                <a:spcPts val="200"/>
+              </a:spcBef>
+              <a:spcAft>
+                <a:spcPts val="200"/>
+              </a:spcAft>
+            </a:pPr>
+            <a:r>
+              <a:rPr sz="1250" b="0">
+                <a:solidFill>
+                  <a:srgbClr val="1E293B"/>
+                </a:solidFill>
+                <a:latin typeface="Times New Roman"/>
+              </a:rPr>
+              <a:t>• Total Records: 811,472 real semiconductor wafer maps collected from 46,393 fabrication lots.</a:t>
+            </a:r>
+          </a:p>
+          <a:p>
+            <a:pPr>
+              <a:spcBef>
+                <a:spcPts val="200"/>
+              </a:spcBef>
+              <a:spcAft>
+                <a:spcPts val="200"/>
+              </a:spcAft>
+            </a:pPr>
+            <a:r>
+              <a:rPr sz="1250" b="0">
+                <a:solidFill>
+                  <a:srgbClr val="1E293B"/>
+                </a:solidFill>
+                <a:latin typeface="Times New Roman"/>
+              </a:rPr>
+              <a:t>• Labeled Samples: ~172,950 annotated wafers with failure pattern labels.</a:t>
+            </a:r>
+          </a:p>
+          <a:p>
+            <a:pPr>
+              <a:spcBef>
+                <a:spcPts val="200"/>
+              </a:spcBef>
+              <a:spcAft>
+                <a:spcPts val="200"/>
+              </a:spcAft>
+            </a:pPr>
+            <a:r>
+              <a:rPr sz="1250" b="0">
+                <a:solidFill>
+                  <a:srgbClr val="1E293B"/>
+                </a:solidFill>
+                <a:latin typeface="Times New Roman"/>
+              </a:rPr>
+              <a:t>• Extreme Real-World Imbalance: Over 96% of manufactured wafers are defect-free (Clean).</a:t>
+            </a:r>
+          </a:p>
+          <a:p>
+            <a:pPr>
+              <a:spcBef>
+                <a:spcPts val="200"/>
+              </a:spcBef>
+              <a:spcAft>
+                <a:spcPts val="200"/>
+              </a:spcAft>
+            </a:pPr>
+            <a:r>
+              <a:rPr sz="1250" b="0">
+                <a:solidFill>
+                  <a:srgbClr val="1E293B"/>
+                </a:solidFill>
+                <a:latin typeface="Times New Roman"/>
+              </a:rPr>
+              <a:t>• 2D Array Representation: 0 = background/exterior, 1 = normal pass die, 2 = defect die.</a:t>
+            </a:r>
+          </a:p>
+          <a:p>
+            <a:pPr>
+              <a:spcBef>
+                <a:spcPts val="200"/>
+              </a:spcBef>
+              <a:spcAft>
+                <a:spcPts val="200"/>
+              </a:spcAft>
+            </a:pPr>
+            <a:r>
+              <a:rPr sz="1250" b="1">
+                <a:solidFill>
+                  <a:srgbClr val="1E293B"/>
+                </a:solidFill>
+                <a:latin typeface="Times New Roman"/>
+              </a:rPr>
+              <a:t>• Automated Preprocessing Pipeline:</a:t>
+            </a:r>
+          </a:p>
+          <a:p>
+            <a:pPr>
+              <a:spcBef>
+                <a:spcPts val="200"/>
+              </a:spcBef>
+              <a:spcAft>
+                <a:spcPts val="200"/>
+              </a:spcAft>
+            </a:pPr>
+            <a:r>
+              <a:rPr sz="1250" b="0">
+                <a:solidFill>
+                  <a:srgbClr val="1E293B"/>
+                </a:solidFill>
+                <a:latin typeface="Times New Roman"/>
+              </a:rPr>
+              <a:t>    1. Runtime patch for deprecated pandas Int64Index unpickling.</a:t>
+            </a:r>
+          </a:p>
+          <a:p>
+            <a:pPr>
+              <a:spcBef>
+                <a:spcPts val="200"/>
+              </a:spcBef>
+              <a:spcAft>
+                <a:spcPts val="200"/>
+              </a:spcAft>
+            </a:pPr>
+            <a:r>
+              <a:rPr sz="1250" b="0">
+                <a:solidFill>
+                  <a:srgbClr val="1E293B"/>
+                </a:solidFill>
+                <a:latin typeface="Times New Roman"/>
+              </a:rPr>
+              <a:t>    2. Standardize dimensions to 224x224 via bilinear interpolation.</a:t>
+            </a:r>
+          </a:p>
+          <a:p>
+            <a:pPr>
+              <a:spcBef>
+                <a:spcPts val="200"/>
+              </a:spcBef>
+              <a:spcAft>
+                <a:spcPts val="200"/>
+              </a:spcAft>
+            </a:pPr>
+            <a:r>
+              <a:rPr sz="1250" b="0">
+                <a:solidFill>
+                  <a:srgbClr val="1E293B"/>
+                </a:solidFill>
+                <a:latin typeface="Times New Roman"/>
+              </a:rPr>
+              <a:t>    3. Scale die values to 0-255 grayscale PNG images.</a:t>
+            </a:r>
+          </a:p>
+          <a:p>
+            <a:pPr>
+              <a:spcBef>
+                <a:spcPts val="200"/>
+              </a:spcBef>
+              <a:spcAft>
+                <a:spcPts val="200"/>
+              </a:spcAft>
+            </a:pPr>
+            <a:r>
+              <a:rPr sz="1250" b="0">
+                <a:solidFill>
+                  <a:srgbClr val="1E293B"/>
+                </a:solidFill>
+                <a:latin typeface="Times New Roman"/>
+              </a:rPr>
+              <a:t>    4. Stratified Train (70%), Validation (15%), Test (15%) partitions.</a:t>
+            </a:r>
+          </a:p>
+        </p:txBody>
+      </p:sp>
+      <p:pic>
+        <p:nvPicPr>
+          <p:cNvPr id="237" name="Picture 236" descr="image.png"/>
+          <p:cNvPicPr>
+            <a:picLocks noChangeAspect="1"/>
+          </p:cNvPicPr>
+          <p:nvPr/>
+        </p:nvPicPr>
+        <p:blipFill>
+          <a:blip r:embed="rId4"/>
+          <a:stretch>
+            <a:fillRect/>
+          </a:stretch>
+        </p:blipFill>
+        <p:spPr>
+          <a:xfrm>
+            <a:off x="6217920" y="1828800"/>
+            <a:ext cx="2103120" cy="1554480"/>
+          </a:xfrm>
+          <a:prstGeom prst="rect">
+            <a:avLst/>
+          </a:prstGeom>
+        </p:spPr>
+      </p:pic>
+      <p:sp>
+        <p:nvSpPr>
+          <p:cNvPr id="238" name="TextBox 237"/>
+          <p:cNvSpPr txBox="1"/>
+          <p:nvPr/>
+        </p:nvSpPr>
+        <p:spPr>
+          <a:xfrm>
+            <a:off x="6217920" y="3337560"/>
+            <a:ext cx="2103120" cy="320040"/>
+          </a:xfrm>
+          <a:prstGeom prst="rect">
+            <a:avLst/>
+          </a:prstGeom>
+          <a:noFill/>
+        </p:spPr>
+        <p:txBody>
+          <a:bodyPr wrap="none">
+            <a:spAutoFit/>
+          </a:bodyPr>
+          <a:lstStyle/>
+          <a:p>
+            <a:pPr algn="ctr"/>
+            <a:r>
+              <a:rPr sz="1300" b="1">
+                <a:solidFill>
+                  <a:srgbClr val="0F172A"/>
+                </a:solidFill>
+                <a:latin typeface="Times New Roman"/>
+              </a:rPr>
+              <a:t>Center Defect</a:t>
+            </a:r>
+          </a:p>
+        </p:txBody>
+      </p:sp>
+      <p:pic>
+        <p:nvPicPr>
+          <p:cNvPr id="239" name="Picture 238" descr="image.png"/>
+          <p:cNvPicPr>
+            <a:picLocks noChangeAspect="1"/>
+          </p:cNvPicPr>
+          <p:nvPr/>
+        </p:nvPicPr>
+        <p:blipFill>
+          <a:blip r:embed="rId5"/>
+          <a:stretch>
+            <a:fillRect/>
+          </a:stretch>
+        </p:blipFill>
+        <p:spPr>
+          <a:xfrm>
+            <a:off x="8503920" y="1828800"/>
+            <a:ext cx="2103120" cy="1554480"/>
+          </a:xfrm>
+          <a:prstGeom prst="rect">
+            <a:avLst/>
+          </a:prstGeom>
+        </p:spPr>
+      </p:pic>
+      <p:sp>
+        <p:nvSpPr>
+          <p:cNvPr id="240" name="TextBox 239"/>
+          <p:cNvSpPr txBox="1"/>
+          <p:nvPr/>
+        </p:nvSpPr>
+        <p:spPr>
+          <a:xfrm>
+            <a:off x="8503920" y="3337560"/>
+            <a:ext cx="2103120" cy="320040"/>
+          </a:xfrm>
+          <a:prstGeom prst="rect">
+            <a:avLst/>
+          </a:prstGeom>
+          <a:noFill/>
+        </p:spPr>
+        <p:txBody>
+          <a:bodyPr wrap="none">
+            <a:spAutoFit/>
+          </a:bodyPr>
+          <a:lstStyle/>
+          <a:p>
+            <a:pPr algn="ctr"/>
+            <a:r>
+              <a:rPr sz="1300" b="1">
+                <a:solidFill>
+                  <a:srgbClr val="0F172A"/>
+                </a:solidFill>
+                <a:latin typeface="Times New Roman"/>
+              </a:rPr>
+              <a:t>Donut Defect</a:t>
+            </a:r>
+          </a:p>
+        </p:txBody>
+      </p:sp>
+      <p:pic>
+        <p:nvPicPr>
+          <p:cNvPr id="241" name="Picture 240" descr="image.png"/>
+          <p:cNvPicPr>
+            <a:picLocks noChangeAspect="1"/>
+          </p:cNvPicPr>
+          <p:nvPr/>
+        </p:nvPicPr>
+        <p:blipFill>
+          <a:blip r:embed="rId6"/>
+          <a:stretch>
+            <a:fillRect/>
+          </a:stretch>
+        </p:blipFill>
+        <p:spPr>
+          <a:xfrm>
+            <a:off x="6217920" y="3840480"/>
+            <a:ext cx="2103120" cy="1554480"/>
+          </a:xfrm>
+          <a:prstGeom prst="rect">
+            <a:avLst/>
+          </a:prstGeom>
+        </p:spPr>
+      </p:pic>
+      <p:sp>
+        <p:nvSpPr>
+          <p:cNvPr id="242" name="TextBox 241"/>
+          <p:cNvSpPr txBox="1"/>
+          <p:nvPr/>
+        </p:nvSpPr>
+        <p:spPr>
+          <a:xfrm>
+            <a:off x="6217920" y="5349240"/>
+            <a:ext cx="2103120" cy="320040"/>
+          </a:xfrm>
+          <a:prstGeom prst="rect">
+            <a:avLst/>
+          </a:prstGeom>
+          <a:noFill/>
+        </p:spPr>
+        <p:txBody>
+          <a:bodyPr wrap="none">
+            <a:spAutoFit/>
+          </a:bodyPr>
+          <a:lstStyle/>
+          <a:p>
+            <a:pPr algn="ctr"/>
+            <a:r>
+              <a:rPr sz="1300" b="1">
+                <a:solidFill>
+                  <a:srgbClr val="0F172A"/>
+                </a:solidFill>
+                <a:latin typeface="Times New Roman"/>
+              </a:rPr>
+              <a:t>Edge-Loc Defect</a:t>
+            </a:r>
+          </a:p>
+        </p:txBody>
+      </p:sp>
+      <p:pic>
+        <p:nvPicPr>
+          <p:cNvPr id="243" name="Picture 242" descr="image.png"/>
+          <p:cNvPicPr>
+            <a:picLocks noChangeAspect="1"/>
+          </p:cNvPicPr>
+          <p:nvPr/>
+        </p:nvPicPr>
+        <p:blipFill>
+          <a:blip r:embed="rId7"/>
+          <a:stretch>
+            <a:fillRect/>
+          </a:stretch>
+        </p:blipFill>
+        <p:spPr>
+          <a:xfrm>
+            <a:off x="8503920" y="3840480"/>
+            <a:ext cx="2103120" cy="1554480"/>
+          </a:xfrm>
+          <a:prstGeom prst="rect">
+            <a:avLst/>
+          </a:prstGeom>
+        </p:spPr>
+      </p:pic>
+      <p:sp>
+        <p:nvSpPr>
+          <p:cNvPr id="244" name="TextBox 243"/>
+          <p:cNvSpPr txBox="1"/>
+          <p:nvPr/>
+        </p:nvSpPr>
+        <p:spPr>
+          <a:xfrm>
+            <a:off x="8503920" y="5349240"/>
+            <a:ext cx="2103120" cy="320040"/>
+          </a:xfrm>
+          <a:prstGeom prst="rect">
+            <a:avLst/>
+          </a:prstGeom>
+          <a:noFill/>
+        </p:spPr>
+        <p:txBody>
+          <a:bodyPr wrap="none">
+            <a:spAutoFit/>
+          </a:bodyPr>
+          <a:lstStyle/>
+          <a:p>
+            <a:pPr algn="ctr"/>
+            <a:r>
+              <a:rPr sz="1300" b="1">
+                <a:solidFill>
+                  <a:srgbClr val="0F172A"/>
+                </a:solidFill>
+                <a:latin typeface="Times New Roman"/>
+              </a:rPr>
+              <a:t>Scratch Defect</a:t>
+            </a:r>
+          </a:p>
+        </p:txBody>
+      </p:sp>
     </p:spTree>
     <p:extLst>
       <p:ext uri="{BB962C8B-B14F-4D97-AF65-F5344CB8AC3E}">
@@ -21027,11 +21542,32 @@
               <a:buNone/>
             </a:pPr>
             <a:r>
-              <a:rPr sz="3400" b="1">
-                <a:solidFill>
-                  <a:srgbClr val="0F172A"/>
-                </a:solidFill>
+              <a:rPr lang="en-US" sz="4000" dirty="0">
+                <a:solidFill>
+                  <a:srgbClr val="181C24"/>
+                </a:solidFill>
+                <a:highlight>
+                  <a:srgbClr val="FFFFFF"/>
+                </a:highlight>
                 <a:latin typeface="Times New Roman"/>
+                <a:ea typeface="Times New Roman"/>
+                <a:cs typeface="Times New Roman"/>
+                <a:sym typeface="Times New Roman"/>
+              </a:rPr>
+              <a:t> </a:t>
+            </a:r>
+            <a:r>
+              <a:rPr lang="en-US" sz="3600" b="1" dirty="0">
+                <a:solidFill>
+                  <a:srgbClr val="181C24"/>
+                </a:solidFill>
+                <a:highlight>
+                  <a:srgbClr val="FFFFFF"/>
+                </a:highlight>
+                <a:latin typeface="Times New Roman"/>
+                <a:ea typeface="Times New Roman"/>
+                <a:cs typeface="Times New Roman"/>
+                <a:sym typeface="Times New Roman"/>
               </a:rPr>
               <a:t>NOVELTY OF THE PROJECT</a:t>
             </a:r>
@@ -21071,181 +21607,6 @@
           </a:ln>
         </p:spPr>
       </p:pic>
-      <p:sp>
-        <p:nvSpPr>
-          <p:cNvPr id="126" name="TextBox 125"/>
-          <p:cNvSpPr txBox="1"/>
-          <p:nvPr/>
-        </p:nvSpPr>
-        <p:spPr>
-          <a:xfrm>
-            <a:off x="731520" y="1920240"/>
-            <a:ext cx="10698480" cy="4114800"/>
-          </a:xfrm>
-          <a:prstGeom prst="rect">
-            <a:avLst/>
-          </a:prstGeom>
-          <a:noFill/>
-        </p:spPr>
-        <p:txBody>
-          <a:bodyPr wrap="square">
-            <a:spAutoFit/>
-          </a:bodyPr>
-          <a:lstStyle/>
-          <a:p>
-            <a:pPr>
-              <a:spcBef>
-                <a:spcPts val="800"/>
-              </a:spcBef>
-              <a:spcAft>
-                <a:spcPts val="200"/>
-              </a:spcAft>
-            </a:pPr>
-            <a:r>
-              <a:rPr sz="2200" b="1">
-                <a:solidFill>
-                  <a:srgbClr val="0284C7"/>
-                </a:solidFill>
-                <a:latin typeface="Times New Roman"/>
-              </a:rPr>
-              <a:t>Edge-First Deep Architecture Selection</a:t>
-            </a:r>
-          </a:p>
-          <a:p>
-            <a:pPr>
-              <a:spcBef>
-                <a:spcPts val="200"/>
-              </a:spcBef>
-              <a:spcAft>
-                <a:spcPts val="400"/>
-              </a:spcAft>
-            </a:pPr>
-            <a:r>
-              <a:rPr sz="1800" b="0">
-                <a:solidFill>
-                  <a:srgbClr val="1E293B"/>
-                </a:solidFill>
-                <a:latin typeface="Times New Roman"/>
-              </a:rPr>
-              <a:t>•  Replaces bulky architectures (ResNet-50 / VGG) with MobileNetV3-Small, reducing floating-point operations (FLOPs) by &gt;90% while maintaining state-of-the-art accuracy.</a:t>
-            </a:r>
-          </a:p>
-          <a:p>
-            <a:pPr>
-              <a:spcBef>
-                <a:spcPts val="800"/>
-              </a:spcBef>
-              <a:spcAft>
-                <a:spcPts val="200"/>
-              </a:spcAft>
-            </a:pPr>
-            <a:r>
-              <a:rPr sz="2200" b="1">
-                <a:solidFill>
-                  <a:srgbClr val="0284C7"/>
-                </a:solidFill>
-                <a:latin typeface="Times New Roman"/>
-              </a:rPr>
-              <a:t>Squeeze-and-Excitation (SE) Channel Attention</a:t>
-            </a:r>
-          </a:p>
-          <a:p>
-            <a:pPr>
-              <a:spcBef>
-                <a:spcPts val="200"/>
-              </a:spcBef>
-              <a:spcAft>
-                <a:spcPts val="400"/>
-              </a:spcAft>
-            </a:pPr>
-            <a:r>
-              <a:rPr sz="1800" b="0">
-                <a:solidFill>
-                  <a:srgbClr val="1E293B"/>
-                </a:solidFill>
-                <a:latin typeface="Times New Roman"/>
-              </a:rPr>
-              <a:t>•  Dynamically recalibrates feature map channels, allowing the network to isolate narrow defect patterns (such as thin scratches) amidst tens of thousands of operational dies.</a:t>
-            </a:r>
-          </a:p>
-          <a:p>
-            <a:pPr>
-              <a:spcBef>
-                <a:spcPts val="800"/>
-              </a:spcBef>
-              <a:spcAft>
-                <a:spcPts val="200"/>
-              </a:spcAft>
-            </a:pPr>
-            <a:r>
-              <a:rPr sz="2200" b="1">
-                <a:solidFill>
-                  <a:srgbClr val="0284C7"/>
-                </a:solidFill>
-                <a:latin typeface="Times New Roman"/>
-              </a:rPr>
-              <a:t>Hardware-Agnostic ONNX Edge Engine</a:t>
-            </a:r>
-          </a:p>
-          <a:p>
-            <a:pPr>
-              <a:spcBef>
-                <a:spcPts val="200"/>
-              </a:spcBef>
-              <a:spcAft>
-                <a:spcPts val="400"/>
-              </a:spcAft>
-            </a:pPr>
-            <a:r>
-              <a:rPr sz="1800" b="0">
-                <a:solidFill>
-                  <a:srgbClr val="1E293B"/>
-                </a:solidFill>
-                <a:latin typeface="Times New Roman"/>
-              </a:rPr>
-              <a:t>•  Compiled into an open neural network exchange (ONNX) format, allowing seamless execution on industrial x86 PCs, Raspberry Pi 4/5, and smart camera vision systems without Python/PyTorch dependencies.</a:t>
-            </a:r>
-          </a:p>
-          <a:p>
-            <a:pPr>
-              <a:spcBef>
-                <a:spcPts val="800"/>
-              </a:spcBef>
-              <a:spcAft>
-                <a:spcPts val="200"/>
-              </a:spcAft>
-            </a:pPr>
-            <a:r>
-              <a:rPr sz="2200" b="1">
-                <a:solidFill>
-                  <a:srgbClr val="0284C7"/>
-                </a:solidFill>
-                <a:latin typeface="Times New Roman"/>
-              </a:rPr>
-              <a:t>Full-Stack Fab Simulation &amp; Die Matrix Telemetry</a:t>
-            </a:r>
-          </a:p>
-          <a:p>
-            <a:pPr>
-              <a:spcBef>
-                <a:spcPts val="200"/>
-              </a:spcBef>
-              <a:spcAft>
-                <a:spcPts val="400"/>
-              </a:spcAft>
-            </a:pPr>
-            <a:r>
-              <a:rPr sz="1800" b="0">
-                <a:solidFill>
-                  <a:srgbClr val="1E293B"/>
-                </a:solidFill>
-                <a:latin typeface="Times New Roman"/>
-              </a:rPr>
-              <a:t>•  Bridges pure model classification with production fab metrics: computes exact good/bad die yield on a 648-die matrix in real time.</a:t>
-            </a:r>
-          </a:p>
-        </p:txBody>
-      </p:sp>
     </p:spTree>
   </p:cSld>
   <p:clrMapOvr>
@@ -21480,13 +21841,34 @@
               <a:buNone/>
             </a:pPr>
             <a:r>
-              <a:rPr sz="3400" b="1">
-                <a:solidFill>
-                  <a:srgbClr val="0F172A"/>
-                </a:solidFill>
+              <a:rPr lang="en-US" sz="4000" dirty="0">
+                <a:solidFill>
+                  <a:srgbClr val="181C24"/>
+                </a:solidFill>
+                <a:highlight>
+                  <a:srgbClr val="FFFFFF"/>
+                </a:highlight>
                 <a:latin typeface="Times New Roman"/>
+                <a:ea typeface="Times New Roman"/>
+                <a:cs typeface="Times New Roman"/>
+                <a:sym typeface="Times New Roman"/>
               </a:rPr>
-              <a:t>SCOPE OF THE PROJECT</a:t>
+              <a:t> </a:t>
+            </a:r>
+            <a:r>
+              <a:rPr lang="en-US" sz="3600" b="1" dirty="0">
+                <a:solidFill>
+                  <a:srgbClr val="181C24"/>
+                </a:solidFill>
+                <a:highlight>
+                  <a:srgbClr val="FFFFFF"/>
+                </a:highlight>
+                <a:latin typeface="Times New Roman"/>
+                <a:ea typeface="Times New Roman"/>
+                <a:cs typeface="Times New Roman"/>
+                <a:sym typeface="Times New Roman"/>
+              </a:rPr>
+              <a:t>SCOPE</a:t>
             </a:r>
             <a:endParaRPr sz="3600" b="1" dirty="0">
               <a:latin typeface="Times New Roman"/>
@@ -21509,8 +21891,8 @@
         </p:nvSpPr>
         <p:spPr>
           <a:xfrm>
-            <a:off x="731520" y="1920240"/>
-            <a:ext cx="10698480" cy="4114800"/>
+            <a:off x="459967" y="2055887"/>
+            <a:ext cx="11128800" cy="4351800"/>
           </a:xfrm>
           <a:prstGeom prst="rect">
             <a:avLst/>
@@ -21531,175 +21913,72 @@
                 <a:spcPct val="100000"/>
               </a:lnSpc>
               <a:spcBef>
-                <a:spcPts val="800"/>
-              </a:spcBef>
-              <a:spcAft>
-                <a:spcPts val="200"/>
-              </a:spcAft>
+                <a:spcPts val="1200"/>
+              </a:spcBef>
               <a:buSzPts val="2600"/>
               <a:buFont typeface="Noto Sans Symbols"/>
               <a:buChar char="⮪"/>
             </a:pPr>
             <a:r>
-              <a:rPr sz="2200" b="1">
-                <a:solidFill>
-                  <a:srgbClr val="0284C7"/>
-                </a:solidFill>
-                <a:latin typeface="Times New Roman"/>
+              <a:rPr lang="en-US" sz="2800" b="1" dirty="0">
+                <a:latin typeface="Times New Roman" panose="02020603050405020304" pitchFamily="18" charset="0"/>
+                <a:cs typeface="Times New Roman" panose="02020603050405020304" pitchFamily="18" charset="0"/>
               </a:rPr>
-              <a:t>Current Implementation Scope</a:t>
+              <a:t>Current Scope</a:t>
             </a:r>
           </a:p>
           <a:p>
-            <a:pPr>
-              <a:spcBef>
-                <a:spcPts val="200"/>
-              </a:spcBef>
-              <a:spcAft>
-                <a:spcPts val="400"/>
-              </a:spcAft>
+            <a:pPr marL="1054100" lvl="1" indent="-457200" algn="l">
+              <a:spcBef>
+                <a:spcPts val="1200"/>
+              </a:spcBef>
+              <a:buSzPts val="2200"/>
+              <a:buFont typeface="Arial" panose="020B0604020202020204" pitchFamily="34" charset="0"/>
+              <a:buChar char="•"/>
             </a:pPr>
             <a:r>
-              <a:rPr sz="1800" b="0">
-                <a:solidFill>
-                  <a:srgbClr val="1E293B"/>
-                </a:solidFill>
-                <a:latin typeface="Times New Roman"/>
+              <a:rPr lang="en-US" sz="2400" dirty="0">
+                <a:latin typeface="Times New Roman" panose="02020603050405020304" pitchFamily="18" charset="0"/>
+                <a:cs typeface="Times New Roman" panose="02020603050405020304" pitchFamily="18" charset="0"/>
               </a:rPr>
-              <a:t>•  Automated high-precision classification across 8 key defect classes: Center, Clean, Donut, Edge-Loc, Edge-Ring, Loc, Other, Scratch.</a:t>
+              <a:t>Supports secure online examinations with authenticated access, encrypted storage and blockchain-based audit trails for a single institution.</a:t>
             </a:r>
           </a:p>
           <a:p>
-            <a:pPr>
-              <a:spcBef>
-                <a:spcPts val="200"/>
-              </a:spcBef>
-              <a:spcAft>
-                <a:spcPts val="400"/>
-              </a:spcAft>
+            <a:pPr marL="342900" lvl="0" indent="-342900" algn="l">
+              <a:lnSpc>
+                <a:spcPct val="100000"/>
+              </a:lnSpc>
+              <a:spcBef>
+                <a:spcPts val="1200"/>
+              </a:spcBef>
+              <a:buSzPts val="2600"/>
+              <a:buFont typeface="Noto Sans Symbols"/>
+              <a:buChar char="⮪"/>
             </a:pPr>
             <a:r>
-              <a:rPr sz="1800" b="0">
-                <a:solidFill>
-                  <a:srgbClr val="1E293B"/>
-                </a:solidFill>
-                <a:latin typeface="Times New Roman"/>
-              </a:rPr>
-              <a:t>•  Complete validation on 121,719 test wafer maps from the WM-811K benchmark.</a:t>
-            </a:r>
-          </a:p>
-          <a:p>
-            <a:pPr>
-              <a:spcBef>
-                <a:spcPts val="200"/>
-              </a:spcBef>
-              <a:spcAft>
-                <a:spcPts val="400"/>
-              </a:spcAft>
-            </a:pPr>
-            <a:r>
-              <a:rPr sz="1800" b="0">
-                <a:solidFill>
-                  <a:srgbClr val="1E293B"/>
-                </a:solidFill>
-                <a:latin typeface="Times New Roman"/>
-              </a:rPr>
-              <a:t>•  Interactive web-based inspection console with live canvas, lot simulation, and REST inference API.</a:t>
-            </a:r>
-          </a:p>
-          <a:p>
-            <a:pPr>
-              <a:spcBef>
-                <a:spcPts val="200"/>
-              </a:spcBef>
-              <a:spcAft>
-                <a:spcPts val="400"/>
-              </a:spcAft>
-            </a:pPr>
-            <a:r>
-              <a:rPr sz="1800" b="0">
-                <a:solidFill>
-                  <a:srgbClr val="1E293B"/>
-                </a:solidFill>
-                <a:latin typeface="Times New Roman"/>
-              </a:rPr>
-              <a:t>•  Zero-cloud offline deployment capable of running on standard shop-floor laptops or edge processors.</a:t>
-            </a:r>
-          </a:p>
-          <a:p>
-            <a:pPr>
-              <a:spcBef>
-                <a:spcPts val="800"/>
-              </a:spcBef>
-              <a:spcAft>
-                <a:spcPts val="200"/>
-              </a:spcAft>
-            </a:pPr>
-            <a:r>
-              <a:rPr sz="2200" b="1">
-                <a:solidFill>
-                  <a:srgbClr val="0284C7"/>
-                </a:solidFill>
-                <a:latin typeface="Times New Roman"/>
+              <a:rPr lang="en-US" sz="2800" b="1" dirty="0">
+                <a:latin typeface="Times New Roman" panose="02020603050405020304" pitchFamily="18" charset="0"/>
+                <a:cs typeface="Times New Roman" panose="02020603050405020304" pitchFamily="18" charset="0"/>
               </a:rPr>
               <a:t>Future Enhancements</a:t>
             </a:r>
           </a:p>
           <a:p>
-            <a:pPr>
-              <a:spcBef>
-                <a:spcPts val="200"/>
-              </a:spcBef>
-              <a:spcAft>
-                <a:spcPts val="400"/>
-              </a:spcAft>
+            <a:pPr marL="1054100" lvl="1" indent="-457200" algn="l">
+              <a:spcBef>
+                <a:spcPts val="1200"/>
+              </a:spcBef>
+              <a:buSzPts val="2200"/>
+              <a:buFont typeface="Arial" panose="020B0604020202020204" pitchFamily="34" charset="0"/>
+              <a:buChar char="•"/>
             </a:pPr>
             <a:r>
-              <a:rPr sz="1800" b="0">
-                <a:solidFill>
-                  <a:srgbClr val="1E293B"/>
-                </a:solidFill>
-                <a:latin typeface="Times New Roman"/>
+              <a:rPr lang="en-US" sz="2400" dirty="0">
+                <a:latin typeface="Times New Roman" panose="02020603050405020304" pitchFamily="18" charset="0"/>
+                <a:cs typeface="Times New Roman" panose="02020603050405020304" pitchFamily="18" charset="0"/>
               </a:rPr>
-              <a:t>•  Die-level semantic segmentation (U-Net / YOLOv8-seg) for pixel-precise defect contouring.</a:t>
-            </a:r>
-          </a:p>
-          <a:p>
-            <a:pPr>
-              <a:spcBef>
-                <a:spcPts val="200"/>
-              </a:spcBef>
-              <a:spcAft>
-                <a:spcPts val="400"/>
-              </a:spcAft>
-            </a:pPr>
-            <a:r>
-              <a:rPr sz="1800" b="0">
-                <a:solidFill>
-                  <a:srgbClr val="1E293B"/>
-                </a:solidFill>
-                <a:latin typeface="Times New Roman"/>
-              </a:rPr>
-              <a:t>•  Multi-modal fab telemetry fusion combining wafer maps with electrical parametric test (E-test) logs.</a:t>
-            </a:r>
-          </a:p>
-          <a:p>
-            <a:pPr>
-              <a:spcBef>
-                <a:spcPts val="200"/>
-              </a:spcBef>
-              <a:spcAft>
-                <a:spcPts val="400"/>
-              </a:spcAft>
-            </a:pPr>
-            <a:r>
-              <a:rPr sz="1800" b="0">
-                <a:solidFill>
-                  <a:srgbClr val="1E293B"/>
-                </a:solidFill>
-                <a:latin typeface="Times New Roman"/>
-              </a:rPr>
-              <a:t>•  Federated active learning for collaborative multi-fab model continuous improvement.</a:t>
+              <a:t>AI-based proctoring, multi-institution federation, mobile app support and advanced analytics dashboards.</a:t>
             </a:r>
           </a:p>
         </p:txBody>

</xml_diff>

<commit_message>
Update last slide of final PPT and web slide deck to only have Thank You
</commit_message>
<xml_diff>
--- a/Final_Review_Mini_Project_Semiconductor_Defects.pptx
+++ b/Final_Review_Mini_Project_Semiconductor_Defects.pptx
@@ -15160,7 +15160,7 @@
   <p:cSld>
     <p:spTree>
       <p:nvGrpSpPr>
-        <p:cNvPr id="1" name="Shape 119"/>
+        <p:cNvPr id="1" name="Shape 381"/>
         <p:cNvGrpSpPr/>
         <p:nvPr/>
       </p:nvGrpSpPr>
@@ -15174,7 +15174,66 @@
       </p:grpSpPr>
       <p:sp>
         <p:nvSpPr>
-          <p:cNvPr id="120" name="Google Shape;120;p3"/>
+          <p:cNvPr id="382" name="Google Shape;382;p26"/>
+          <p:cNvSpPr txBox="1">
+            <a:spLocks noGrp="1"/>
+          </p:cNvSpPr>
+          <p:nvPr>
+            <p:ph type="title"/>
+          </p:nvPr>
+        </p:nvSpPr>
+        <p:spPr>
+          <a:xfrm>
+            <a:off x="680884" y="743804"/>
+            <a:ext cx="10515600" cy="1325700"/>
+          </a:xfrm>
+          <a:prstGeom prst="rect">
+            <a:avLst/>
+          </a:prstGeom>
+          <a:noFill/>
+          <a:ln>
+            <a:noFill/>
+          </a:ln>
+        </p:spPr>
+        <p:txBody>
+          <a:bodyPr spcFirstLastPara="1" wrap="square" lIns="91425" tIns="45700" rIns="91425" bIns="45700" anchor="ctr" anchorCtr="0">
+            <a:normAutofit/>
+          </a:bodyPr>
+          <a:lstStyle/>
+          <a:p>
+            <a:pPr marL="0" lvl="0" indent="0" algn="l" rtl="0">
+              <a:lnSpc>
+                <a:spcPct val="90000"/>
+              </a:lnSpc>
+              <a:spcBef>
+                <a:spcPts val="0"/>
+              </a:spcBef>
+              <a:spcAft>
+                <a:spcPts val="0"/>
+              </a:spcAft>
+              <a:buClr>
+                <a:schemeClr val="dk1"/>
+              </a:buClr>
+              <a:buSzPts val="3600"/>
+              <a:buFont typeface="Times New Roman"/>
+              <a:buNone/>
+            </a:pPr>
+            <a:r>
+              <a:rPr sz="3400" b="1">
+                <a:solidFill>
+                  <a:srgbClr val="0F172A"/>
+                </a:solidFill>
+                <a:latin typeface="Times New Roman"/>
+              </a:rPr>
+              <a:t>REFERENCES</a:t>
+            </a:r>
+            <a:endParaRPr b="1" dirty="0"/>
+          </a:p>
+        </p:txBody>
+      </p:sp>
+      <p:sp>
+        <p:nvSpPr>
+          <p:cNvPr id="384" name="Google Shape;384;p26"/>
           <p:cNvSpPr txBox="1">
             <a:spLocks noGrp="1"/>
           </p:cNvSpPr>
@@ -15217,7 +15276,7 @@
                 </a:solidFill>
                 <a:latin typeface="Times New Roman"/>
               </a:rPr>
-              <a:t>8</a:t>
+              <a:t>10</a:t>
             </a:r>
             <a:endParaRPr/>
           </a:p>
@@ -15225,12 +15284,39 @@
       </p:sp>
       <p:pic>
         <p:nvPicPr>
-          <p:cNvPr id="121" name="Google Shape;121;p3"/>
+          <p:cNvPr id="385" name="Google Shape;385;p26"/>
           <p:cNvPicPr preferRelativeResize="0"/>
           <p:nvPr/>
         </p:nvPicPr>
         <p:blipFill rotWithShape="1">
           <a:blip r:embed="rId2">
+            <a:alphaModFix/>
+          </a:blip>
+          <a:srcRect/>
+          <a:stretch/>
+        </p:blipFill>
+        <p:spPr>
+          <a:xfrm>
+            <a:off x="159971" y="211556"/>
+            <a:ext cx="4517529" cy="810838"/>
+          </a:xfrm>
+          <a:prstGeom prst="rect">
+            <a:avLst/>
+          </a:prstGeom>
+          <a:noFill/>
+          <a:ln>
+            <a:noFill/>
+          </a:ln>
+        </p:spPr>
+      </p:pic>
+      <p:pic>
+        <p:nvPicPr>
+          <p:cNvPr id="386" name="Google Shape;386;p26"/>
+          <p:cNvPicPr preferRelativeResize="0"/>
+          <p:nvPr/>
+        </p:nvPicPr>
+        <p:blipFill rotWithShape="1">
+          <a:blip r:embed="rId3">
             <a:alphaModFix/>
           </a:blip>
           <a:srcRect/>
@@ -15252,7 +15338,7 @@
       </p:pic>
       <p:sp>
         <p:nvSpPr>
-          <p:cNvPr id="122" name="Google Shape;122;p3"/>
+          <p:cNvPr id="387" name="Google Shape;387;p26"/>
           <p:cNvSpPr/>
           <p:nvPr/>
         </p:nvSpPr>
@@ -15341,77 +15427,9 @@
       </p:sp>
       <p:sp>
         <p:nvSpPr>
-          <p:cNvPr id="123" name="Google Shape;123;p3"/>
-          <p:cNvSpPr txBox="1">
-            <a:spLocks noGrp="1"/>
-          </p:cNvSpPr>
-          <p:nvPr>
-            <p:ph type="ctrTitle"/>
-          </p:nvPr>
-        </p:nvSpPr>
-        <p:spPr>
-          <a:xfrm>
-            <a:off x="459967" y="1100168"/>
-            <a:ext cx="9625800" cy="761400"/>
-          </a:xfrm>
-          <a:prstGeom prst="rect">
-            <a:avLst/>
-          </a:prstGeom>
-          <a:noFill/>
-          <a:ln>
-            <a:noFill/>
-          </a:ln>
-        </p:spPr>
-        <p:txBody>
-          <a:bodyPr spcFirstLastPara="1" wrap="square" lIns="91425" tIns="45700" rIns="91425" bIns="45700" anchor="b" anchorCtr="0">
-            <a:normAutofit/>
-          </a:bodyPr>
-          <a:lstStyle/>
-          <a:p>
-            <a:pPr marL="0" lvl="0" indent="0" algn="l" rtl="0">
-              <a:lnSpc>
-                <a:spcPct val="90000"/>
-              </a:lnSpc>
-              <a:spcBef>
-                <a:spcPts val="0"/>
-              </a:spcBef>
-              <a:spcAft>
-                <a:spcPts val="0"/>
-              </a:spcAft>
-              <a:buClr>
-                <a:srgbClr val="181C24"/>
-              </a:buClr>
-              <a:buSzPts val="4000"/>
-              <a:buFont typeface="Times New Roman"/>
-              <a:buNone/>
-            </a:pPr>
-            <a:r>
-              <a:rPr sz="3400" b="1">
-                <a:solidFill>
-                  <a:srgbClr val="0F172A"/>
-                </a:solidFill>
-                <a:latin typeface="Times New Roman"/>
-              </a:rPr>
-              <a:t>METHODOLOGY &amp; WORKFLOW</a:t>
-            </a:r>
-            <a:endParaRPr sz="3600" b="1" dirty="0">
-              <a:latin typeface="Times New Roman"/>
-              <a:ea typeface="Times New Roman"/>
-              <a:cs typeface="Times New Roman"/>
-              <a:sym typeface="Times New Roman"/>
-            </a:endParaRPr>
-          </a:p>
-        </p:txBody>
-      </p:sp>
-      <p:sp>
-        <p:nvSpPr>
-          <p:cNvPr id="124" name="Google Shape;124;p3"/>
-          <p:cNvSpPr txBox="1">
-            <a:spLocks noGrp="1"/>
-          </p:cNvSpPr>
-          <p:nvPr>
-            <p:ph type="subTitle" idx="1"/>
-          </p:nvPr>
+          <p:cNvPr id="388" name="TextBox 387"/>
+          <p:cNvSpPr txBox="1"/>
+          <p:nvPr/>
         </p:nvSpPr>
         <p:spPr>
           <a:xfrm>
@@ -15422,40 +15440,12 @@
             <a:avLst/>
           </a:prstGeom>
           <a:noFill/>
-          <a:ln>
-            <a:noFill/>
-          </a:ln>
         </p:spPr>
         <p:txBody>
-          <a:bodyPr spcFirstLastPara="1" wrap="square" lIns="91425" tIns="45700" rIns="91425" bIns="45700" anchor="t" anchorCtr="0">
-            <a:normAutofit/>
+          <a:bodyPr wrap="square">
+            <a:spAutoFit/>
           </a:bodyPr>
           <a:lstStyle/>
-          <a:p>
-            <a:pPr marL="342900" lvl="0" indent="-342900" algn="l">
-              <a:lnSpc>
-                <a:spcPct val="100000"/>
-              </a:lnSpc>
-              <a:spcBef>
-                <a:spcPts val="800"/>
-              </a:spcBef>
-              <a:spcAft>
-                <a:spcPts val="200"/>
-              </a:spcAft>
-              <a:buSzPts val="2600"/>
-              <a:buFont typeface="Noto Sans Symbols"/>
-              <a:buChar char="⮪"/>
-            </a:pPr>
-            <a:r>
-              <a:rPr sz="2200" b="1">
-                <a:solidFill>
-                  <a:srgbClr val="0284C7"/>
-                </a:solidFill>
-                <a:latin typeface="Times New Roman"/>
-              </a:rPr>
-              <a:t>Phase 1: Dataset Curation &amp; Preprocessing</a:t>
-            </a:r>
-          </a:p>
           <a:p>
             <a:pPr>
               <a:spcBef>
@@ -15472,26 +15462,7 @@
                 </a:solidFill>
                 <a:latin typeface="Times New Roman"/>
               </a:rPr>
-              <a:t>•  Extracted wafer maps from the WM-811K benchmark; performed spatial bicubic/nearest resizing to 224x224 and tensor normalization (ImageNet mean &amp; std).</a:t>
-            </a:r>
-          </a:p>
-          <a:p>
-            <a:pPr>
-              <a:spcBef>
-                <a:spcPts val="800"/>
-              </a:spcBef>
-              <a:spcAft>
-                <a:spcPts val="200"/>
-              </a:spcAft>
-            </a:pPr>
-            <a:r>
-              <a:rPr sz="2200" b="1">
-                <a:solidFill>
-                  <a:srgbClr val="0284C7"/>
-                </a:solidFill>
-                <a:latin typeface="Times New Roman"/>
-              </a:rPr>
-              <a:t>Phase 2: Transfer Learning &amp; Model Fine-Tuning</a:t>
+              <a:t>•  1. M.-J. Wu, J.-S. R. Jang, and J.-L. Chen, 'Wafer map failure pattern recognition and similarity ranking for large-scale semiconductor manufacturing,' IEEE Transactions on Semiconductor Manufacturing, vol. 28, no. 1, pp. 1–12, 2015.</a:t>
             </a:r>
           </a:p>
           <a:p>
@@ -15510,26 +15481,7 @@
                 </a:solidFill>
                 <a:latin typeface="Times New Roman"/>
               </a:rPr>
-              <a:t>•  Utilized pre-trained MobileNetV3-Small backbone with inverted residual bottlenecks and Hard-Swish activations; replaced the classification head with an 8-output linear layer.</a:t>
-            </a:r>
-          </a:p>
-          <a:p>
-            <a:pPr>
-              <a:spcBef>
-                <a:spcPts val="800"/>
-              </a:spcBef>
-              <a:spcAft>
-                <a:spcPts val="200"/>
-              </a:spcAft>
-            </a:pPr>
-            <a:r>
-              <a:rPr sz="2200" b="1">
-                <a:solidFill>
-                  <a:srgbClr val="0284C7"/>
-                </a:solidFill>
-                <a:latin typeface="Times New Roman"/>
-              </a:rPr>
-              <a:t>Phase 3: Training &amp; Regularization Pipeline</a:t>
+              <a:t>•  2. A. Howard, M. Sandler, G. Chu, L.-C. Chen, B. Chen, M. Tan, W. Wang, Y. Zhu, R. Pang, V. Vasudevan et al., 'Searching for MobileNetV3,' in Proceedings of the IEEE/CVF International Conference on Computer Vision (ICCV), 2019, pp. 1314–1324.</a:t>
             </a:r>
           </a:p>
           <a:p>
@@ -15548,26 +15500,7 @@
                 </a:solidFill>
                 <a:latin typeface="Times New Roman"/>
               </a:rPr>
-              <a:t>•  Trained using Adam optimizer, cross-entropy loss, dropout regularization (p=0.2), and early stopping to prevent overfitting on majority classes.</a:t>
-            </a:r>
-          </a:p>
-          <a:p>
-            <a:pPr>
-              <a:spcBef>
-                <a:spcPts val="800"/>
-              </a:spcBef>
-              <a:spcAft>
-                <a:spcPts val="200"/>
-              </a:spcAft>
-            </a:pPr>
-            <a:r>
-              <a:rPr sz="2200" b="1">
-                <a:solidFill>
-                  <a:srgbClr val="0284C7"/>
-                </a:solidFill>
-                <a:latin typeface="Times New Roman"/>
-              </a:rPr>
-              <a:t>Phase 4: ONNX Compilation &amp; Edge Integration</a:t>
+              <a:t>•  3. T. Nakazawa and D. V. Kulkarni, 'Wafer map defect pattern classification and retrieval using convolutional neural networks,' IEEE Transactions on Semiconductor Manufacturing, vol. 31, no. 2, pp. 309–314, 2018.</a:t>
             </a:r>
           </a:p>
           <a:p>
@@ -15586,38 +15519,30 @@
                 </a:solidFill>
                 <a:latin typeface="Times New Roman"/>
               </a:rPr>
-              <a:t>•  Exported PyTorch computational graph to ONNX with CPU graph optimizations; integrated into a high-concurrency Python REST server and interactive web visualizer.</a:t>
+              <a:t>•  4. S. Cheon, H. Lee, C. O. Kim, and S. H. Lee, 'Convolutional neural network for wafer surface defect classification and the detection of unknown defect classes,' IEEE Transactions on Semiconductor Manufacturing, vol. 32, no. 2, pp. 163–170, 2019.</a:t>
+            </a:r>
+          </a:p>
+          <a:p>
+            <a:pPr>
+              <a:spcBef>
+                <a:spcPts val="200"/>
+              </a:spcBef>
+              <a:spcAft>
+                <a:spcPts val="400"/>
+              </a:spcAft>
+            </a:pPr>
+            <a:r>
+              <a:rPr sz="1800" b="0">
+                <a:solidFill>
+                  <a:srgbClr val="1E293B"/>
+                </a:solidFill>
+                <a:latin typeface="Times New Roman"/>
+              </a:rPr>
+              <a:t>•  5. ONNX Runtime Developers, 'ONNX Runtime: Cross-platform, high performance ML inferencing and training accelerator,' Linux Foundation / Microsoft, 2024. [Online]. Available: https://onnxruntime.ai</a:t>
             </a:r>
           </a:p>
         </p:txBody>
       </p:sp>
-      <p:pic>
-        <p:nvPicPr>
-          <p:cNvPr id="125" name="Google Shape;125;p3"/>
-          <p:cNvPicPr preferRelativeResize="0"/>
-          <p:nvPr/>
-        </p:nvPicPr>
-        <p:blipFill rotWithShape="1">
-          <a:blip r:embed="rId3">
-            <a:alphaModFix/>
-          </a:blip>
-          <a:srcRect l="15320" t="28789" r="16466" b="54857"/>
-          <a:stretch/>
-        </p:blipFill>
-        <p:spPr>
-          <a:xfrm>
-            <a:off x="155527" y="217182"/>
-            <a:ext cx="4521325" cy="812948"/>
-          </a:xfrm>
-          <a:prstGeom prst="rect">
-            <a:avLst/>
-          </a:prstGeom>
-          <a:noFill/>
-          <a:ln>
-            <a:noFill/>
-          </a:ln>
-        </p:spPr>
-      </p:pic>
     </p:spTree>
   </p:cSld>
   <p:clrMapOvr>
@@ -15631,7 +15556,7 @@
   <p:cSld>
     <p:spTree>
       <p:nvGrpSpPr>
-        <p:cNvPr id="1" name="Shape 119"/>
+        <p:cNvPr id="1" name="Shape 391"/>
         <p:cNvGrpSpPr/>
         <p:nvPr/>
       </p:nvGrpSpPr>
@@ -15645,7 +15570,7 @@
       </p:grpSpPr>
       <p:sp>
         <p:nvSpPr>
-          <p:cNvPr id="120" name="Google Shape;120;p3"/>
+          <p:cNvPr id="392" name="Google Shape;392;p27"/>
           <p:cNvSpPr txBox="1">
             <a:spLocks noGrp="1"/>
           </p:cNvSpPr>
@@ -15681,22 +15606,45 @@
               </a:spcAft>
               <a:buNone/>
             </a:pPr>
-            <a:fld id="{00000000-1234-1234-1234-123412341234}" type="slidenum">
-              <a:rPr lang="en-US"/>
-              <a:t>11</a:t>
-            </a:fld>
             <a:endParaRPr/>
           </a:p>
         </p:txBody>
       </p:sp>
       <p:pic>
         <p:nvPicPr>
-          <p:cNvPr id="121" name="Google Shape;121;p3"/>
+          <p:cNvPr id="393" name="Google Shape;393;p27"/>
           <p:cNvPicPr preferRelativeResize="0"/>
           <p:nvPr/>
         </p:nvPicPr>
         <p:blipFill rotWithShape="1">
           <a:blip r:embed="rId2">
+            <a:alphaModFix/>
+          </a:blip>
+          <a:srcRect/>
+          <a:stretch/>
+        </p:blipFill>
+        <p:spPr>
+          <a:xfrm>
+            <a:off x="159971" y="211556"/>
+            <a:ext cx="4517529" cy="810838"/>
+          </a:xfrm>
+          <a:prstGeom prst="rect">
+            <a:avLst/>
+          </a:prstGeom>
+          <a:noFill/>
+          <a:ln>
+            <a:noFill/>
+          </a:ln>
+        </p:spPr>
+      </p:pic>
+      <p:pic>
+        <p:nvPicPr>
+          <p:cNvPr id="394" name="Google Shape;394;p27"/>
+          <p:cNvPicPr preferRelativeResize="0"/>
+          <p:nvPr/>
+        </p:nvPicPr>
+        <p:blipFill rotWithShape="1">
+          <a:blip r:embed="rId3">
             <a:alphaModFix/>
           </a:blip>
           <a:srcRect/>
@@ -15718,7 +15666,7 @@
       </p:pic>
       <p:sp>
         <p:nvSpPr>
-          <p:cNvPr id="122" name="Google Shape;122;p3"/>
+          <p:cNvPr id="395" name="Google Shape;395;p27"/>
           <p:cNvSpPr/>
           <p:nvPr/>
         </p:nvSpPr>
@@ -15807,18 +15755,18 @@
       </p:sp>
       <p:sp>
         <p:nvSpPr>
-          <p:cNvPr id="123" name="Google Shape;123;p3"/>
+          <p:cNvPr id="396" name="Google Shape;396;p27"/>
           <p:cNvSpPr txBox="1">
             <a:spLocks noGrp="1"/>
           </p:cNvSpPr>
           <p:nvPr>
-            <p:ph type="ctrTitle"/>
+            <p:ph type="title"/>
           </p:nvPr>
         </p:nvSpPr>
         <p:spPr>
           <a:xfrm>
-            <a:off x="459967" y="1100168"/>
-            <a:ext cx="9625800" cy="761400"/>
+            <a:off x="914400" y="2560320"/>
+            <a:ext cx="10332720" cy="2011680"/>
           </a:xfrm>
           <a:prstGeom prst="rect">
             <a:avLst/>
@@ -15829,12 +15777,12 @@
           </a:ln>
         </p:spPr>
         <p:txBody>
-          <a:bodyPr spcFirstLastPara="1" wrap="square" lIns="91425" tIns="45700" rIns="91425" bIns="45700" anchor="b" anchorCtr="0">
+          <a:bodyPr spcFirstLastPara="1" wrap="square" lIns="91425" tIns="45700" rIns="91425" bIns="45700" anchor="ctr" anchorCtr="0">
             <a:normAutofit/>
           </a:bodyPr>
           <a:lstStyle/>
           <a:p>
-            <a:pPr marL="0" lvl="0" indent="0" algn="l" rtl="0">
+            <a:pPr marL="0" lvl="0" indent="0" algn="ctr" rtl="0">
               <a:lnSpc>
                 <a:spcPct val="90000"/>
               </a:lnSpc>
@@ -15845,43 +15793,22 @@
                 <a:spcPts val="0"/>
               </a:spcAft>
               <a:buClr>
-                <a:srgbClr val="181C24"/>
-              </a:buClr>
-              <a:buSzPts val="4000"/>
+                <a:schemeClr val="dk1"/>
+              </a:buClr>
+              <a:buSzPts val="4400"/>
               <a:buFont typeface="Times New Roman"/>
               <a:buNone/>
             </a:pPr>
             <a:r>
-              <a:rPr lang="en-US" sz="4000" dirty="0">
-                <a:solidFill>
-                  <a:srgbClr val="181C24"/>
-                </a:solidFill>
-                <a:highlight>
-                  <a:srgbClr val="FFFFFF"/>
-                </a:highlight>
+              <a:rPr sz="6400" b="1">
+                <a:solidFill>
+                  <a:srgbClr val="0F172A"/>
+                </a:solidFill>
                 <a:latin typeface="Times New Roman"/>
-                <a:ea typeface="Times New Roman"/>
-                <a:cs typeface="Times New Roman"/>
-                <a:sym typeface="Times New Roman"/>
               </a:rPr>
-              <a:t> </a:t>
+              <a:t>THANK YOU</a:t>
             </a:r>
-            <a:r>
-              <a:rPr lang="en-US" sz="3600" b="1" dirty="0">
-                <a:solidFill>
-                  <a:srgbClr val="181C24"/>
-                </a:solidFill>
-                <a:highlight>
-                  <a:srgbClr val="FFFFFF"/>
-                </a:highlight>
-                <a:latin typeface="Times New Roman"/>
-                <a:ea typeface="Times New Roman"/>
-                <a:cs typeface="Times New Roman"/>
-                <a:sym typeface="Times New Roman"/>
-              </a:rPr>
-              <a:t>HARDWARE REQUIREMENTS</a:t>
-            </a:r>
-            <a:endParaRPr sz="3600" b="1" dirty="0">
+            <a:endParaRPr i="1">
               <a:latin typeface="Times New Roman"/>
               <a:ea typeface="Times New Roman"/>
               <a:cs typeface="Times New Roman"/>
@@ -15892,18 +15819,14 @@
       </p:sp>
       <p:sp>
         <p:nvSpPr>
-          <p:cNvPr id="124" name="Google Shape;124;p3"/>
-          <p:cNvSpPr txBox="1">
-            <a:spLocks noGrp="1"/>
-          </p:cNvSpPr>
-          <p:nvPr>
-            <p:ph type="subTitle" idx="1"/>
-          </p:nvPr>
+          <p:cNvPr id="397" name="Questions Subtitle"/>
+          <p:cNvSpPr txBox="1"/>
+          <p:nvPr/>
         </p:nvSpPr>
         <p:spPr>
           <a:xfrm>
-            <a:off x="459967" y="2055887"/>
-            <a:ext cx="11128800" cy="4351800"/>
+            <a:off x="-18288000" y="4000000"/>
+            <a:ext cx="10515600" cy="700000"/>
           </a:xfrm>
           <a:prstGeom prst="rect">
             <a:avLst/>
@@ -15919,114 +15842,21 @@
           </a:bodyPr>
           <a:lstStyle/>
           <a:p>
-            <a:pPr marL="342900" lvl="0" indent="-342900" algn="l">
-              <a:lnSpc>
-                <a:spcPct val="100000"/>
-              </a:lnSpc>
-              <a:spcBef>
-                <a:spcPts val="1200"/>
-              </a:spcBef>
-              <a:buSzPts val="2600"/>
-              <a:buFont typeface="Noto Sans Symbols"/>
-              <a:buChar char="⮪"/>
+            <a:pPr marL="0" lvl="0" indent="0" algn="ctr" rtl="0">
+              <a:spcBef>
+                <a:spcPts val="0"/>
+              </a:spcBef>
+              <a:buNone/>
             </a:pPr>
-            <a:r>
-              <a:rPr lang="en-US" dirty="0">
-                <a:latin typeface="Times New Roman" panose="02020603050405020304" pitchFamily="18" charset="0"/>
-                <a:cs typeface="Times New Roman" panose="02020603050405020304" pitchFamily="18" charset="0"/>
-              </a:rPr>
-              <a:t>Intel i5 Processor (or equivalent)</a:t>
-            </a:r>
-          </a:p>
-          <a:p>
-            <a:pPr marL="342900" lvl="0" indent="-342900" algn="l">
-              <a:lnSpc>
-                <a:spcPct val="100000"/>
-              </a:lnSpc>
-              <a:spcBef>
-                <a:spcPts val="1200"/>
-              </a:spcBef>
-              <a:buSzPts val="2600"/>
-              <a:buFont typeface="Noto Sans Symbols"/>
-              <a:buChar char="⮪"/>
-            </a:pPr>
-            <a:r>
-              <a:rPr lang="en-US" dirty="0">
-                <a:latin typeface="Times New Roman" panose="02020603050405020304" pitchFamily="18" charset="0"/>
-                <a:cs typeface="Times New Roman" panose="02020603050405020304" pitchFamily="18" charset="0"/>
-              </a:rPr>
-              <a:t>8 GB RAM</a:t>
-            </a:r>
-          </a:p>
-          <a:p>
-            <a:pPr marL="342900" lvl="0" indent="-342900" algn="l">
-              <a:lnSpc>
-                <a:spcPct val="100000"/>
-              </a:lnSpc>
-              <a:spcBef>
-                <a:spcPts val="1200"/>
-              </a:spcBef>
-              <a:buSzPts val="2600"/>
-              <a:buFont typeface="Noto Sans Symbols"/>
-              <a:buChar char="⮪"/>
-            </a:pPr>
-            <a:r>
-              <a:rPr lang="en-US" dirty="0">
-                <a:latin typeface="Times New Roman" panose="02020603050405020304" pitchFamily="18" charset="0"/>
-                <a:cs typeface="Times New Roman" panose="02020603050405020304" pitchFamily="18" charset="0"/>
-              </a:rPr>
-              <a:t>256 GB SSD Storage</a:t>
-            </a:r>
-          </a:p>
-          <a:p>
-            <a:pPr marL="342900" lvl="0" indent="-342900" algn="l">
-              <a:lnSpc>
-                <a:spcPct val="100000"/>
-              </a:lnSpc>
-              <a:spcBef>
-                <a:spcPts val="1200"/>
-              </a:spcBef>
-              <a:buSzPts val="2600"/>
-              <a:buFont typeface="Noto Sans Symbols"/>
-              <a:buChar char="⮪"/>
-            </a:pPr>
-            <a:r>
-              <a:rPr lang="en-US" dirty="0">
-                <a:latin typeface="Times New Roman" panose="02020603050405020304" pitchFamily="18" charset="0"/>
-                <a:cs typeface="Times New Roman" panose="02020603050405020304" pitchFamily="18" charset="0"/>
-              </a:rPr>
-              <a:t>Stable Internet Connection</a:t>
-            </a:r>
+            <a:endParaRPr sz="2800" dirty="0">
+              <a:latin typeface="Times New Roman"/>
+              <a:ea typeface="Times New Roman"/>
+              <a:cs typeface="Times New Roman"/>
+              <a:sym typeface="Times New Roman"/>
+            </a:endParaRPr>
           </a:p>
         </p:txBody>
       </p:sp>
-      <p:pic>
-        <p:nvPicPr>
-          <p:cNvPr id="125" name="Google Shape;125;p3"/>
-          <p:cNvPicPr preferRelativeResize="0"/>
-          <p:nvPr/>
-        </p:nvPicPr>
-        <p:blipFill rotWithShape="1">
-          <a:blip r:embed="rId3">
-            <a:alphaModFix/>
-          </a:blip>
-          <a:srcRect l="15320" t="28789" r="16466" b="54857"/>
-          <a:stretch/>
-        </p:blipFill>
-        <p:spPr>
-          <a:xfrm>
-            <a:off x="155527" y="217182"/>
-            <a:ext cx="4521325" cy="812948"/>
-          </a:xfrm>
-          <a:prstGeom prst="rect">
-            <a:avLst/>
-          </a:prstGeom>
-          <a:noFill/>
-          <a:ln>
-            <a:noFill/>
-          </a:ln>
-        </p:spPr>
-      </p:pic>
     </p:spTree>
   </p:cSld>
   <p:clrMapOvr>
@@ -16035,12 +15865,12 @@
 </p:sld>
 </file>
 
-<file path=ppt/slides/slide12.xml><?xml version="1.0" encoding="utf-8"?>
+<file path=ppt/slides/slide11.xml><?xml version="1.0" encoding="utf-8"?>
 <p:sld xmlns:a="http://schemas.openxmlformats.org/drawingml/2006/main" xmlns:r="http://schemas.openxmlformats.org/officeDocument/2006/relationships" xmlns:p="http://schemas.openxmlformats.org/presentationml/2006/main">
   <p:cSld>
     <p:spTree>
       <p:nvGrpSpPr>
-        <p:cNvPr id="1" name="Shape 119"/>
+        <p:cNvPr id="1" name="Shape 391"/>
         <p:cNvGrpSpPr/>
         <p:nvPr/>
       </p:nvGrpSpPr>
@@ -16054,7 +15884,7 @@
       </p:grpSpPr>
       <p:sp>
         <p:nvSpPr>
-          <p:cNvPr id="120" name="Google Shape;120;p3"/>
+          <p:cNvPr id="392" name="Google Shape;392;p27"/>
           <p:cNvSpPr txBox="1">
             <a:spLocks noGrp="1"/>
           </p:cNvSpPr>
@@ -16090,27 +15920,45 @@
               </a:spcAft>
               <a:buNone/>
             </a:pPr>
-            <a:r>
-              <a:rPr sz="1800" b="1">
-                <a:solidFill>
-                  <a:srgbClr val="0F172A"/>
-                </a:solidFill>
-                <a:latin typeface="Times New Roman"/>
-              </a:rPr>
-              <a:t>9</a:t>
-            </a:r>
             <a:endParaRPr/>
           </a:p>
         </p:txBody>
       </p:sp>
       <p:pic>
         <p:nvPicPr>
-          <p:cNvPr id="121" name="Google Shape;121;p3"/>
+          <p:cNvPr id="393" name="Google Shape;393;p27"/>
           <p:cNvPicPr preferRelativeResize="0"/>
           <p:nvPr/>
         </p:nvPicPr>
         <p:blipFill rotWithShape="1">
           <a:blip r:embed="rId2">
+            <a:alphaModFix/>
+          </a:blip>
+          <a:srcRect/>
+          <a:stretch/>
+        </p:blipFill>
+        <p:spPr>
+          <a:xfrm>
+            <a:off x="159971" y="211556"/>
+            <a:ext cx="4517529" cy="810838"/>
+          </a:xfrm>
+          <a:prstGeom prst="rect">
+            <a:avLst/>
+          </a:prstGeom>
+          <a:noFill/>
+          <a:ln>
+            <a:noFill/>
+          </a:ln>
+        </p:spPr>
+      </p:pic>
+      <p:pic>
+        <p:nvPicPr>
+          <p:cNvPr id="394" name="Google Shape;394;p27"/>
+          <p:cNvPicPr preferRelativeResize="0"/>
+          <p:nvPr/>
+        </p:nvPicPr>
+        <p:blipFill rotWithShape="1">
+          <a:blip r:embed="rId3">
             <a:alphaModFix/>
           </a:blip>
           <a:srcRect/>
@@ -16132,7 +15980,7 @@
       </p:pic>
       <p:sp>
         <p:nvSpPr>
-          <p:cNvPr id="122" name="Google Shape;122;p3"/>
+          <p:cNvPr id="395" name="Google Shape;395;p27"/>
           <p:cNvSpPr/>
           <p:nvPr/>
         </p:nvSpPr>
@@ -16221,18 +16069,18 @@
       </p:sp>
       <p:sp>
         <p:nvSpPr>
-          <p:cNvPr id="123" name="Google Shape;123;p3"/>
+          <p:cNvPr id="396" name="Google Shape;396;p27"/>
           <p:cNvSpPr txBox="1">
             <a:spLocks noGrp="1"/>
           </p:cNvSpPr>
           <p:nvPr>
-            <p:ph type="ctrTitle"/>
+            <p:ph type="title"/>
           </p:nvPr>
         </p:nvSpPr>
         <p:spPr>
           <a:xfrm>
-            <a:off x="459967" y="1100168"/>
-            <a:ext cx="9625800" cy="761400"/>
+            <a:off x="914400" y="2560320"/>
+            <a:ext cx="10332720" cy="2011680"/>
           </a:xfrm>
           <a:prstGeom prst="rect">
             <a:avLst/>
@@ -16243,12 +16091,12 @@
           </a:ln>
         </p:spPr>
         <p:txBody>
-          <a:bodyPr spcFirstLastPara="1" wrap="square" lIns="91425" tIns="45700" rIns="91425" bIns="45700" anchor="b" anchorCtr="0">
+          <a:bodyPr spcFirstLastPara="1" wrap="square" lIns="91425" tIns="45700" rIns="91425" bIns="45700" anchor="ctr" anchorCtr="0">
             <a:normAutofit/>
           </a:bodyPr>
           <a:lstStyle/>
           <a:p>
-            <a:pPr marL="0" lvl="0" indent="0" algn="l" rtl="0">
+            <a:pPr marL="0" lvl="0" indent="0" algn="ctr" rtl="0">
               <a:lnSpc>
                 <a:spcPct val="90000"/>
               </a:lnSpc>
@@ -16259,22 +16107,22 @@
                 <a:spcPts val="0"/>
               </a:spcAft>
               <a:buClr>
-                <a:srgbClr val="181C24"/>
-              </a:buClr>
-              <a:buSzPts val="4000"/>
+                <a:schemeClr val="dk1"/>
+              </a:buClr>
+              <a:buSzPts val="4400"/>
               <a:buFont typeface="Times New Roman"/>
               <a:buNone/>
             </a:pPr>
             <a:r>
-              <a:rPr sz="3400" b="1">
+              <a:rPr sz="6400" b="1">
                 <a:solidFill>
                   <a:srgbClr val="0F172A"/>
                 </a:solidFill>
                 <a:latin typeface="Times New Roman"/>
               </a:rPr>
-              <a:t>EXPERIMENTAL RESULTS &amp; OUTCOMES</a:t>
+              <a:t>THANK YOU</a:t>
             </a:r>
-            <a:endParaRPr sz="3600" b="1" dirty="0">
+            <a:endParaRPr i="1">
               <a:latin typeface="Times New Roman"/>
               <a:ea typeface="Times New Roman"/>
               <a:cs typeface="Times New Roman"/>
@@ -16285,18 +16133,14 @@
       </p:sp>
       <p:sp>
         <p:nvSpPr>
-          <p:cNvPr id="124" name="Google Shape;124;p3"/>
-          <p:cNvSpPr txBox="1">
-            <a:spLocks noGrp="1"/>
-          </p:cNvSpPr>
-          <p:nvPr>
-            <p:ph type="subTitle" idx="1"/>
-          </p:nvPr>
+          <p:cNvPr id="397" name="Questions Subtitle"/>
+          <p:cNvSpPr txBox="1"/>
+          <p:nvPr/>
         </p:nvSpPr>
         <p:spPr>
           <a:xfrm>
-            <a:off x="731520" y="1828800"/>
-            <a:ext cx="6217920" cy="4114800"/>
+            <a:off x="-18288000" y="4000000"/>
+            <a:ext cx="10515600" cy="700000"/>
           </a:xfrm>
           <a:prstGeom prst="rect">
             <a:avLst/>
@@ -16312,273 +16156,21 @@
           </a:bodyPr>
           <a:lstStyle/>
           <a:p>
-            <a:pPr marL="342900" lvl="0" indent="-342900" algn="l">
-              <a:lnSpc>
-                <a:spcPct val="100000"/>
-              </a:lnSpc>
-              <a:spcBef>
-                <a:spcPts val="600"/>
-              </a:spcBef>
-              <a:spcAft>
-                <a:spcPts val="200"/>
-              </a:spcAft>
-              <a:buSzPts val="2600"/>
-              <a:buFont typeface="Noto Sans Symbols"/>
-              <a:buChar char="⮪"/>
+            <a:pPr marL="0" lvl="0" indent="0" algn="ctr" rtl="0">
+              <a:spcBef>
+                <a:spcPts val="0"/>
+              </a:spcBef>
+              <a:buNone/>
             </a:pPr>
-            <a:r>
-              <a:rPr sz="2000" b="1">
-                <a:solidFill>
-                  <a:srgbClr val="0284C7"/>
-                </a:solidFill>
-                <a:latin typeface="Times New Roman"/>
-              </a:rPr>
-              <a:t>Key Performance Metrics</a:t>
-            </a:r>
-          </a:p>
-          <a:p>
-            <a:pPr>
-              <a:spcBef>
-                <a:spcPts val="200"/>
-              </a:spcBef>
-              <a:spcAft>
-                <a:spcPts val="300"/>
-              </a:spcAft>
-            </a:pPr>
-            <a:r>
-              <a:rPr sz="1500" b="0">
-                <a:solidFill>
-                  <a:srgbClr val="1E293B"/>
-                </a:solidFill>
-                <a:latin typeface="Times New Roman"/>
-              </a:rPr>
-              <a:t>•  Overall Test Set Accuracy: 98.02% across 121,719 test wafer samples.</a:t>
-            </a:r>
-          </a:p>
-          <a:p>
-            <a:pPr>
-              <a:spcBef>
-                <a:spcPts val="200"/>
-              </a:spcBef>
-              <a:spcAft>
-                <a:spcPts val="300"/>
-              </a:spcAft>
-            </a:pPr>
-            <a:r>
-              <a:rPr sz="1500" b="0">
-                <a:solidFill>
-                  <a:srgbClr val="1E293B"/>
-                </a:solidFill>
-                <a:latin typeface="Times New Roman"/>
-              </a:rPr>
-              <a:t>•  Macro Precision: 0.6897  |  Macro Recall: 0.6177</a:t>
-            </a:r>
-          </a:p>
-          <a:p>
-            <a:pPr>
-              <a:spcBef>
-                <a:spcPts val="200"/>
-              </a:spcBef>
-              <a:spcAft>
-                <a:spcPts val="300"/>
-              </a:spcAft>
-            </a:pPr>
-            <a:r>
-              <a:rPr sz="1500" b="0">
-                <a:solidFill>
-                  <a:srgbClr val="1E293B"/>
-                </a:solidFill>
-                <a:latin typeface="Times New Roman"/>
-              </a:rPr>
-              <a:t>•  Inference Latency: 1.53 ms on standard CPU (zero GPU requirement).</a:t>
-            </a:r>
-          </a:p>
-          <a:p>
-            <a:pPr>
-              <a:spcBef>
-                <a:spcPts val="200"/>
-              </a:spcBef>
-              <a:spcAft>
-                <a:spcPts val="300"/>
-              </a:spcAft>
-            </a:pPr>
-            <a:r>
-              <a:rPr sz="1500" b="0">
-                <a:solidFill>
-                  <a:srgbClr val="1E293B"/>
-                </a:solidFill>
-                <a:latin typeface="Times New Roman"/>
-              </a:rPr>
-              <a:t>•  Model Binary Footprint: 5.84 MB (ultra-compact ONNX engine).</a:t>
-            </a:r>
-          </a:p>
-          <a:p>
-            <a:pPr>
-              <a:spcBef>
-                <a:spcPts val="600"/>
-              </a:spcBef>
-              <a:spcAft>
-                <a:spcPts val="200"/>
-              </a:spcAft>
-            </a:pPr>
-            <a:r>
-              <a:rPr sz="2000" b="1">
-                <a:solidFill>
-                  <a:srgbClr val="0284C7"/>
-                </a:solidFill>
-                <a:latin typeface="Times New Roman"/>
-              </a:rPr>
-              <a:t>Per-Class Defect Verification Highlights</a:t>
-            </a:r>
-          </a:p>
-          <a:p>
-            <a:pPr>
-              <a:spcBef>
-                <a:spcPts val="200"/>
-              </a:spcBef>
-              <a:spcAft>
-                <a:spcPts val="300"/>
-              </a:spcAft>
-            </a:pPr>
-            <a:r>
-              <a:rPr sz="1500" b="0">
-                <a:solidFill>
-                  <a:srgbClr val="1E293B"/>
-                </a:solidFill>
-                <a:latin typeface="Times New Roman"/>
-              </a:rPr>
-              <a:t>•  Clean (Nominal): 99.98% Precision, 100% Detection Rate (Near-zero false alarms).</a:t>
-            </a:r>
-          </a:p>
-          <a:p>
-            <a:pPr>
-              <a:spcBef>
-                <a:spcPts val="200"/>
-              </a:spcBef>
-              <a:spcAft>
-                <a:spcPts val="300"/>
-              </a:spcAft>
-            </a:pPr>
-            <a:r>
-              <a:rPr sz="1500" b="0">
-                <a:solidFill>
-                  <a:srgbClr val="1E293B"/>
-                </a:solidFill>
-                <a:latin typeface="Times New Roman"/>
-              </a:rPr>
-              <a:t>•  Scratch: 99.92% Confidence with clear linear scratch isolation.</a:t>
-            </a:r>
-          </a:p>
-          <a:p>
-            <a:pPr>
-              <a:spcBef>
-                <a:spcPts val="200"/>
-              </a:spcBef>
-              <a:spcAft>
-                <a:spcPts val="300"/>
-              </a:spcAft>
-            </a:pPr>
-            <a:r>
-              <a:rPr sz="1500" b="0">
-                <a:solidFill>
-                  <a:srgbClr val="1E293B"/>
-                </a:solidFill>
-                <a:latin typeface="Times New Roman"/>
-              </a:rPr>
-              <a:t>•  Donut: 99.99% Confidence detecting radial thermal ring defects.</a:t>
-            </a:r>
-          </a:p>
-          <a:p>
-            <a:pPr>
-              <a:spcBef>
-                <a:spcPts val="200"/>
-              </a:spcBef>
-              <a:spcAft>
-                <a:spcPts val="300"/>
-              </a:spcAft>
-            </a:pPr>
-            <a:r>
-              <a:rPr sz="1500" b="0">
-                <a:solidFill>
-                  <a:srgbClr val="1E293B"/>
-                </a:solidFill>
-                <a:latin typeface="Times New Roman"/>
-              </a:rPr>
-              <a:t>•  Center Cluster: 98.01% Confidence detecting CMP slurry anomalies.</a:t>
-            </a:r>
-          </a:p>
-          <a:p>
-            <a:pPr>
-              <a:spcBef>
-                <a:spcPts val="200"/>
-              </a:spcBef>
-              <a:spcAft>
-                <a:spcPts val="300"/>
-              </a:spcAft>
-            </a:pPr>
-            <a:r>
-              <a:rPr sz="1500" b="0">
-                <a:solidFill>
-                  <a:srgbClr val="1E293B"/>
-                </a:solidFill>
-                <a:latin typeface="Times New Roman"/>
-              </a:rPr>
-              <a:t>•  Edge-Loc &amp; Loc: &gt;99.2% Confidence identifying localized clusters.</a:t>
-            </a:r>
+            <a:endParaRPr sz="2800" dirty="0">
+              <a:latin typeface="Times New Roman"/>
+              <a:ea typeface="Times New Roman"/>
+              <a:cs typeface="Times New Roman"/>
+              <a:sym typeface="Times New Roman"/>
+            </a:endParaRPr>
           </a:p>
         </p:txBody>
       </p:sp>
-      <p:pic>
-        <p:nvPicPr>
-          <p:cNvPr id="125" name="Google Shape;125;p3"/>
-          <p:cNvPicPr preferRelativeResize="0"/>
-          <p:nvPr/>
-        </p:nvPicPr>
-        <p:blipFill rotWithShape="1">
-          <a:blip r:embed="rId3">
-            <a:alphaModFix/>
-          </a:blip>
-          <a:srcRect l="15320" t="28789" r="16466" b="54857"/>
-          <a:stretch/>
-        </p:blipFill>
-        <p:spPr>
-          <a:xfrm>
-            <a:off x="155527" y="217182"/>
-            <a:ext cx="4521325" cy="812948"/>
-          </a:xfrm>
-          <a:prstGeom prst="rect">
-            <a:avLst/>
-          </a:prstGeom>
-          <a:noFill/>
-          <a:ln>
-            <a:noFill/>
-          </a:ln>
-        </p:spPr>
-      </p:pic>
-      <p:pic>
-        <p:nvPicPr>
-          <p:cNvPr id="126" name="Picture 125" descr="confusion_matrix.png"/>
-          <p:cNvPicPr>
-            <a:picLocks noChangeAspect="1"/>
-          </p:cNvPicPr>
-          <p:nvPr/>
-        </p:nvPicPr>
-        <p:blipFill>
-          <a:blip r:embed="rId4"/>
-          <a:stretch>
-            <a:fillRect/>
-          </a:stretch>
-        </p:blipFill>
-        <p:spPr>
-          <a:xfrm>
-            <a:off x="7132320" y="1920240"/>
-            <a:ext cx="4206240" cy="3840480"/>
-          </a:xfrm>
-          <a:prstGeom prst="rect">
-            <a:avLst/>
-          </a:prstGeom>
-        </p:spPr>
-      </p:pic>
     </p:spTree>
   </p:cSld>
   <p:clrMapOvr>
@@ -16871,785 +16463,6 @@
               <a:cs typeface="Calibri"/>
               <a:sym typeface="Calibri"/>
             </a:endParaRPr>
-          </a:p>
-        </p:txBody>
-      </p:sp>
-    </p:spTree>
-  </p:cSld>
-  <p:clrMapOvr>
-    <a:masterClrMapping/>
-  </p:clrMapOvr>
-</p:sld>
-</file>
-
-<file path=ppt/slides/slide14.xml><?xml version="1.0" encoding="utf-8"?>
-<p:sld xmlns:a="http://schemas.openxmlformats.org/drawingml/2006/main" xmlns:r="http://schemas.openxmlformats.org/officeDocument/2006/relationships" xmlns:p="http://schemas.openxmlformats.org/presentationml/2006/main">
-  <p:cSld>
-    <p:spTree>
-      <p:nvGrpSpPr>
-        <p:cNvPr id="1" name="Shape 381"/>
-        <p:cNvGrpSpPr/>
-        <p:nvPr/>
-      </p:nvGrpSpPr>
-      <p:grpSpPr>
-        <a:xfrm>
-          <a:off x="0" y="0"/>
-          <a:ext cx="0" cy="0"/>
-          <a:chOff x="0" y="0"/>
-          <a:chExt cx="0" cy="0"/>
-        </a:xfrm>
-      </p:grpSpPr>
-      <p:sp>
-        <p:nvSpPr>
-          <p:cNvPr id="382" name="Google Shape;382;p26"/>
-          <p:cNvSpPr txBox="1">
-            <a:spLocks noGrp="1"/>
-          </p:cNvSpPr>
-          <p:nvPr>
-            <p:ph type="title"/>
-          </p:nvPr>
-        </p:nvSpPr>
-        <p:spPr>
-          <a:xfrm>
-            <a:off x="680884" y="743804"/>
-            <a:ext cx="10515600" cy="1325700"/>
-          </a:xfrm>
-          <a:prstGeom prst="rect">
-            <a:avLst/>
-          </a:prstGeom>
-          <a:noFill/>
-          <a:ln>
-            <a:noFill/>
-          </a:ln>
-        </p:spPr>
-        <p:txBody>
-          <a:bodyPr spcFirstLastPara="1" wrap="square" lIns="91425" tIns="45700" rIns="91425" bIns="45700" anchor="ctr" anchorCtr="0">
-            <a:normAutofit/>
-          </a:bodyPr>
-          <a:lstStyle/>
-          <a:p>
-            <a:pPr marL="0" lvl="0" indent="0" algn="l" rtl="0">
-              <a:lnSpc>
-                <a:spcPct val="90000"/>
-              </a:lnSpc>
-              <a:spcBef>
-                <a:spcPts val="0"/>
-              </a:spcBef>
-              <a:spcAft>
-                <a:spcPts val="0"/>
-              </a:spcAft>
-              <a:buClr>
-                <a:schemeClr val="dk1"/>
-              </a:buClr>
-              <a:buSzPts val="3600"/>
-              <a:buFont typeface="Times New Roman"/>
-              <a:buNone/>
-            </a:pPr>
-            <a:r>
-              <a:rPr sz="3400" b="1">
-                <a:solidFill>
-                  <a:srgbClr val="0F172A"/>
-                </a:solidFill>
-                <a:latin typeface="Times New Roman"/>
-              </a:rPr>
-              <a:t>REFERENCES</a:t>
-            </a:r>
-            <a:endParaRPr b="1" dirty="0"/>
-          </a:p>
-        </p:txBody>
-      </p:sp>
-      <p:sp>
-        <p:nvSpPr>
-          <p:cNvPr id="384" name="Google Shape;384;p26"/>
-          <p:cNvSpPr txBox="1">
-            <a:spLocks noGrp="1"/>
-          </p:cNvSpPr>
-          <p:nvPr>
-            <p:ph type="sldNum" idx="12"/>
-          </p:nvPr>
-        </p:nvSpPr>
-        <p:spPr>
-          <a:xfrm>
-            <a:off x="8610600" y="6356350"/>
-            <a:ext cx="2743200" cy="365100"/>
-          </a:xfrm>
-          <a:prstGeom prst="rect">
-            <a:avLst/>
-          </a:prstGeom>
-          <a:noFill/>
-          <a:ln>
-            <a:noFill/>
-          </a:ln>
-        </p:spPr>
-        <p:txBody>
-          <a:bodyPr spcFirstLastPara="1" wrap="square" lIns="91425" tIns="45700" rIns="91425" bIns="45700" anchor="ctr" anchorCtr="0">
-            <a:noAutofit/>
-          </a:bodyPr>
-          <a:lstStyle/>
-          <a:p>
-            <a:pPr marL="0" lvl="0" indent="0" algn="r" rtl="0">
-              <a:spcBef>
-                <a:spcPts val="0"/>
-              </a:spcBef>
-              <a:spcAft>
-                <a:spcPts val="0"/>
-              </a:spcAft>
-              <a:buNone/>
-            </a:pPr>
-            <a:r>
-              <a:rPr sz="1800" b="1">
-                <a:solidFill>
-                  <a:srgbClr val="0F172A"/>
-                </a:solidFill>
-                <a:latin typeface="Times New Roman"/>
-              </a:rPr>
-              <a:t>10</a:t>
-            </a:r>
-            <a:endParaRPr/>
-          </a:p>
-        </p:txBody>
-      </p:sp>
-      <p:pic>
-        <p:nvPicPr>
-          <p:cNvPr id="385" name="Google Shape;385;p26"/>
-          <p:cNvPicPr preferRelativeResize="0"/>
-          <p:nvPr/>
-        </p:nvPicPr>
-        <p:blipFill rotWithShape="1">
-          <a:blip r:embed="rId2">
-            <a:alphaModFix/>
-          </a:blip>
-          <a:srcRect/>
-          <a:stretch/>
-        </p:blipFill>
-        <p:spPr>
-          <a:xfrm>
-            <a:off x="159971" y="211556"/>
-            <a:ext cx="4517529" cy="810838"/>
-          </a:xfrm>
-          <a:prstGeom prst="rect">
-            <a:avLst/>
-          </a:prstGeom>
-          <a:noFill/>
-          <a:ln>
-            <a:noFill/>
-          </a:ln>
-        </p:spPr>
-      </p:pic>
-      <p:pic>
-        <p:nvPicPr>
-          <p:cNvPr id="386" name="Google Shape;386;p26"/>
-          <p:cNvPicPr preferRelativeResize="0"/>
-          <p:nvPr/>
-        </p:nvPicPr>
-        <p:blipFill rotWithShape="1">
-          <a:blip r:embed="rId3">
-            <a:alphaModFix/>
-          </a:blip>
-          <a:srcRect/>
-          <a:stretch/>
-        </p:blipFill>
-        <p:spPr>
-          <a:xfrm>
-            <a:off x="11072819" y="154753"/>
-            <a:ext cx="816174" cy="930568"/>
-          </a:xfrm>
-          <a:prstGeom prst="rect">
-            <a:avLst/>
-          </a:prstGeom>
-          <a:noFill/>
-          <a:ln>
-            <a:noFill/>
-          </a:ln>
-        </p:spPr>
-      </p:pic>
-      <p:sp>
-        <p:nvSpPr>
-          <p:cNvPr id="387" name="Google Shape;387;p26"/>
-          <p:cNvSpPr/>
-          <p:nvPr/>
-        </p:nvSpPr>
-        <p:spPr>
-          <a:xfrm>
-            <a:off x="0" y="6407689"/>
-            <a:ext cx="7684389" cy="461665"/>
-          </a:xfrm>
-          <a:custGeom>
-            <a:avLst/>
-            <a:gdLst/>
-            <a:ahLst/>
-            <a:cxnLst/>
-            <a:rect l="l" t="t" r="r" b="b"/>
-            <a:pathLst>
-              <a:path w="6172200" h="369332" extrusionOk="0">
-                <a:moveTo>
-                  <a:pt x="0" y="0"/>
-                </a:moveTo>
-                <a:lnTo>
-                  <a:pt x="5791200" y="0"/>
-                </a:lnTo>
-                <a:lnTo>
-                  <a:pt x="6172200" y="369332"/>
-                </a:lnTo>
-                <a:lnTo>
-                  <a:pt x="0" y="369332"/>
-                </a:lnTo>
-                <a:lnTo>
-                  <a:pt x="0" y="0"/>
-                </a:lnTo>
-                <a:close/>
-              </a:path>
-            </a:pathLst>
-          </a:custGeom>
-          <a:solidFill>
-            <a:schemeClr val="accent1"/>
-          </a:solidFill>
-          <a:ln>
-            <a:noFill/>
-          </a:ln>
-        </p:spPr>
-        <p:txBody>
-          <a:bodyPr spcFirstLastPara="1" wrap="square" lIns="91425" tIns="45700" rIns="91425" bIns="45700" anchor="t" anchorCtr="0">
-            <a:spAutoFit/>
-          </a:bodyPr>
-          <a:lstStyle/>
-          <a:p>
-            <a:pPr marL="0" marR="0" lvl="0" indent="0" algn="ctr" rtl="0">
-              <a:spcBef>
-                <a:spcPts val="0"/>
-              </a:spcBef>
-              <a:spcAft>
-                <a:spcPts val="0"/>
-              </a:spcAft>
-              <a:buClr>
-                <a:schemeClr val="lt1"/>
-              </a:buClr>
-              <a:buSzPts val="2400"/>
-              <a:buFont typeface="Gill Sans"/>
-              <a:buNone/>
-            </a:pPr>
-            <a:r>
-              <a:rPr lang="en-US" sz="2400">
-                <a:solidFill>
-                  <a:schemeClr val="lt1"/>
-                </a:solidFill>
-                <a:latin typeface="Gill Sans"/>
-                <a:ea typeface="Gill Sans"/>
-                <a:cs typeface="Gill Sans"/>
-                <a:sym typeface="Gill Sans"/>
-              </a:rPr>
-              <a:t>LEARN . GROW . EXCEL</a:t>
-            </a:r>
-            <a:endParaRPr sz="1800">
-              <a:solidFill>
-                <a:schemeClr val="dk1"/>
-              </a:solidFill>
-              <a:latin typeface="Calibri"/>
-              <a:ea typeface="Calibri"/>
-              <a:cs typeface="Calibri"/>
-              <a:sym typeface="Calibri"/>
-            </a:endParaRPr>
-          </a:p>
-        </p:txBody>
-      </p:sp>
-      <p:sp>
-        <p:nvSpPr>
-          <p:cNvPr id="388" name="TextBox 387"/>
-          <p:cNvSpPr txBox="1"/>
-          <p:nvPr/>
-        </p:nvSpPr>
-        <p:spPr>
-          <a:xfrm>
-            <a:off x="731520" y="1920240"/>
-            <a:ext cx="10698480" cy="4114800"/>
-          </a:xfrm>
-          <a:prstGeom prst="rect">
-            <a:avLst/>
-          </a:prstGeom>
-          <a:noFill/>
-        </p:spPr>
-        <p:txBody>
-          <a:bodyPr wrap="square">
-            <a:spAutoFit/>
-          </a:bodyPr>
-          <a:lstStyle/>
-          <a:p>
-            <a:pPr>
-              <a:spcBef>
-                <a:spcPts val="200"/>
-              </a:spcBef>
-              <a:spcAft>
-                <a:spcPts val="400"/>
-              </a:spcAft>
-            </a:pPr>
-            <a:r>
-              <a:rPr sz="1800" b="0">
-                <a:solidFill>
-                  <a:srgbClr val="1E293B"/>
-                </a:solidFill>
-                <a:latin typeface="Times New Roman"/>
-              </a:rPr>
-              <a:t>•  1. M.-J. Wu, J.-S. R. Jang, and J.-L. Chen, 'Wafer map failure pattern recognition and similarity ranking for large-scale semiconductor manufacturing,' IEEE Transactions on Semiconductor Manufacturing, vol. 28, no. 1, pp. 1–12, 2015.</a:t>
-            </a:r>
-          </a:p>
-          <a:p>
-            <a:pPr>
-              <a:spcBef>
-                <a:spcPts val="200"/>
-              </a:spcBef>
-              <a:spcAft>
-                <a:spcPts val="400"/>
-              </a:spcAft>
-            </a:pPr>
-            <a:r>
-              <a:rPr sz="1800" b="0">
-                <a:solidFill>
-                  <a:srgbClr val="1E293B"/>
-                </a:solidFill>
-                <a:latin typeface="Times New Roman"/>
-              </a:rPr>
-              <a:t>•  2. A. Howard, M. Sandler, G. Chu, L.-C. Chen, B. Chen, M. Tan, W. Wang, Y. Zhu, R. Pang, V. Vasudevan et al., 'Searching for MobileNetV3,' in Proceedings of the IEEE/CVF International Conference on Computer Vision (ICCV), 2019, pp. 1314–1324.</a:t>
-            </a:r>
-          </a:p>
-          <a:p>
-            <a:pPr>
-              <a:spcBef>
-                <a:spcPts val="200"/>
-              </a:spcBef>
-              <a:spcAft>
-                <a:spcPts val="400"/>
-              </a:spcAft>
-            </a:pPr>
-            <a:r>
-              <a:rPr sz="1800" b="0">
-                <a:solidFill>
-                  <a:srgbClr val="1E293B"/>
-                </a:solidFill>
-                <a:latin typeface="Times New Roman"/>
-              </a:rPr>
-              <a:t>•  3. T. Nakazawa and D. V. Kulkarni, 'Wafer map defect pattern classification and retrieval using convolutional neural networks,' IEEE Transactions on Semiconductor Manufacturing, vol. 31, no. 2, pp. 309–314, 2018.</a:t>
-            </a:r>
-          </a:p>
-          <a:p>
-            <a:pPr>
-              <a:spcBef>
-                <a:spcPts val="200"/>
-              </a:spcBef>
-              <a:spcAft>
-                <a:spcPts val="400"/>
-              </a:spcAft>
-            </a:pPr>
-            <a:r>
-              <a:rPr sz="1800" b="0">
-                <a:solidFill>
-                  <a:srgbClr val="1E293B"/>
-                </a:solidFill>
-                <a:latin typeface="Times New Roman"/>
-              </a:rPr>
-              <a:t>•  4. S. Cheon, H. Lee, C. O. Kim, and S. H. Lee, 'Convolutional neural network for wafer surface defect classification and the detection of unknown defect classes,' IEEE Transactions on Semiconductor Manufacturing, vol. 32, no. 2, pp. 163–170, 2019.</a:t>
-            </a:r>
-          </a:p>
-          <a:p>
-            <a:pPr>
-              <a:spcBef>
-                <a:spcPts val="200"/>
-              </a:spcBef>
-              <a:spcAft>
-                <a:spcPts val="400"/>
-              </a:spcAft>
-            </a:pPr>
-            <a:r>
-              <a:rPr sz="1800" b="0">
-                <a:solidFill>
-                  <a:srgbClr val="1E293B"/>
-                </a:solidFill>
-                <a:latin typeface="Times New Roman"/>
-              </a:rPr>
-              <a:t>•  5. ONNX Runtime Developers, 'ONNX Runtime: Cross-platform, high performance ML inferencing and training accelerator,' Linux Foundation / Microsoft, 2024. [Online]. Available: https://onnxruntime.ai</a:t>
-            </a:r>
-          </a:p>
-        </p:txBody>
-      </p:sp>
-    </p:spTree>
-  </p:cSld>
-  <p:clrMapOvr>
-    <a:masterClrMapping/>
-  </p:clrMapOvr>
-</p:sld>
-</file>
-
-<file path=ppt/slides/slide15.xml><?xml version="1.0" encoding="utf-8"?>
-<p:sld xmlns:a="http://schemas.openxmlformats.org/drawingml/2006/main" xmlns:r="http://schemas.openxmlformats.org/officeDocument/2006/relationships" xmlns:p="http://schemas.openxmlformats.org/presentationml/2006/main">
-  <p:cSld>
-    <p:spTree>
-      <p:nvGrpSpPr>
-        <p:cNvPr id="1" name="Shape 391"/>
-        <p:cNvGrpSpPr/>
-        <p:nvPr/>
-      </p:nvGrpSpPr>
-      <p:grpSpPr>
-        <a:xfrm>
-          <a:off x="0" y="0"/>
-          <a:ext cx="0" cy="0"/>
-          <a:chOff x="0" y="0"/>
-          <a:chExt cx="0" cy="0"/>
-        </a:xfrm>
-      </p:grpSpPr>
-      <p:sp>
-        <p:nvSpPr>
-          <p:cNvPr id="392" name="Google Shape;392;p27"/>
-          <p:cNvSpPr txBox="1">
-            <a:spLocks noGrp="1"/>
-          </p:cNvSpPr>
-          <p:nvPr>
-            <p:ph type="sldNum" idx="12"/>
-          </p:nvPr>
-        </p:nvSpPr>
-        <p:spPr>
-          <a:xfrm>
-            <a:off x="8610600" y="6356350"/>
-            <a:ext cx="2743200" cy="365100"/>
-          </a:xfrm>
-          <a:prstGeom prst="rect">
-            <a:avLst/>
-          </a:prstGeom>
-          <a:noFill/>
-          <a:ln>
-            <a:noFill/>
-          </a:ln>
-        </p:spPr>
-        <p:txBody>
-          <a:bodyPr spcFirstLastPara="1" wrap="square" lIns="91425" tIns="45700" rIns="91425" bIns="45700" anchor="ctr" anchorCtr="0">
-            <a:noAutofit/>
-          </a:bodyPr>
-          <a:lstStyle/>
-          <a:p>
-            <a:pPr marL="0" lvl="0" indent="0" algn="r" rtl="0">
-              <a:spcBef>
-                <a:spcPts val="0"/>
-              </a:spcBef>
-              <a:spcAft>
-                <a:spcPts val="0"/>
-              </a:spcAft>
-              <a:buNone/>
-            </a:pPr>
-            <a:r>
-              <a:rPr sz="1800" b="1">
-                <a:solidFill>
-                  <a:srgbClr val="0F172A"/>
-                </a:solidFill>
-                <a:latin typeface="Times New Roman"/>
-              </a:rPr>
-              <a:t>11</a:t>
-            </a:r>
-            <a:endParaRPr/>
-          </a:p>
-        </p:txBody>
-      </p:sp>
-      <p:pic>
-        <p:nvPicPr>
-          <p:cNvPr id="393" name="Google Shape;393;p27"/>
-          <p:cNvPicPr preferRelativeResize="0"/>
-          <p:nvPr/>
-        </p:nvPicPr>
-        <p:blipFill rotWithShape="1">
-          <a:blip r:embed="rId2">
-            <a:alphaModFix/>
-          </a:blip>
-          <a:srcRect/>
-          <a:stretch/>
-        </p:blipFill>
-        <p:spPr>
-          <a:xfrm>
-            <a:off x="159971" y="211556"/>
-            <a:ext cx="4517529" cy="810838"/>
-          </a:xfrm>
-          <a:prstGeom prst="rect">
-            <a:avLst/>
-          </a:prstGeom>
-          <a:noFill/>
-          <a:ln>
-            <a:noFill/>
-          </a:ln>
-        </p:spPr>
-      </p:pic>
-      <p:pic>
-        <p:nvPicPr>
-          <p:cNvPr id="394" name="Google Shape;394;p27"/>
-          <p:cNvPicPr preferRelativeResize="0"/>
-          <p:nvPr/>
-        </p:nvPicPr>
-        <p:blipFill rotWithShape="1">
-          <a:blip r:embed="rId3">
-            <a:alphaModFix/>
-          </a:blip>
-          <a:srcRect/>
-          <a:stretch/>
-        </p:blipFill>
-        <p:spPr>
-          <a:xfrm>
-            <a:off x="11072819" y="154753"/>
-            <a:ext cx="816174" cy="930568"/>
-          </a:xfrm>
-          <a:prstGeom prst="rect">
-            <a:avLst/>
-          </a:prstGeom>
-          <a:noFill/>
-          <a:ln>
-            <a:noFill/>
-          </a:ln>
-        </p:spPr>
-      </p:pic>
-      <p:sp>
-        <p:nvSpPr>
-          <p:cNvPr id="395" name="Google Shape;395;p27"/>
-          <p:cNvSpPr/>
-          <p:nvPr/>
-        </p:nvSpPr>
-        <p:spPr>
-          <a:xfrm>
-            <a:off x="0" y="6407689"/>
-            <a:ext cx="7684389" cy="461665"/>
-          </a:xfrm>
-          <a:custGeom>
-            <a:avLst/>
-            <a:gdLst/>
-            <a:ahLst/>
-            <a:cxnLst/>
-            <a:rect l="l" t="t" r="r" b="b"/>
-            <a:pathLst>
-              <a:path w="6172200" h="369332" extrusionOk="0">
-                <a:moveTo>
-                  <a:pt x="0" y="0"/>
-                </a:moveTo>
-                <a:lnTo>
-                  <a:pt x="5791200" y="0"/>
-                </a:lnTo>
-                <a:lnTo>
-                  <a:pt x="6172200" y="369332"/>
-                </a:lnTo>
-                <a:lnTo>
-                  <a:pt x="0" y="369332"/>
-                </a:lnTo>
-                <a:lnTo>
-                  <a:pt x="0" y="0"/>
-                </a:lnTo>
-                <a:close/>
-              </a:path>
-            </a:pathLst>
-          </a:custGeom>
-          <a:solidFill>
-            <a:schemeClr val="accent1"/>
-          </a:solidFill>
-          <a:ln>
-            <a:noFill/>
-          </a:ln>
-        </p:spPr>
-        <p:txBody>
-          <a:bodyPr spcFirstLastPara="1" wrap="square" lIns="91425" tIns="45700" rIns="91425" bIns="45700" anchor="t" anchorCtr="0">
-            <a:spAutoFit/>
-          </a:bodyPr>
-          <a:lstStyle/>
-          <a:p>
-            <a:pPr marL="0" marR="0" lvl="0" indent="0" algn="ctr" rtl="0">
-              <a:spcBef>
-                <a:spcPts val="0"/>
-              </a:spcBef>
-              <a:spcAft>
-                <a:spcPts val="0"/>
-              </a:spcAft>
-              <a:buClr>
-                <a:schemeClr val="lt1"/>
-              </a:buClr>
-              <a:buSzPts val="2400"/>
-              <a:buFont typeface="Gill Sans"/>
-              <a:buNone/>
-            </a:pPr>
-            <a:r>
-              <a:rPr lang="en-US" sz="2400">
-                <a:solidFill>
-                  <a:schemeClr val="lt1"/>
-                </a:solidFill>
-                <a:latin typeface="Gill Sans"/>
-                <a:ea typeface="Gill Sans"/>
-                <a:cs typeface="Gill Sans"/>
-                <a:sym typeface="Gill Sans"/>
-              </a:rPr>
-              <a:t>LEARN . GROW . EXCEL</a:t>
-            </a:r>
-            <a:endParaRPr sz="1800">
-              <a:solidFill>
-                <a:schemeClr val="dk1"/>
-              </a:solidFill>
-              <a:latin typeface="Calibri"/>
-              <a:ea typeface="Calibri"/>
-              <a:cs typeface="Calibri"/>
-              <a:sym typeface="Calibri"/>
-            </a:endParaRPr>
-          </a:p>
-        </p:txBody>
-      </p:sp>
-      <p:sp>
-        <p:nvSpPr>
-          <p:cNvPr id="396" name="Google Shape;396;p27"/>
-          <p:cNvSpPr txBox="1">
-            <a:spLocks noGrp="1"/>
-          </p:cNvSpPr>
-          <p:nvPr>
-            <p:ph type="title"/>
-          </p:nvPr>
-        </p:nvSpPr>
-        <p:spPr>
-          <a:xfrm>
-            <a:off x="754224" y="2665957"/>
-            <a:ext cx="10515600" cy="1325700"/>
-          </a:xfrm>
-          <a:prstGeom prst="rect">
-            <a:avLst/>
-          </a:prstGeom>
-          <a:noFill/>
-          <a:ln>
-            <a:noFill/>
-          </a:ln>
-        </p:spPr>
-        <p:txBody>
-          <a:bodyPr spcFirstLastPara="1" wrap="square" lIns="91425" tIns="45700" rIns="91425" bIns="45700" anchor="ctr" anchorCtr="0">
-            <a:normAutofit/>
-          </a:bodyPr>
-          <a:lstStyle/>
-          <a:p>
-            <a:pPr marL="0" lvl="0" indent="0" algn="ctr" rtl="0">
-              <a:lnSpc>
-                <a:spcPct val="90000"/>
-              </a:lnSpc>
-              <a:spcBef>
-                <a:spcPts val="0"/>
-              </a:spcBef>
-              <a:spcAft>
-                <a:spcPts val="0"/>
-              </a:spcAft>
-              <a:buClr>
-                <a:schemeClr val="dk1"/>
-              </a:buClr>
-              <a:buSzPts val="4400"/>
-              <a:buFont typeface="Times New Roman"/>
-              <a:buNone/>
-            </a:pPr>
-            <a:r>
-              <a:rPr sz="5400" b="1">
-                <a:solidFill>
-                  <a:srgbClr val="0F172A"/>
-                </a:solidFill>
-                <a:latin typeface="Times New Roman"/>
-              </a:rPr>
-              <a:t>THANK YOU</a:t>
-            </a:r>
-            <a:endParaRPr i="1">
-              <a:latin typeface="Times New Roman"/>
-              <a:ea typeface="Times New Roman"/>
-              <a:cs typeface="Times New Roman"/>
-              <a:sym typeface="Times New Roman"/>
-            </a:endParaRPr>
-          </a:p>
-        </p:txBody>
-      </p:sp>
-      <p:sp>
-        <p:nvSpPr>
-          <p:cNvPr id="397" name="Questions Subtitle"/>
-          <p:cNvSpPr txBox="1"/>
-          <p:nvPr/>
-        </p:nvSpPr>
-        <p:spPr>
-          <a:xfrm>
-            <a:off x="754224" y="4000000"/>
-            <a:ext cx="10515600" cy="700000"/>
-          </a:xfrm>
-          <a:prstGeom prst="rect">
-            <a:avLst/>
-          </a:prstGeom>
-          <a:noFill/>
-          <a:ln>
-            <a:noFill/>
-          </a:ln>
-        </p:spPr>
-        <p:txBody>
-          <a:bodyPr spcFirstLastPara="1" wrap="square" lIns="91425" tIns="45700" rIns="91425" bIns="45700" anchor="t" anchorCtr="0">
-            <a:normAutofit/>
-          </a:bodyPr>
-          <a:lstStyle/>
-          <a:p>
-            <a:pPr marL="0" lvl="0" indent="0" algn="ctr" rtl="0">
-              <a:spcBef>
-                <a:spcPts val="0"/>
-              </a:spcBef>
-              <a:buNone/>
-            </a:pPr>
-            <a:r>
-              <a:rPr sz="2600" b="1">
-                <a:solidFill>
-                  <a:srgbClr val="0284C7"/>
-                </a:solidFill>
-                <a:latin typeface="Times New Roman"/>
-              </a:rPr>
-              <a:t>Questions &amp; Discussion</a:t>
-            </a:r>
-            <a:endParaRPr sz="2800" dirty="0">
-              <a:latin typeface="Times New Roman"/>
-              <a:ea typeface="Times New Roman"/>
-              <a:cs typeface="Times New Roman"/>
-              <a:sym typeface="Times New Roman"/>
-            </a:endParaRPr>
-          </a:p>
-          <a:p>
-            <a:pPr algn="ctr"/>
-          </a:p>
-          <a:p>
-            <a:pPr algn="ctr"/>
-            <a:r>
-              <a:rPr sz="2000" b="1">
-                <a:solidFill>
-                  <a:srgbClr val="0F172A"/>
-                </a:solidFill>
-                <a:latin typeface="Times New Roman"/>
-              </a:rPr>
-              <a:t>Automated Semiconductor Wafer Defect Inspection System</a:t>
-            </a:r>
-          </a:p>
-          <a:p>
-            <a:pPr algn="ctr"/>
-            <a:r>
-              <a:rPr sz="1600" b="0">
-                <a:solidFill>
-                  <a:srgbClr val="1E293B"/>
-                </a:solidFill>
-                <a:latin typeface="Times New Roman"/>
-              </a:rPr>
-              <a:t>B.Tech Mini Project Final Internal Review • Saintgits College of Engineering (Autonomous)</a:t>
-            </a:r>
-          </a:p>
-          <a:p>
-            <a:pPr algn="ctr"/>
-            <a:r>
-              <a:rPr sz="1600" b="0">
-                <a:solidFill>
-                  <a:srgbClr val="1E293B"/>
-                </a:solidFill>
-                <a:latin typeface="Times New Roman"/>
-              </a:rPr>
-              <a:t>Team: Adithyan B • Anna Boban • Noopa Maria Rojan</a:t>
-            </a:r>
-          </a:p>
-          <a:p>
-            <a:pPr algn="ctr"/>
-            <a:r>
-              <a:rPr sz="1600" b="0">
-                <a:solidFill>
-                  <a:srgbClr val="1E293B"/>
-                </a:solidFill>
-                <a:latin typeface="Times New Roman"/>
-              </a:rPr>
-              <a:t>Supervisor: Er. Justin Mathew, Assistant Professor, Dept. of ECE</a:t>
-            </a:r>
           </a:p>
         </p:txBody>
       </p:sp>
@@ -21371,10 +20184,15 @@
               </a:spcAft>
               <a:buNone/>
             </a:pPr>
-            <a:fld id="{00000000-1234-1234-1234-123412341234}" type="slidenum">
-              <a:rPr lang="en-US"/>
+            <a:r>
+              <a:rPr sz="1800" b="1">
+                <a:solidFill>
+                  <a:srgbClr val="0F172A"/>
+                </a:solidFill>
+                <a:latin typeface="Times New Roman"/>
+              </a:rPr>
               <a:t>8</a:t>
-            </a:fld>
+            </a:r>
             <a:endParaRPr/>
           </a:p>
         </p:txBody>
@@ -21542,34 +20360,13 @@
               <a:buNone/>
             </a:pPr>
             <a:r>
-              <a:rPr lang="en-US" sz="4000" dirty="0">
-                <a:solidFill>
-                  <a:srgbClr val="181C24"/>
-                </a:solidFill>
-                <a:highlight>
-                  <a:srgbClr val="FFFFFF"/>
-                </a:highlight>
+              <a:rPr sz="3400" b="1">
+                <a:solidFill>
+                  <a:srgbClr val="0F172A"/>
+                </a:solidFill>
                 <a:latin typeface="Times New Roman"/>
-                <a:ea typeface="Times New Roman"/>
-                <a:cs typeface="Times New Roman"/>
-                <a:sym typeface="Times New Roman"/>
               </a:rPr>
-              <a:t> </a:t>
-            </a:r>
-            <a:r>
-              <a:rPr lang="en-US" sz="3600" b="1" dirty="0">
-                <a:solidFill>
-                  <a:srgbClr val="181C24"/>
-                </a:solidFill>
-                <a:highlight>
-                  <a:srgbClr val="FFFFFF"/>
-                </a:highlight>
-                <a:latin typeface="Times New Roman"/>
-                <a:ea typeface="Times New Roman"/>
-                <a:cs typeface="Times New Roman"/>
-                <a:sym typeface="Times New Roman"/>
-              </a:rPr>
-              <a:t>NOVELTY OF THE PROJECT</a:t>
+              <a:t>METHODOLOGY &amp; WORKFLOW</a:t>
             </a:r>
             <a:endParaRPr sz="3600" b="1" dirty="0">
               <a:latin typeface="Times New Roman"/>
@@ -21577,6 +20374,665 @@
               <a:cs typeface="Times New Roman"/>
               <a:sym typeface="Times New Roman"/>
             </a:endParaRPr>
+          </a:p>
+        </p:txBody>
+      </p:sp>
+      <p:sp>
+        <p:nvSpPr>
+          <p:cNvPr id="124" name="Google Shape;124;p3"/>
+          <p:cNvSpPr txBox="1">
+            <a:spLocks noGrp="1"/>
+          </p:cNvSpPr>
+          <p:nvPr>
+            <p:ph type="subTitle" idx="1"/>
+          </p:nvPr>
+        </p:nvSpPr>
+        <p:spPr>
+          <a:xfrm>
+            <a:off x="731520" y="1920240"/>
+            <a:ext cx="10698480" cy="4114800"/>
+          </a:xfrm>
+          <a:prstGeom prst="rect">
+            <a:avLst/>
+          </a:prstGeom>
+          <a:noFill/>
+          <a:ln>
+            <a:noFill/>
+          </a:ln>
+        </p:spPr>
+        <p:txBody>
+          <a:bodyPr spcFirstLastPara="1" wrap="square" lIns="91425" tIns="45700" rIns="91425" bIns="45700" anchor="t" anchorCtr="0">
+            <a:normAutofit/>
+          </a:bodyPr>
+          <a:lstStyle/>
+          <a:p>
+            <a:pPr marL="342900" lvl="0" indent="-342900" algn="l">
+              <a:lnSpc>
+                <a:spcPct val="100000"/>
+              </a:lnSpc>
+              <a:spcBef>
+                <a:spcPts val="800"/>
+              </a:spcBef>
+              <a:spcAft>
+                <a:spcPts val="200"/>
+              </a:spcAft>
+              <a:buSzPts val="2600"/>
+              <a:buFont typeface="Noto Sans Symbols"/>
+              <a:buChar char="⮪"/>
+            </a:pPr>
+            <a:r>
+              <a:rPr sz="2200" b="1">
+                <a:solidFill>
+                  <a:srgbClr val="0284C7"/>
+                </a:solidFill>
+                <a:latin typeface="Times New Roman"/>
+              </a:rPr>
+              <a:t>Phase 1: Dataset Curation &amp; Preprocessing</a:t>
+            </a:r>
+          </a:p>
+          <a:p>
+            <a:pPr>
+              <a:spcBef>
+                <a:spcPts val="200"/>
+              </a:spcBef>
+              <a:spcAft>
+                <a:spcPts val="400"/>
+              </a:spcAft>
+            </a:pPr>
+            <a:r>
+              <a:rPr sz="1800" b="0">
+                <a:solidFill>
+                  <a:srgbClr val="1E293B"/>
+                </a:solidFill>
+                <a:latin typeface="Times New Roman"/>
+              </a:rPr>
+              <a:t>•  Extracted wafer maps from the WM-811K benchmark; performed spatial bicubic/nearest resizing to 224x224 and tensor normalization (ImageNet mean &amp; std).</a:t>
+            </a:r>
+          </a:p>
+          <a:p>
+            <a:pPr>
+              <a:spcBef>
+                <a:spcPts val="800"/>
+              </a:spcBef>
+              <a:spcAft>
+                <a:spcPts val="200"/>
+              </a:spcAft>
+            </a:pPr>
+            <a:r>
+              <a:rPr sz="2200" b="1">
+                <a:solidFill>
+                  <a:srgbClr val="0284C7"/>
+                </a:solidFill>
+                <a:latin typeface="Times New Roman"/>
+              </a:rPr>
+              <a:t>Phase 2: Transfer Learning &amp; Model Fine-Tuning</a:t>
+            </a:r>
+          </a:p>
+          <a:p>
+            <a:pPr>
+              <a:spcBef>
+                <a:spcPts val="200"/>
+              </a:spcBef>
+              <a:spcAft>
+                <a:spcPts val="400"/>
+              </a:spcAft>
+            </a:pPr>
+            <a:r>
+              <a:rPr sz="1800" b="0">
+                <a:solidFill>
+                  <a:srgbClr val="1E293B"/>
+                </a:solidFill>
+                <a:latin typeface="Times New Roman"/>
+              </a:rPr>
+              <a:t>•  Utilized pre-trained MobileNetV3-Small backbone with inverted residual bottlenecks and Hard-Swish activations; replaced the classification head with an 8-output linear layer.</a:t>
+            </a:r>
+          </a:p>
+          <a:p>
+            <a:pPr>
+              <a:spcBef>
+                <a:spcPts val="800"/>
+              </a:spcBef>
+              <a:spcAft>
+                <a:spcPts val="200"/>
+              </a:spcAft>
+            </a:pPr>
+            <a:r>
+              <a:rPr sz="2200" b="1">
+                <a:solidFill>
+                  <a:srgbClr val="0284C7"/>
+                </a:solidFill>
+                <a:latin typeface="Times New Roman"/>
+              </a:rPr>
+              <a:t>Phase 3: Training &amp; Regularization Pipeline</a:t>
+            </a:r>
+          </a:p>
+          <a:p>
+            <a:pPr>
+              <a:spcBef>
+                <a:spcPts val="200"/>
+              </a:spcBef>
+              <a:spcAft>
+                <a:spcPts val="400"/>
+              </a:spcAft>
+            </a:pPr>
+            <a:r>
+              <a:rPr sz="1800" b="0">
+                <a:solidFill>
+                  <a:srgbClr val="1E293B"/>
+                </a:solidFill>
+                <a:latin typeface="Times New Roman"/>
+              </a:rPr>
+              <a:t>•  Trained using Adam optimizer, cross-entropy loss, dropout regularization (p=0.2), and early stopping to prevent overfitting on majority classes.</a:t>
+            </a:r>
+          </a:p>
+          <a:p>
+            <a:pPr>
+              <a:spcBef>
+                <a:spcPts val="800"/>
+              </a:spcBef>
+              <a:spcAft>
+                <a:spcPts val="200"/>
+              </a:spcAft>
+            </a:pPr>
+            <a:r>
+              <a:rPr sz="2200" b="1">
+                <a:solidFill>
+                  <a:srgbClr val="0284C7"/>
+                </a:solidFill>
+                <a:latin typeface="Times New Roman"/>
+              </a:rPr>
+              <a:t>Phase 4: ONNX Compilation &amp; Edge Integration</a:t>
+            </a:r>
+          </a:p>
+          <a:p>
+            <a:pPr>
+              <a:spcBef>
+                <a:spcPts val="200"/>
+              </a:spcBef>
+              <a:spcAft>
+                <a:spcPts val="400"/>
+              </a:spcAft>
+            </a:pPr>
+            <a:r>
+              <a:rPr sz="1800" b="0">
+                <a:solidFill>
+                  <a:srgbClr val="1E293B"/>
+                </a:solidFill>
+                <a:latin typeface="Times New Roman"/>
+              </a:rPr>
+              <a:t>•  Exported PyTorch computational graph to ONNX with CPU graph optimizations; integrated into a high-concurrency Python REST server and interactive web visualizer.</a:t>
+            </a:r>
+          </a:p>
+        </p:txBody>
+      </p:sp>
+      <p:pic>
+        <p:nvPicPr>
+          <p:cNvPr id="125" name="Google Shape;125;p3"/>
+          <p:cNvPicPr preferRelativeResize="0"/>
+          <p:nvPr/>
+        </p:nvPicPr>
+        <p:blipFill rotWithShape="1">
+          <a:blip r:embed="rId3">
+            <a:alphaModFix/>
+          </a:blip>
+          <a:srcRect l="15320" t="28789" r="16466" b="54857"/>
+          <a:stretch/>
+        </p:blipFill>
+        <p:spPr>
+          <a:xfrm>
+            <a:off x="155527" y="217182"/>
+            <a:ext cx="4521325" cy="812948"/>
+          </a:xfrm>
+          <a:prstGeom prst="rect">
+            <a:avLst/>
+          </a:prstGeom>
+          <a:noFill/>
+          <a:ln>
+            <a:noFill/>
+          </a:ln>
+        </p:spPr>
+      </p:pic>
+    </p:spTree>
+  </p:cSld>
+  <p:clrMapOvr>
+    <a:masterClrMapping/>
+  </p:clrMapOvr>
+</p:sld>
+</file>
+
+<file path=ppt/slides/slide8.xml><?xml version="1.0" encoding="utf-8"?>
+<p:sld xmlns:a="http://schemas.openxmlformats.org/drawingml/2006/main" xmlns:r="http://schemas.openxmlformats.org/officeDocument/2006/relationships" xmlns:p="http://schemas.openxmlformats.org/presentationml/2006/main">
+  <p:cSld>
+    <p:spTree>
+      <p:nvGrpSpPr>
+        <p:cNvPr id="1" name="Shape 119"/>
+        <p:cNvGrpSpPr/>
+        <p:nvPr/>
+      </p:nvGrpSpPr>
+      <p:grpSpPr>
+        <a:xfrm>
+          <a:off x="0" y="0"/>
+          <a:ext cx="0" cy="0"/>
+          <a:chOff x="0" y="0"/>
+          <a:chExt cx="0" cy="0"/>
+        </a:xfrm>
+      </p:grpSpPr>
+      <p:sp>
+        <p:nvSpPr>
+          <p:cNvPr id="120" name="Google Shape;120;p3"/>
+          <p:cNvSpPr txBox="1">
+            <a:spLocks noGrp="1"/>
+          </p:cNvSpPr>
+          <p:nvPr>
+            <p:ph type="sldNum" idx="12"/>
+          </p:nvPr>
+        </p:nvSpPr>
+        <p:spPr>
+          <a:xfrm>
+            <a:off x="8610600" y="6356350"/>
+            <a:ext cx="2743200" cy="365100"/>
+          </a:xfrm>
+          <a:prstGeom prst="rect">
+            <a:avLst/>
+          </a:prstGeom>
+          <a:noFill/>
+          <a:ln>
+            <a:noFill/>
+          </a:ln>
+        </p:spPr>
+        <p:txBody>
+          <a:bodyPr spcFirstLastPara="1" wrap="square" lIns="91425" tIns="45700" rIns="91425" bIns="45700" anchor="ctr" anchorCtr="0">
+            <a:noAutofit/>
+          </a:bodyPr>
+          <a:lstStyle/>
+          <a:p>
+            <a:pPr marL="0" lvl="0" indent="0" algn="r" rtl="0">
+              <a:spcBef>
+                <a:spcPts val="0"/>
+              </a:spcBef>
+              <a:spcAft>
+                <a:spcPts val="0"/>
+              </a:spcAft>
+              <a:buNone/>
+            </a:pPr>
+            <a:r>
+              <a:rPr sz="1800" b="1">
+                <a:solidFill>
+                  <a:srgbClr val="0F172A"/>
+                </a:solidFill>
+                <a:latin typeface="Times New Roman"/>
+              </a:rPr>
+              <a:t>8</a:t>
+            </a:r>
+            <a:endParaRPr/>
+          </a:p>
+        </p:txBody>
+      </p:sp>
+      <p:pic>
+        <p:nvPicPr>
+          <p:cNvPr id="121" name="Google Shape;121;p3"/>
+          <p:cNvPicPr preferRelativeResize="0"/>
+          <p:nvPr/>
+        </p:nvPicPr>
+        <p:blipFill rotWithShape="1">
+          <a:blip r:embed="rId2">
+            <a:alphaModFix/>
+          </a:blip>
+          <a:srcRect/>
+          <a:stretch/>
+        </p:blipFill>
+        <p:spPr>
+          <a:xfrm>
+            <a:off x="11072819" y="154753"/>
+            <a:ext cx="816174" cy="930568"/>
+          </a:xfrm>
+          <a:prstGeom prst="rect">
+            <a:avLst/>
+          </a:prstGeom>
+          <a:noFill/>
+          <a:ln>
+            <a:noFill/>
+          </a:ln>
+        </p:spPr>
+      </p:pic>
+      <p:sp>
+        <p:nvSpPr>
+          <p:cNvPr id="122" name="Google Shape;122;p3"/>
+          <p:cNvSpPr/>
+          <p:nvPr/>
+        </p:nvSpPr>
+        <p:spPr>
+          <a:xfrm>
+            <a:off x="0" y="6407689"/>
+            <a:ext cx="7684389" cy="461665"/>
+          </a:xfrm>
+          <a:custGeom>
+            <a:avLst/>
+            <a:gdLst/>
+            <a:ahLst/>
+            <a:cxnLst/>
+            <a:rect l="l" t="t" r="r" b="b"/>
+            <a:pathLst>
+              <a:path w="6172200" h="369332" extrusionOk="0">
+                <a:moveTo>
+                  <a:pt x="0" y="0"/>
+                </a:moveTo>
+                <a:lnTo>
+                  <a:pt x="5791200" y="0"/>
+                </a:lnTo>
+                <a:lnTo>
+                  <a:pt x="6172200" y="369332"/>
+                </a:lnTo>
+                <a:lnTo>
+                  <a:pt x="0" y="369332"/>
+                </a:lnTo>
+                <a:lnTo>
+                  <a:pt x="0" y="0"/>
+                </a:lnTo>
+                <a:close/>
+              </a:path>
+            </a:pathLst>
+          </a:custGeom>
+          <a:solidFill>
+            <a:schemeClr val="accent1"/>
+          </a:solidFill>
+          <a:ln>
+            <a:noFill/>
+          </a:ln>
+        </p:spPr>
+        <p:txBody>
+          <a:bodyPr spcFirstLastPara="1" wrap="square" lIns="91425" tIns="45700" rIns="91425" bIns="45700" anchor="t" anchorCtr="0">
+            <a:spAutoFit/>
+          </a:bodyPr>
+          <a:lstStyle/>
+          <a:p>
+            <a:pPr marL="0" marR="0" lvl="0" indent="0" algn="ctr" rtl="0">
+              <a:spcBef>
+                <a:spcPts val="0"/>
+              </a:spcBef>
+              <a:spcAft>
+                <a:spcPts val="0"/>
+              </a:spcAft>
+              <a:buClr>
+                <a:schemeClr val="lt1"/>
+              </a:buClr>
+              <a:buSzPts val="2400"/>
+              <a:buFont typeface="Gill Sans"/>
+              <a:buNone/>
+            </a:pPr>
+            <a:r>
+              <a:rPr lang="en-US" sz="2400">
+                <a:solidFill>
+                  <a:schemeClr val="lt1"/>
+                </a:solidFill>
+                <a:latin typeface="Gill Sans"/>
+                <a:ea typeface="Gill Sans"/>
+                <a:cs typeface="Gill Sans"/>
+                <a:sym typeface="Gill Sans"/>
+              </a:rPr>
+              <a:t>LEARN . GROW . EXCEL</a:t>
+            </a:r>
+            <a:endParaRPr sz="1800">
+              <a:solidFill>
+                <a:schemeClr val="dk1"/>
+              </a:solidFill>
+              <a:latin typeface="Calibri"/>
+              <a:ea typeface="Calibri"/>
+              <a:cs typeface="Calibri"/>
+              <a:sym typeface="Calibri"/>
+            </a:endParaRPr>
+          </a:p>
+        </p:txBody>
+      </p:sp>
+      <p:sp>
+        <p:nvSpPr>
+          <p:cNvPr id="123" name="Google Shape;123;p3"/>
+          <p:cNvSpPr txBox="1">
+            <a:spLocks noGrp="1"/>
+          </p:cNvSpPr>
+          <p:nvPr>
+            <p:ph type="ctrTitle"/>
+          </p:nvPr>
+        </p:nvSpPr>
+        <p:spPr>
+          <a:xfrm>
+            <a:off x="459967" y="1100168"/>
+            <a:ext cx="9625800" cy="761400"/>
+          </a:xfrm>
+          <a:prstGeom prst="rect">
+            <a:avLst/>
+          </a:prstGeom>
+          <a:noFill/>
+          <a:ln>
+            <a:noFill/>
+          </a:ln>
+        </p:spPr>
+        <p:txBody>
+          <a:bodyPr spcFirstLastPara="1" wrap="square" lIns="91425" tIns="45700" rIns="91425" bIns="45700" anchor="b" anchorCtr="0">
+            <a:normAutofit/>
+          </a:bodyPr>
+          <a:lstStyle/>
+          <a:p>
+            <a:pPr marL="0" lvl="0" indent="0" algn="l" rtl="0">
+              <a:lnSpc>
+                <a:spcPct val="90000"/>
+              </a:lnSpc>
+              <a:spcBef>
+                <a:spcPts val="0"/>
+              </a:spcBef>
+              <a:spcAft>
+                <a:spcPts val="0"/>
+              </a:spcAft>
+              <a:buClr>
+                <a:srgbClr val="181C24"/>
+              </a:buClr>
+              <a:buSzPts val="4000"/>
+              <a:buFont typeface="Times New Roman"/>
+              <a:buNone/>
+            </a:pPr>
+            <a:r>
+              <a:rPr sz="3400" b="1">
+                <a:solidFill>
+                  <a:srgbClr val="0F172A"/>
+                </a:solidFill>
+                <a:latin typeface="Times New Roman"/>
+              </a:rPr>
+              <a:t>METHODOLOGY &amp; WORKFLOW</a:t>
+            </a:r>
+            <a:endParaRPr sz="3600" b="1" dirty="0">
+              <a:latin typeface="Times New Roman"/>
+              <a:ea typeface="Times New Roman"/>
+              <a:cs typeface="Times New Roman"/>
+              <a:sym typeface="Times New Roman"/>
+            </a:endParaRPr>
+          </a:p>
+        </p:txBody>
+      </p:sp>
+      <p:sp>
+        <p:nvSpPr>
+          <p:cNvPr id="124" name="Google Shape;124;p3"/>
+          <p:cNvSpPr txBox="1">
+            <a:spLocks noGrp="1"/>
+          </p:cNvSpPr>
+          <p:nvPr>
+            <p:ph type="subTitle" idx="1"/>
+          </p:nvPr>
+        </p:nvSpPr>
+        <p:spPr>
+          <a:xfrm>
+            <a:off x="731520" y="1920240"/>
+            <a:ext cx="10698480" cy="4114800"/>
+          </a:xfrm>
+          <a:prstGeom prst="rect">
+            <a:avLst/>
+          </a:prstGeom>
+          <a:noFill/>
+          <a:ln>
+            <a:noFill/>
+          </a:ln>
+        </p:spPr>
+        <p:txBody>
+          <a:bodyPr spcFirstLastPara="1" wrap="square" lIns="91425" tIns="45700" rIns="91425" bIns="45700" anchor="t" anchorCtr="0">
+            <a:normAutofit/>
+          </a:bodyPr>
+          <a:lstStyle/>
+          <a:p>
+            <a:pPr marL="342900" lvl="0" indent="-342900" algn="l">
+              <a:lnSpc>
+                <a:spcPct val="100000"/>
+              </a:lnSpc>
+              <a:spcBef>
+                <a:spcPts val="800"/>
+              </a:spcBef>
+              <a:spcAft>
+                <a:spcPts val="200"/>
+              </a:spcAft>
+              <a:buSzPts val="2600"/>
+              <a:buFont typeface="Noto Sans Symbols"/>
+              <a:buChar char="⮪"/>
+            </a:pPr>
+            <a:r>
+              <a:rPr sz="2200" b="1">
+                <a:solidFill>
+                  <a:srgbClr val="0284C7"/>
+                </a:solidFill>
+                <a:latin typeface="Times New Roman"/>
+              </a:rPr>
+              <a:t>Phase 1: Dataset Curation &amp; Preprocessing</a:t>
+            </a:r>
+          </a:p>
+          <a:p>
+            <a:pPr>
+              <a:spcBef>
+                <a:spcPts val="200"/>
+              </a:spcBef>
+              <a:spcAft>
+                <a:spcPts val="400"/>
+              </a:spcAft>
+            </a:pPr>
+            <a:r>
+              <a:rPr sz="1800" b="0">
+                <a:solidFill>
+                  <a:srgbClr val="1E293B"/>
+                </a:solidFill>
+                <a:latin typeface="Times New Roman"/>
+              </a:rPr>
+              <a:t>•  Extracted wafer maps from the WM-811K benchmark; performed spatial bicubic/nearest resizing to 224x224 and tensor normalization (ImageNet mean &amp; std).</a:t>
+            </a:r>
+          </a:p>
+          <a:p>
+            <a:pPr>
+              <a:spcBef>
+                <a:spcPts val="800"/>
+              </a:spcBef>
+              <a:spcAft>
+                <a:spcPts val="200"/>
+              </a:spcAft>
+            </a:pPr>
+            <a:r>
+              <a:rPr sz="2200" b="1">
+                <a:solidFill>
+                  <a:srgbClr val="0284C7"/>
+                </a:solidFill>
+                <a:latin typeface="Times New Roman"/>
+              </a:rPr>
+              <a:t>Phase 2: Transfer Learning &amp; Model Fine-Tuning</a:t>
+            </a:r>
+          </a:p>
+          <a:p>
+            <a:pPr>
+              <a:spcBef>
+                <a:spcPts val="200"/>
+              </a:spcBef>
+              <a:spcAft>
+                <a:spcPts val="400"/>
+              </a:spcAft>
+            </a:pPr>
+            <a:r>
+              <a:rPr sz="1800" b="0">
+                <a:solidFill>
+                  <a:srgbClr val="1E293B"/>
+                </a:solidFill>
+                <a:latin typeface="Times New Roman"/>
+              </a:rPr>
+              <a:t>•  Utilized pre-trained MobileNetV3-Small backbone with inverted residual bottlenecks and Hard-Swish activations; replaced the classification head with an 8-output linear layer.</a:t>
+            </a:r>
+          </a:p>
+          <a:p>
+            <a:pPr>
+              <a:spcBef>
+                <a:spcPts val="800"/>
+              </a:spcBef>
+              <a:spcAft>
+                <a:spcPts val="200"/>
+              </a:spcAft>
+            </a:pPr>
+            <a:r>
+              <a:rPr sz="2200" b="1">
+                <a:solidFill>
+                  <a:srgbClr val="0284C7"/>
+                </a:solidFill>
+                <a:latin typeface="Times New Roman"/>
+              </a:rPr>
+              <a:t>Phase 3: Training &amp; Regularization Pipeline</a:t>
+            </a:r>
+          </a:p>
+          <a:p>
+            <a:pPr>
+              <a:spcBef>
+                <a:spcPts val="200"/>
+              </a:spcBef>
+              <a:spcAft>
+                <a:spcPts val="400"/>
+              </a:spcAft>
+            </a:pPr>
+            <a:r>
+              <a:rPr sz="1800" b="0">
+                <a:solidFill>
+                  <a:srgbClr val="1E293B"/>
+                </a:solidFill>
+                <a:latin typeface="Times New Roman"/>
+              </a:rPr>
+              <a:t>•  Trained using Adam optimizer, cross-entropy loss, dropout regularization (p=0.2), and early stopping to prevent overfitting on majority classes.</a:t>
+            </a:r>
+          </a:p>
+          <a:p>
+            <a:pPr>
+              <a:spcBef>
+                <a:spcPts val="800"/>
+              </a:spcBef>
+              <a:spcAft>
+                <a:spcPts val="200"/>
+              </a:spcAft>
+            </a:pPr>
+            <a:r>
+              <a:rPr sz="2200" b="1">
+                <a:solidFill>
+                  <a:srgbClr val="0284C7"/>
+                </a:solidFill>
+                <a:latin typeface="Times New Roman"/>
+              </a:rPr>
+              <a:t>Phase 4: ONNX Compilation &amp; Edge Integration</a:t>
+            </a:r>
+          </a:p>
+          <a:p>
+            <a:pPr>
+              <a:spcBef>
+                <a:spcPts val="200"/>
+              </a:spcBef>
+              <a:spcAft>
+                <a:spcPts val="400"/>
+              </a:spcAft>
+            </a:pPr>
+            <a:r>
+              <a:rPr sz="1800" b="0">
+                <a:solidFill>
+                  <a:srgbClr val="1E293B"/>
+                </a:solidFill>
+                <a:latin typeface="Times New Roman"/>
+              </a:rPr>
+              <a:t>•  Exported PyTorch computational graph to ONNX with CPU graph optimizations; integrated into a high-concurrency Python REST server and interactive web visualizer.</a:t>
+            </a:r>
           </a:p>
         </p:txBody>
       </p:sp>
@@ -21670,10 +21126,15 @@
               </a:spcAft>
               <a:buNone/>
             </a:pPr>
-            <a:fld id="{00000000-1234-1234-1234-123412341234}" type="slidenum">
-              <a:rPr lang="en-US"/>
+            <a:r>
+              <a:rPr sz="1800" b="1">
+                <a:solidFill>
+                  <a:srgbClr val="0F172A"/>
+                </a:solidFill>
+                <a:latin typeface="Times New Roman"/>
+              </a:rPr>
               <a:t>9</a:t>
-            </a:fld>
+            </a:r>
             <a:endParaRPr/>
           </a:p>
         </p:txBody>
@@ -21841,34 +21302,13 @@
               <a:buNone/>
             </a:pPr>
             <a:r>
-              <a:rPr lang="en-US" sz="4000" dirty="0">
-                <a:solidFill>
-                  <a:srgbClr val="181C24"/>
-                </a:solidFill>
-                <a:highlight>
-                  <a:srgbClr val="FFFFFF"/>
-                </a:highlight>
+              <a:rPr sz="3400" b="1">
+                <a:solidFill>
+                  <a:srgbClr val="0F172A"/>
+                </a:solidFill>
                 <a:latin typeface="Times New Roman"/>
-                <a:ea typeface="Times New Roman"/>
-                <a:cs typeface="Times New Roman"/>
-                <a:sym typeface="Times New Roman"/>
               </a:rPr>
-              <a:t> </a:t>
-            </a:r>
-            <a:r>
-              <a:rPr lang="en-US" sz="3600" b="1" dirty="0">
-                <a:solidFill>
-                  <a:srgbClr val="181C24"/>
-                </a:solidFill>
-                <a:highlight>
-                  <a:srgbClr val="FFFFFF"/>
-                </a:highlight>
-                <a:latin typeface="Times New Roman"/>
-                <a:ea typeface="Times New Roman"/>
-                <a:cs typeface="Times New Roman"/>
-                <a:sym typeface="Times New Roman"/>
-              </a:rPr>
-              <a:t>SCOPE</a:t>
+              <a:t>EXPERIMENTAL RESULTS &amp; OUTCOMES</a:t>
             </a:r>
             <a:endParaRPr sz="3600" b="1" dirty="0">
               <a:latin typeface="Times New Roman"/>
@@ -21891,8 +21331,8 @@
         </p:nvSpPr>
         <p:spPr>
           <a:xfrm>
-            <a:off x="459967" y="2055887"/>
-            <a:ext cx="11128800" cy="4351800"/>
+            <a:off x="731520" y="1828800"/>
+            <a:ext cx="6217920" cy="4114800"/>
           </a:xfrm>
           <a:prstGeom prst="rect">
             <a:avLst/>
@@ -21913,72 +21353,213 @@
                 <a:spcPct val="100000"/>
               </a:lnSpc>
               <a:spcBef>
-                <a:spcPts val="1200"/>
-              </a:spcBef>
+                <a:spcPts val="600"/>
+              </a:spcBef>
+              <a:spcAft>
+                <a:spcPts val="200"/>
+              </a:spcAft>
               <a:buSzPts val="2600"/>
               <a:buFont typeface="Noto Sans Symbols"/>
               <a:buChar char="⮪"/>
             </a:pPr>
             <a:r>
-              <a:rPr lang="en-US" sz="2800" b="1" dirty="0">
-                <a:latin typeface="Times New Roman" panose="02020603050405020304" pitchFamily="18" charset="0"/>
-                <a:cs typeface="Times New Roman" panose="02020603050405020304" pitchFamily="18" charset="0"/>
+              <a:rPr sz="2000" b="1">
+                <a:solidFill>
+                  <a:srgbClr val="0284C7"/>
+                </a:solidFill>
+                <a:latin typeface="Times New Roman"/>
               </a:rPr>
-              <a:t>Current Scope</a:t>
+              <a:t>Key Performance Metrics</a:t>
             </a:r>
           </a:p>
           <a:p>
-            <a:pPr marL="1054100" lvl="1" indent="-457200" algn="l">
-              <a:spcBef>
-                <a:spcPts val="1200"/>
-              </a:spcBef>
-              <a:buSzPts val="2200"/>
-              <a:buFont typeface="Arial" panose="020B0604020202020204" pitchFamily="34" charset="0"/>
-              <a:buChar char="•"/>
+            <a:pPr>
+              <a:spcBef>
+                <a:spcPts val="200"/>
+              </a:spcBef>
+              <a:spcAft>
+                <a:spcPts val="300"/>
+              </a:spcAft>
             </a:pPr>
             <a:r>
-              <a:rPr lang="en-US" sz="2400" dirty="0">
-                <a:latin typeface="Times New Roman" panose="02020603050405020304" pitchFamily="18" charset="0"/>
-                <a:cs typeface="Times New Roman" panose="02020603050405020304" pitchFamily="18" charset="0"/>
+              <a:rPr sz="1500" b="0">
+                <a:solidFill>
+                  <a:srgbClr val="1E293B"/>
+                </a:solidFill>
+                <a:latin typeface="Times New Roman"/>
               </a:rPr>
-              <a:t>Supports secure online examinations with authenticated access, encrypted storage and blockchain-based audit trails for a single institution.</a:t>
+              <a:t>•  Overall Test Set Accuracy: 98.02% across 121,719 test wafer samples.</a:t>
             </a:r>
           </a:p>
           <a:p>
-            <a:pPr marL="342900" lvl="0" indent="-342900" algn="l">
-              <a:lnSpc>
-                <a:spcPct val="100000"/>
-              </a:lnSpc>
-              <a:spcBef>
-                <a:spcPts val="1200"/>
-              </a:spcBef>
-              <a:buSzPts val="2600"/>
-              <a:buFont typeface="Noto Sans Symbols"/>
-              <a:buChar char="⮪"/>
+            <a:pPr>
+              <a:spcBef>
+                <a:spcPts val="200"/>
+              </a:spcBef>
+              <a:spcAft>
+                <a:spcPts val="300"/>
+              </a:spcAft>
             </a:pPr>
             <a:r>
-              <a:rPr lang="en-US" sz="2800" b="1" dirty="0">
-                <a:latin typeface="Times New Roman" panose="02020603050405020304" pitchFamily="18" charset="0"/>
-                <a:cs typeface="Times New Roman" panose="02020603050405020304" pitchFamily="18" charset="0"/>
+              <a:rPr sz="1500" b="0">
+                <a:solidFill>
+                  <a:srgbClr val="1E293B"/>
+                </a:solidFill>
+                <a:latin typeface="Times New Roman"/>
               </a:rPr>
-              <a:t>Future Enhancements</a:t>
+              <a:t>•  Macro Precision: 0.6897  |  Macro Recall: 0.6177</a:t>
             </a:r>
           </a:p>
           <a:p>
-            <a:pPr marL="1054100" lvl="1" indent="-457200" algn="l">
-              <a:spcBef>
-                <a:spcPts val="1200"/>
-              </a:spcBef>
-              <a:buSzPts val="2200"/>
-              <a:buFont typeface="Arial" panose="020B0604020202020204" pitchFamily="34" charset="0"/>
-              <a:buChar char="•"/>
+            <a:pPr>
+              <a:spcBef>
+                <a:spcPts val="200"/>
+              </a:spcBef>
+              <a:spcAft>
+                <a:spcPts val="300"/>
+              </a:spcAft>
             </a:pPr>
             <a:r>
-              <a:rPr lang="en-US" sz="2400" dirty="0">
-                <a:latin typeface="Times New Roman" panose="02020603050405020304" pitchFamily="18" charset="0"/>
-                <a:cs typeface="Times New Roman" panose="02020603050405020304" pitchFamily="18" charset="0"/>
+              <a:rPr sz="1500" b="0">
+                <a:solidFill>
+                  <a:srgbClr val="1E293B"/>
+                </a:solidFill>
+                <a:latin typeface="Times New Roman"/>
               </a:rPr>
-              <a:t>AI-based proctoring, multi-institution federation, mobile app support and advanced analytics dashboards.</a:t>
+              <a:t>•  Inference Latency: 1.53 ms on standard CPU (zero GPU requirement).</a:t>
+            </a:r>
+          </a:p>
+          <a:p>
+            <a:pPr>
+              <a:spcBef>
+                <a:spcPts val="200"/>
+              </a:spcBef>
+              <a:spcAft>
+                <a:spcPts val="300"/>
+              </a:spcAft>
+            </a:pPr>
+            <a:r>
+              <a:rPr sz="1500" b="0">
+                <a:solidFill>
+                  <a:srgbClr val="1E293B"/>
+                </a:solidFill>
+                <a:latin typeface="Times New Roman"/>
+              </a:rPr>
+              <a:t>•  Model Binary Footprint: 5.84 MB (ultra-compact ONNX engine).</a:t>
+            </a:r>
+          </a:p>
+          <a:p>
+            <a:pPr>
+              <a:spcBef>
+                <a:spcPts val="600"/>
+              </a:spcBef>
+              <a:spcAft>
+                <a:spcPts val="200"/>
+              </a:spcAft>
+            </a:pPr>
+            <a:r>
+              <a:rPr sz="2000" b="1">
+                <a:solidFill>
+                  <a:srgbClr val="0284C7"/>
+                </a:solidFill>
+                <a:latin typeface="Times New Roman"/>
+              </a:rPr>
+              <a:t>Per-Class Defect Verification Highlights</a:t>
+            </a:r>
+          </a:p>
+          <a:p>
+            <a:pPr>
+              <a:spcBef>
+                <a:spcPts val="200"/>
+              </a:spcBef>
+              <a:spcAft>
+                <a:spcPts val="300"/>
+              </a:spcAft>
+            </a:pPr>
+            <a:r>
+              <a:rPr sz="1500" b="0">
+                <a:solidFill>
+                  <a:srgbClr val="1E293B"/>
+                </a:solidFill>
+                <a:latin typeface="Times New Roman"/>
+              </a:rPr>
+              <a:t>•  Clean (Nominal): 99.98% Precision, 100% Detection Rate (Near-zero false alarms).</a:t>
+            </a:r>
+          </a:p>
+          <a:p>
+            <a:pPr>
+              <a:spcBef>
+                <a:spcPts val="200"/>
+              </a:spcBef>
+              <a:spcAft>
+                <a:spcPts val="300"/>
+              </a:spcAft>
+            </a:pPr>
+            <a:r>
+              <a:rPr sz="1500" b="0">
+                <a:solidFill>
+                  <a:srgbClr val="1E293B"/>
+                </a:solidFill>
+                <a:latin typeface="Times New Roman"/>
+              </a:rPr>
+              <a:t>•  Scratch: 99.92% Confidence with clear linear scratch isolation.</a:t>
+            </a:r>
+          </a:p>
+          <a:p>
+            <a:pPr>
+              <a:spcBef>
+                <a:spcPts val="200"/>
+              </a:spcBef>
+              <a:spcAft>
+                <a:spcPts val="300"/>
+              </a:spcAft>
+            </a:pPr>
+            <a:r>
+              <a:rPr sz="1500" b="0">
+                <a:solidFill>
+                  <a:srgbClr val="1E293B"/>
+                </a:solidFill>
+                <a:latin typeface="Times New Roman"/>
+              </a:rPr>
+              <a:t>•  Donut: 99.99% Confidence detecting radial thermal ring defects.</a:t>
+            </a:r>
+          </a:p>
+          <a:p>
+            <a:pPr>
+              <a:spcBef>
+                <a:spcPts val="200"/>
+              </a:spcBef>
+              <a:spcAft>
+                <a:spcPts val="300"/>
+              </a:spcAft>
+            </a:pPr>
+            <a:r>
+              <a:rPr sz="1500" b="0">
+                <a:solidFill>
+                  <a:srgbClr val="1E293B"/>
+                </a:solidFill>
+                <a:latin typeface="Times New Roman"/>
+              </a:rPr>
+              <a:t>•  Center Cluster: 98.01% Confidence detecting CMP slurry anomalies.</a:t>
+            </a:r>
+          </a:p>
+          <a:p>
+            <a:pPr>
+              <a:spcBef>
+                <a:spcPts val="200"/>
+              </a:spcBef>
+              <a:spcAft>
+                <a:spcPts val="300"/>
+              </a:spcAft>
+            </a:pPr>
+            <a:r>
+              <a:rPr sz="1500" b="0">
+                <a:solidFill>
+                  <a:srgbClr val="1E293B"/>
+                </a:solidFill>
+                <a:latin typeface="Times New Roman"/>
+              </a:rPr>
+              <a:t>•  Edge-Loc &amp; Loc: &gt;99.2% Confidence identifying localized clusters.</a:t>
             </a:r>
           </a:p>
         </p:txBody>
@@ -22008,6 +21589,582 @@
           <a:ln>
             <a:noFill/>
           </a:ln>
+        </p:spPr>
+      </p:pic>
+      <p:pic>
+        <p:nvPicPr>
+          <p:cNvPr id="126" name="Picture 125" descr="confusion_matrix.png"/>
+          <p:cNvPicPr>
+            <a:picLocks noChangeAspect="1"/>
+          </p:cNvPicPr>
+          <p:nvPr/>
+        </p:nvPicPr>
+        <p:blipFill>
+          <a:blip r:embed="rId4"/>
+          <a:stretch>
+            <a:fillRect/>
+          </a:stretch>
+        </p:blipFill>
+        <p:spPr>
+          <a:xfrm>
+            <a:off x="7132320" y="1920240"/>
+            <a:ext cx="4206240" cy="3840480"/>
+          </a:xfrm>
+          <a:prstGeom prst="rect">
+            <a:avLst/>
+          </a:prstGeom>
+        </p:spPr>
+      </p:pic>
+    </p:spTree>
+  </p:cSld>
+  <p:clrMapOvr>
+    <a:masterClrMapping/>
+  </p:clrMapOvr>
+</p:sld>
+</file>
+
+<file path=ppt/slides/slide9.xml><?xml version="1.0" encoding="utf-8"?>
+<p:sld xmlns:a="http://schemas.openxmlformats.org/drawingml/2006/main" xmlns:r="http://schemas.openxmlformats.org/officeDocument/2006/relationships" xmlns:p="http://schemas.openxmlformats.org/presentationml/2006/main">
+  <p:cSld>
+    <p:spTree>
+      <p:nvGrpSpPr>
+        <p:cNvPr id="1" name="Shape 119"/>
+        <p:cNvGrpSpPr/>
+        <p:nvPr/>
+      </p:nvGrpSpPr>
+      <p:grpSpPr>
+        <a:xfrm>
+          <a:off x="0" y="0"/>
+          <a:ext cx="0" cy="0"/>
+          <a:chOff x="0" y="0"/>
+          <a:chExt cx="0" cy="0"/>
+        </a:xfrm>
+      </p:grpSpPr>
+      <p:sp>
+        <p:nvSpPr>
+          <p:cNvPr id="120" name="Google Shape;120;p3"/>
+          <p:cNvSpPr txBox="1">
+            <a:spLocks noGrp="1"/>
+          </p:cNvSpPr>
+          <p:nvPr>
+            <p:ph type="sldNum" idx="12"/>
+          </p:nvPr>
+        </p:nvSpPr>
+        <p:spPr>
+          <a:xfrm>
+            <a:off x="8610600" y="6356350"/>
+            <a:ext cx="2743200" cy="365100"/>
+          </a:xfrm>
+          <a:prstGeom prst="rect">
+            <a:avLst/>
+          </a:prstGeom>
+          <a:noFill/>
+          <a:ln>
+            <a:noFill/>
+          </a:ln>
+        </p:spPr>
+        <p:txBody>
+          <a:bodyPr spcFirstLastPara="1" wrap="square" lIns="91425" tIns="45700" rIns="91425" bIns="45700" anchor="ctr" anchorCtr="0">
+            <a:noAutofit/>
+          </a:bodyPr>
+          <a:lstStyle/>
+          <a:p>
+            <a:pPr marL="0" lvl="0" indent="0" algn="r" rtl="0">
+              <a:spcBef>
+                <a:spcPts val="0"/>
+              </a:spcBef>
+              <a:spcAft>
+                <a:spcPts val="0"/>
+              </a:spcAft>
+              <a:buNone/>
+            </a:pPr>
+            <a:r>
+              <a:rPr sz="1800" b="1">
+                <a:solidFill>
+                  <a:srgbClr val="0F172A"/>
+                </a:solidFill>
+                <a:latin typeface="Times New Roman"/>
+              </a:rPr>
+              <a:t>9</a:t>
+            </a:r>
+            <a:endParaRPr/>
+          </a:p>
+        </p:txBody>
+      </p:sp>
+      <p:pic>
+        <p:nvPicPr>
+          <p:cNvPr id="121" name="Google Shape;121;p3"/>
+          <p:cNvPicPr preferRelativeResize="0"/>
+          <p:nvPr/>
+        </p:nvPicPr>
+        <p:blipFill rotWithShape="1">
+          <a:blip r:embed="rId2">
+            <a:alphaModFix/>
+          </a:blip>
+          <a:srcRect/>
+          <a:stretch/>
+        </p:blipFill>
+        <p:spPr>
+          <a:xfrm>
+            <a:off x="11072819" y="154753"/>
+            <a:ext cx="816174" cy="930568"/>
+          </a:xfrm>
+          <a:prstGeom prst="rect">
+            <a:avLst/>
+          </a:prstGeom>
+          <a:noFill/>
+          <a:ln>
+            <a:noFill/>
+          </a:ln>
+        </p:spPr>
+      </p:pic>
+      <p:sp>
+        <p:nvSpPr>
+          <p:cNvPr id="122" name="Google Shape;122;p3"/>
+          <p:cNvSpPr/>
+          <p:nvPr/>
+        </p:nvSpPr>
+        <p:spPr>
+          <a:xfrm>
+            <a:off x="0" y="6407689"/>
+            <a:ext cx="7684389" cy="461665"/>
+          </a:xfrm>
+          <a:custGeom>
+            <a:avLst/>
+            <a:gdLst/>
+            <a:ahLst/>
+            <a:cxnLst/>
+            <a:rect l="l" t="t" r="r" b="b"/>
+            <a:pathLst>
+              <a:path w="6172200" h="369332" extrusionOk="0">
+                <a:moveTo>
+                  <a:pt x="0" y="0"/>
+                </a:moveTo>
+                <a:lnTo>
+                  <a:pt x="5791200" y="0"/>
+                </a:lnTo>
+                <a:lnTo>
+                  <a:pt x="6172200" y="369332"/>
+                </a:lnTo>
+                <a:lnTo>
+                  <a:pt x="0" y="369332"/>
+                </a:lnTo>
+                <a:lnTo>
+                  <a:pt x="0" y="0"/>
+                </a:lnTo>
+                <a:close/>
+              </a:path>
+            </a:pathLst>
+          </a:custGeom>
+          <a:solidFill>
+            <a:schemeClr val="accent1"/>
+          </a:solidFill>
+          <a:ln>
+            <a:noFill/>
+          </a:ln>
+        </p:spPr>
+        <p:txBody>
+          <a:bodyPr spcFirstLastPara="1" wrap="square" lIns="91425" tIns="45700" rIns="91425" bIns="45700" anchor="t" anchorCtr="0">
+            <a:spAutoFit/>
+          </a:bodyPr>
+          <a:lstStyle/>
+          <a:p>
+            <a:pPr marL="0" marR="0" lvl="0" indent="0" algn="ctr" rtl="0">
+              <a:spcBef>
+                <a:spcPts val="0"/>
+              </a:spcBef>
+              <a:spcAft>
+                <a:spcPts val="0"/>
+              </a:spcAft>
+              <a:buClr>
+                <a:schemeClr val="lt1"/>
+              </a:buClr>
+              <a:buSzPts val="2400"/>
+              <a:buFont typeface="Gill Sans"/>
+              <a:buNone/>
+            </a:pPr>
+            <a:r>
+              <a:rPr lang="en-US" sz="2400">
+                <a:solidFill>
+                  <a:schemeClr val="lt1"/>
+                </a:solidFill>
+                <a:latin typeface="Gill Sans"/>
+                <a:ea typeface="Gill Sans"/>
+                <a:cs typeface="Gill Sans"/>
+                <a:sym typeface="Gill Sans"/>
+              </a:rPr>
+              <a:t>LEARN . GROW . EXCEL</a:t>
+            </a:r>
+            <a:endParaRPr sz="1800">
+              <a:solidFill>
+                <a:schemeClr val="dk1"/>
+              </a:solidFill>
+              <a:latin typeface="Calibri"/>
+              <a:ea typeface="Calibri"/>
+              <a:cs typeface="Calibri"/>
+              <a:sym typeface="Calibri"/>
+            </a:endParaRPr>
+          </a:p>
+        </p:txBody>
+      </p:sp>
+      <p:sp>
+        <p:nvSpPr>
+          <p:cNvPr id="123" name="Google Shape;123;p3"/>
+          <p:cNvSpPr txBox="1">
+            <a:spLocks noGrp="1"/>
+          </p:cNvSpPr>
+          <p:nvPr>
+            <p:ph type="ctrTitle"/>
+          </p:nvPr>
+        </p:nvSpPr>
+        <p:spPr>
+          <a:xfrm>
+            <a:off x="459967" y="1100168"/>
+            <a:ext cx="9625800" cy="761400"/>
+          </a:xfrm>
+          <a:prstGeom prst="rect">
+            <a:avLst/>
+          </a:prstGeom>
+          <a:noFill/>
+          <a:ln>
+            <a:noFill/>
+          </a:ln>
+        </p:spPr>
+        <p:txBody>
+          <a:bodyPr spcFirstLastPara="1" wrap="square" lIns="91425" tIns="45700" rIns="91425" bIns="45700" anchor="b" anchorCtr="0">
+            <a:normAutofit/>
+          </a:bodyPr>
+          <a:lstStyle/>
+          <a:p>
+            <a:pPr marL="0" lvl="0" indent="0" algn="l" rtl="0">
+              <a:lnSpc>
+                <a:spcPct val="90000"/>
+              </a:lnSpc>
+              <a:spcBef>
+                <a:spcPts val="0"/>
+              </a:spcBef>
+              <a:spcAft>
+                <a:spcPts val="0"/>
+              </a:spcAft>
+              <a:buClr>
+                <a:srgbClr val="181C24"/>
+              </a:buClr>
+              <a:buSzPts val="4000"/>
+              <a:buFont typeface="Times New Roman"/>
+              <a:buNone/>
+            </a:pPr>
+            <a:r>
+              <a:rPr sz="3400" b="1">
+                <a:solidFill>
+                  <a:srgbClr val="0F172A"/>
+                </a:solidFill>
+                <a:latin typeface="Times New Roman"/>
+              </a:rPr>
+              <a:t>EXPERIMENTAL RESULTS &amp; OUTCOMES</a:t>
+            </a:r>
+            <a:endParaRPr sz="3600" b="1" dirty="0">
+              <a:latin typeface="Times New Roman"/>
+              <a:ea typeface="Times New Roman"/>
+              <a:cs typeface="Times New Roman"/>
+              <a:sym typeface="Times New Roman"/>
+            </a:endParaRPr>
+          </a:p>
+        </p:txBody>
+      </p:sp>
+      <p:sp>
+        <p:nvSpPr>
+          <p:cNvPr id="124" name="Google Shape;124;p3"/>
+          <p:cNvSpPr txBox="1">
+            <a:spLocks noGrp="1"/>
+          </p:cNvSpPr>
+          <p:nvPr>
+            <p:ph type="subTitle" idx="1"/>
+          </p:nvPr>
+        </p:nvSpPr>
+        <p:spPr>
+          <a:xfrm>
+            <a:off x="731520" y="1828800"/>
+            <a:ext cx="6217920" cy="4114800"/>
+          </a:xfrm>
+          <a:prstGeom prst="rect">
+            <a:avLst/>
+          </a:prstGeom>
+          <a:noFill/>
+          <a:ln>
+            <a:noFill/>
+          </a:ln>
+        </p:spPr>
+        <p:txBody>
+          <a:bodyPr spcFirstLastPara="1" wrap="square" lIns="91425" tIns="45700" rIns="91425" bIns="45700" anchor="t" anchorCtr="0">
+            <a:normAutofit/>
+          </a:bodyPr>
+          <a:lstStyle/>
+          <a:p>
+            <a:pPr marL="342900" lvl="0" indent="-342900" algn="l">
+              <a:lnSpc>
+                <a:spcPct val="100000"/>
+              </a:lnSpc>
+              <a:spcBef>
+                <a:spcPts val="600"/>
+              </a:spcBef>
+              <a:spcAft>
+                <a:spcPts val="200"/>
+              </a:spcAft>
+              <a:buSzPts val="2600"/>
+              <a:buFont typeface="Noto Sans Symbols"/>
+              <a:buChar char="⮪"/>
+            </a:pPr>
+            <a:r>
+              <a:rPr sz="2000" b="1">
+                <a:solidFill>
+                  <a:srgbClr val="0284C7"/>
+                </a:solidFill>
+                <a:latin typeface="Times New Roman"/>
+              </a:rPr>
+              <a:t>Key Performance Metrics</a:t>
+            </a:r>
+          </a:p>
+          <a:p>
+            <a:pPr>
+              <a:spcBef>
+                <a:spcPts val="200"/>
+              </a:spcBef>
+              <a:spcAft>
+                <a:spcPts val="300"/>
+              </a:spcAft>
+            </a:pPr>
+            <a:r>
+              <a:rPr sz="1500" b="0">
+                <a:solidFill>
+                  <a:srgbClr val="1E293B"/>
+                </a:solidFill>
+                <a:latin typeface="Times New Roman"/>
+              </a:rPr>
+              <a:t>•  Overall Test Set Accuracy: 98.02% across 121,719 test wafer samples.</a:t>
+            </a:r>
+          </a:p>
+          <a:p>
+            <a:pPr>
+              <a:spcBef>
+                <a:spcPts val="200"/>
+              </a:spcBef>
+              <a:spcAft>
+                <a:spcPts val="300"/>
+              </a:spcAft>
+            </a:pPr>
+            <a:r>
+              <a:rPr sz="1500" b="0">
+                <a:solidFill>
+                  <a:srgbClr val="1E293B"/>
+                </a:solidFill>
+                <a:latin typeface="Times New Roman"/>
+              </a:rPr>
+              <a:t>•  Macro Precision: 0.6897  |  Macro Recall: 0.6177</a:t>
+            </a:r>
+          </a:p>
+          <a:p>
+            <a:pPr>
+              <a:spcBef>
+                <a:spcPts val="200"/>
+              </a:spcBef>
+              <a:spcAft>
+                <a:spcPts val="300"/>
+              </a:spcAft>
+            </a:pPr>
+            <a:r>
+              <a:rPr sz="1500" b="0">
+                <a:solidFill>
+                  <a:srgbClr val="1E293B"/>
+                </a:solidFill>
+                <a:latin typeface="Times New Roman"/>
+              </a:rPr>
+              <a:t>•  Inference Latency: 1.53 ms on standard CPU (zero GPU requirement).</a:t>
+            </a:r>
+          </a:p>
+          <a:p>
+            <a:pPr>
+              <a:spcBef>
+                <a:spcPts val="200"/>
+              </a:spcBef>
+              <a:spcAft>
+                <a:spcPts val="300"/>
+              </a:spcAft>
+            </a:pPr>
+            <a:r>
+              <a:rPr sz="1500" b="0">
+                <a:solidFill>
+                  <a:srgbClr val="1E293B"/>
+                </a:solidFill>
+                <a:latin typeface="Times New Roman"/>
+              </a:rPr>
+              <a:t>•  Model Binary Footprint: 5.84 MB (ultra-compact ONNX engine).</a:t>
+            </a:r>
+          </a:p>
+          <a:p>
+            <a:pPr>
+              <a:spcBef>
+                <a:spcPts val="600"/>
+              </a:spcBef>
+              <a:spcAft>
+                <a:spcPts val="200"/>
+              </a:spcAft>
+            </a:pPr>
+            <a:r>
+              <a:rPr sz="2000" b="1">
+                <a:solidFill>
+                  <a:srgbClr val="0284C7"/>
+                </a:solidFill>
+                <a:latin typeface="Times New Roman"/>
+              </a:rPr>
+              <a:t>Per-Class Defect Verification Highlights</a:t>
+            </a:r>
+          </a:p>
+          <a:p>
+            <a:pPr>
+              <a:spcBef>
+                <a:spcPts val="200"/>
+              </a:spcBef>
+              <a:spcAft>
+                <a:spcPts val="300"/>
+              </a:spcAft>
+            </a:pPr>
+            <a:r>
+              <a:rPr sz="1500" b="0">
+                <a:solidFill>
+                  <a:srgbClr val="1E293B"/>
+                </a:solidFill>
+                <a:latin typeface="Times New Roman"/>
+              </a:rPr>
+              <a:t>•  Clean (Nominal): 99.98% Precision, 100% Detection Rate (Near-zero false alarms).</a:t>
+            </a:r>
+          </a:p>
+          <a:p>
+            <a:pPr>
+              <a:spcBef>
+                <a:spcPts val="200"/>
+              </a:spcBef>
+              <a:spcAft>
+                <a:spcPts val="300"/>
+              </a:spcAft>
+            </a:pPr>
+            <a:r>
+              <a:rPr sz="1500" b="0">
+                <a:solidFill>
+                  <a:srgbClr val="1E293B"/>
+                </a:solidFill>
+                <a:latin typeface="Times New Roman"/>
+              </a:rPr>
+              <a:t>•  Scratch: 99.92% Confidence with clear linear scratch isolation.</a:t>
+            </a:r>
+          </a:p>
+          <a:p>
+            <a:pPr>
+              <a:spcBef>
+                <a:spcPts val="200"/>
+              </a:spcBef>
+              <a:spcAft>
+                <a:spcPts val="300"/>
+              </a:spcAft>
+            </a:pPr>
+            <a:r>
+              <a:rPr sz="1500" b="0">
+                <a:solidFill>
+                  <a:srgbClr val="1E293B"/>
+                </a:solidFill>
+                <a:latin typeface="Times New Roman"/>
+              </a:rPr>
+              <a:t>•  Donut: 99.99% Confidence detecting radial thermal ring defects.</a:t>
+            </a:r>
+          </a:p>
+          <a:p>
+            <a:pPr>
+              <a:spcBef>
+                <a:spcPts val="200"/>
+              </a:spcBef>
+              <a:spcAft>
+                <a:spcPts val="300"/>
+              </a:spcAft>
+            </a:pPr>
+            <a:r>
+              <a:rPr sz="1500" b="0">
+                <a:solidFill>
+                  <a:srgbClr val="1E293B"/>
+                </a:solidFill>
+                <a:latin typeface="Times New Roman"/>
+              </a:rPr>
+              <a:t>•  Center Cluster: 98.01% Confidence detecting CMP slurry anomalies.</a:t>
+            </a:r>
+          </a:p>
+          <a:p>
+            <a:pPr>
+              <a:spcBef>
+                <a:spcPts val="200"/>
+              </a:spcBef>
+              <a:spcAft>
+                <a:spcPts val="300"/>
+              </a:spcAft>
+            </a:pPr>
+            <a:r>
+              <a:rPr sz="1500" b="0">
+                <a:solidFill>
+                  <a:srgbClr val="1E293B"/>
+                </a:solidFill>
+                <a:latin typeface="Times New Roman"/>
+              </a:rPr>
+              <a:t>•  Edge-Loc &amp; Loc: &gt;99.2% Confidence identifying localized clusters.</a:t>
+            </a:r>
+          </a:p>
+        </p:txBody>
+      </p:sp>
+      <p:pic>
+        <p:nvPicPr>
+          <p:cNvPr id="125" name="Google Shape;125;p3"/>
+          <p:cNvPicPr preferRelativeResize="0"/>
+          <p:nvPr/>
+        </p:nvPicPr>
+        <p:blipFill rotWithShape="1">
+          <a:blip r:embed="rId3">
+            <a:alphaModFix/>
+          </a:blip>
+          <a:srcRect l="15320" t="28789" r="16466" b="54857"/>
+          <a:stretch/>
+        </p:blipFill>
+        <p:spPr>
+          <a:xfrm>
+            <a:off x="155527" y="217182"/>
+            <a:ext cx="4521325" cy="812948"/>
+          </a:xfrm>
+          <a:prstGeom prst="rect">
+            <a:avLst/>
+          </a:prstGeom>
+          <a:noFill/>
+          <a:ln>
+            <a:noFill/>
+          </a:ln>
+        </p:spPr>
+      </p:pic>
+      <p:pic>
+        <p:nvPicPr>
+          <p:cNvPr id="126" name="Picture 125" descr="confusion_matrix.png"/>
+          <p:cNvPicPr>
+            <a:picLocks noChangeAspect="1"/>
+          </p:cNvPicPr>
+          <p:nvPr/>
+        </p:nvPicPr>
+        <p:blipFill>
+          <a:blip r:embed="rId4"/>
+          <a:stretch>
+            <a:fillRect/>
+          </a:stretch>
+        </p:blipFill>
+        <p:spPr>
+          <a:xfrm>
+            <a:off x="7132320" y="1920240"/>
+            <a:ext cx="4206240" cy="3840480"/>
+          </a:xfrm>
+          <a:prstGeom prst="rect">
+            <a:avLst/>
+          </a:prstGeom>
         </p:spPr>
       </p:pic>
     </p:spTree>

</xml_diff>